<commit_message>
Lecture 5 slides: side-by-side code+output on slides 16 & 18, add specificity walkthrough
- New codeImageSide layout in deckBuilder.js (code left, screenshot right)
- Slide 16 (Combinators): new real browser screenshot demonstrating nav > a,
  h2 + p, and h2 ~ p, laid out side by side with the code
- Slide 18 (Pseudo-Classes): switched from stacked to side-by-side layout
- New slide 26: step-by-step breakdown of how the #nav .item a:hover vs.
  nav ul li a specificity scores from slide 25 are actually calculated
- Re-exported PDF, overriding the previous one

Co-Authored-By: Claude Sonnet 5 <noreply@anthropic.com>
</commit_message>
<xml_diff>
--- a/slides/CSC336-Lecture-05-CSS-Fundamentals.pptx
+++ b/slides/CSC336-Lecture-05-CSS-Fundamentals.pptx
@@ -37,9 +37,10 @@
     <p:sldId id="285" r:id="rId31"/>
     <p:sldId id="286" r:id="rId32"/>
     <p:sldId id="287" r:id="rId33"/>
+    <p:sldId id="288" r:id="rId34"/>
   </p:sldIdLst>
   <p:notesMasterIdLst>
-    <p:notesMasterId r:id="rId34"/>
+    <p:notesMasterId r:id="rId35"/>
   </p:notesMasterIdLst>
   <p:sldSz cx="12192000" cy="6858000"/>
   <p:notesSz cx="6858000" cy="12192000"/>
@@ -2757,6 +2758,94 @@
             <a:fld id="{F7021451-1387-4CA6-816F-3879F97B5CBC}" type="slidenum">
               <a:rPr lang="en-US"/>
               <a:t>32</a:t>
+            </a:fld>
+            <a:endParaRPr lang="en-US"/>
+          </a:p>
+        </p:txBody>
+      </p:sp>
+    </p:spTree>
+    <p:extLst>
+      <p:ext uri="{BB962C8B-B14F-4D97-AF65-F5344CB8AC3E}">
+        <p14:creationId xmlns:p14="http://schemas.microsoft.com/office/powerpoint/2010/main" val="1024086991"/>
+      </p:ext>
+    </p:extLst>
+  </p:cSld>
+  <p:clrMapOvr>
+    <a:masterClrMapping/>
+  </p:clrMapOvr>
+</p:notes>
+</file>
+
+<file path=ppt/notesSlides/notesSlide33.xml><?xml version="1.0" encoding="utf-8"?>
+<p:notes xmlns:a="http://schemas.openxmlformats.org/drawingml/2006/main" xmlns:r="http://schemas.openxmlformats.org/officeDocument/2006/relationships" xmlns:p="http://schemas.openxmlformats.org/presentationml/2006/main">
+  <p:cSld>
+    <p:spTree>
+      <p:nvGrpSpPr>
+        <p:cNvPr id="1" name=""/>
+        <p:cNvGrpSpPr/>
+        <p:nvPr/>
+      </p:nvGrpSpPr>
+      <p:grpSpPr>
+        <a:xfrm>
+          <a:off x="0" y="0"/>
+          <a:ext cx="0" cy="0"/>
+          <a:chOff x="0" y="0"/>
+          <a:chExt cx="0" cy="0"/>
+        </a:xfrm>
+      </p:grpSpPr>
+      <p:sp>
+        <p:nvSpPr>
+          <p:cNvPr id="2" name="Slide Image Placeholder 1"/>
+          <p:cNvSpPr>
+            <a:spLocks noGrp="1" noRot="1" noChangeAspect="1"/>
+          </p:cNvSpPr>
+          <p:nvPr>
+            <p:ph type="sldImg"/>
+          </p:nvPr>
+        </p:nvSpPr>
+        <p:spPr/>
+      </p:sp>
+      <p:sp>
+        <p:nvSpPr>
+          <p:cNvPr id="3" name="Notes Placeholder 2"/>
+          <p:cNvSpPr>
+            <a:spLocks noGrp="1"/>
+          </p:cNvSpPr>
+          <p:nvPr>
+            <p:ph type="body" idx="1"/>
+          </p:nvPr>
+        </p:nvSpPr>
+        <p:spPr/>
+        <p:txBody>
+          <a:bodyPr/>
+          <a:lstStyle/>
+          <a:p>
+            <a:r>
+              <a:rPr lang="en-US" dirty="0"/>
+              <a:t/>
+            </a:r>
+            <a:endParaRPr lang="en-US" dirty="0"/>
+          </a:p>
+        </p:txBody>
+      </p:sp>
+      <p:sp>
+        <p:nvSpPr>
+          <p:cNvPr id="4" name="Slide Number Placeholder 3"/>
+          <p:cNvSpPr>
+            <a:spLocks noGrp="1"/>
+          </p:cNvSpPr>
+          <p:nvPr>
+            <p:ph type="sldNum" sz="quarter" idx="10"/>
+          </p:nvPr>
+        </p:nvSpPr>
+        <p:spPr/>
+        <p:txBody>
+          <a:bodyPr/>
+          <a:lstStyle/>
+          <a:p>
+            <a:fld id="{F7021451-1387-4CA6-816F-3879F97B5CBC}" type="slidenum">
+              <a:rPr lang="en-US"/>
+              <a:t>33</a:t>
             </a:fld>
             <a:endParaRPr lang="en-US"/>
           </a:p>
@@ -6300,12 +6389,12 @@
         </p:nvSpPr>
         <p:spPr>
           <a:xfrm>
-            <a:off x="640080" y="1965960"/>
-            <a:ext cx="10911535" cy="1348740"/>
+            <a:off x="640080" y="2501265"/>
+            <a:ext cx="5272888" cy="3272790"/>
           </a:xfrm>
           <a:prstGeom prst="roundRect">
             <a:avLst>
-              <a:gd name="adj" fmla="val 5424"/>
+              <a:gd name="adj" fmla="val 2235"/>
             </a:avLst>
           </a:prstGeom>
           <a:solidFill>
@@ -6322,8 +6411,8 @@
         </p:nvSpPr>
         <p:spPr>
           <a:xfrm>
-            <a:off x="960120" y="2194560"/>
-            <a:ext cx="10271455" cy="891540"/>
+            <a:off x="960120" y="2729865"/>
+            <a:ext cx="4632808" cy="2815590"/>
           </a:xfrm>
           <a:prstGeom prst="rect">
             <a:avLst/>
@@ -6342,7 +6431,7 @@
               <a:buNone/>
             </a:pPr>
             <a:r>
-              <a:rPr lang="en-US" sz="1400" dirty="0">
+              <a:rPr lang="en-US" sz="1300" dirty="0">
                 <a:solidFill>
                   <a:srgbClr val="C9D3F5"/>
                 </a:solidFill>
@@ -6350,9 +6439,9 @@
                 <a:ea typeface="Courier New" pitchFamily="34" charset="-122"/>
                 <a:cs typeface="Courier New" pitchFamily="34" charset="-120"/>
               </a:rPr>
-              <a:t>nav &gt; a   { color: navy; }    /* only DIRECT children, not grandchildren   */</a:t>
-            </a:r>
-            <a:endParaRPr lang="en-US" sz="1400" dirty="0"/>
+              <a:t>nav &gt; a { color: navy; font-weight: bold; }</a:t>
+            </a:r>
+            <a:endParaRPr lang="en-US" sz="1300" dirty="0"/>
           </a:p>
           <a:p>
             <a:pPr indent="0" marL="0">
@@ -6362,7 +6451,7 @@
               <a:buNone/>
             </a:pPr>
             <a:r>
-              <a:rPr lang="en-US" sz="1400" dirty="0">
+              <a:rPr lang="en-US" sz="1300" dirty="0">
                 <a:solidFill>
                   <a:srgbClr val="C9D3F5"/>
                 </a:solidFill>
@@ -6370,9 +6459,9 @@
                 <a:ea typeface="Courier New" pitchFamily="34" charset="-122"/>
                 <a:cs typeface="Courier New" pitchFamily="34" charset="-120"/>
               </a:rPr>
-              <a:t>h2 + p    { font-weight: bold; } /* the paragraph immediately after an h2  */</a:t>
-            </a:r>
-            <a:endParaRPr lang="en-US" sz="1400" dirty="0"/>
+              <a:t>h2 + p  { font-weight: bold; }</a:t>
+            </a:r>
+            <a:endParaRPr lang="en-US" sz="1300" dirty="0"/>
           </a:p>
           <a:p>
             <a:pPr indent="0" marL="0">
@@ -6382,7 +6471,7 @@
               <a:buNone/>
             </a:pPr>
             <a:r>
-              <a:rPr lang="en-US" sz="1400" dirty="0">
+              <a:rPr lang="en-US" sz="1300" dirty="0">
                 <a:solidFill>
                   <a:srgbClr val="C9D3F5"/>
                 </a:solidFill>
@@ -6390,22 +6479,229 @@
                 <a:ea typeface="Courier New" pitchFamily="34" charset="-122"/>
                 <a:cs typeface="Courier New" pitchFamily="34" charset="-120"/>
               </a:rPr>
-              <a:t>h2 ~ p    { color: gray; }       /* every p that follows an h2, not just one */</a:t>
-            </a:r>
-            <a:endParaRPr lang="en-US" sz="1400" dirty="0"/>
-          </a:p>
-        </p:txBody>
-      </p:sp>
-      <p:sp>
-        <p:nvSpPr>
-          <p:cNvPr id="6" name="Text 4"/>
+              <a:t>h2 ~ p  { color: gray; }</a:t>
+            </a:r>
+            <a:endParaRPr lang="en-US" sz="1300" dirty="0"/>
+          </a:p>
+          <a:p>
+            <a:pPr indent="0" marL="0">
+              <a:lnSpc>
+                <a:spcPct val="125000"/>
+              </a:lnSpc>
+              <a:buNone/>
+            </a:pPr>
+            <a:endParaRPr lang="en-US" sz="1300" dirty="0"/>
+          </a:p>
+          <a:p>
+            <a:pPr indent="0" marL="0">
+              <a:lnSpc>
+                <a:spcPct val="125000"/>
+              </a:lnSpc>
+              <a:buNone/>
+            </a:pPr>
+            <a:r>
+              <a:rPr lang="en-US" sz="1300" dirty="0">
+                <a:solidFill>
+                  <a:srgbClr val="C9D3F5"/>
+                </a:solidFill>
+                <a:latin typeface="Courier New" pitchFamily="34" charset="0"/>
+                <a:ea typeface="Courier New" pitchFamily="34" charset="-122"/>
+                <a:cs typeface="Courier New" pitchFamily="34" charset="-120"/>
+              </a:rPr>
+              <a:t>&lt;nav&gt;</a:t>
+            </a:r>
+            <a:endParaRPr lang="en-US" sz="1300" dirty="0"/>
+          </a:p>
+          <a:p>
+            <a:pPr indent="0" marL="0">
+              <a:lnSpc>
+                <a:spcPct val="125000"/>
+              </a:lnSpc>
+              <a:buNone/>
+            </a:pPr>
+            <a:r>
+              <a:rPr lang="en-US" sz="1300" dirty="0">
+                <a:solidFill>
+                  <a:srgbClr val="C9D3F5"/>
+                </a:solidFill>
+                <a:latin typeface="Courier New" pitchFamily="34" charset="0"/>
+                <a:ea typeface="Courier New" pitchFamily="34" charset="-122"/>
+                <a:cs typeface="Courier New" pitchFamily="34" charset="-120"/>
+              </a:rPr>
+              <a:t>  &lt;a&gt;Direct link&lt;/a&gt;</a:t>
+            </a:r>
+            <a:endParaRPr lang="en-US" sz="1300" dirty="0"/>
+          </a:p>
+          <a:p>
+            <a:pPr indent="0" marL="0">
+              <a:lnSpc>
+                <a:spcPct val="125000"/>
+              </a:lnSpc>
+              <a:buNone/>
+            </a:pPr>
+            <a:r>
+              <a:rPr lang="en-US" sz="1300" dirty="0">
+                <a:solidFill>
+                  <a:srgbClr val="C9D3F5"/>
+                </a:solidFill>
+                <a:latin typeface="Courier New" pitchFamily="34" charset="0"/>
+                <a:ea typeface="Courier New" pitchFamily="34" charset="-122"/>
+                <a:cs typeface="Courier New" pitchFamily="34" charset="-120"/>
+              </a:rPr>
+              <a:t>  &lt;div&gt;&lt;a&gt;Grandchild link&lt;/a&gt;&lt;/div&gt;</a:t>
+            </a:r>
+            <a:endParaRPr lang="en-US" sz="1300" dirty="0"/>
+          </a:p>
+          <a:p>
+            <a:pPr indent="0" marL="0">
+              <a:lnSpc>
+                <a:spcPct val="125000"/>
+              </a:lnSpc>
+              <a:buNone/>
+            </a:pPr>
+            <a:r>
+              <a:rPr lang="en-US" sz="1300" dirty="0">
+                <a:solidFill>
+                  <a:srgbClr val="C9D3F5"/>
+                </a:solidFill>
+                <a:latin typeface="Courier New" pitchFamily="34" charset="0"/>
+                <a:ea typeface="Courier New" pitchFamily="34" charset="-122"/>
+                <a:cs typeface="Courier New" pitchFamily="34" charset="-120"/>
+              </a:rPr>
+              <a:t>&lt;/nav&gt;</a:t>
+            </a:r>
+            <a:endParaRPr lang="en-US" sz="1300" dirty="0"/>
+          </a:p>
+          <a:p>
+            <a:pPr indent="0" marL="0">
+              <a:lnSpc>
+                <a:spcPct val="125000"/>
+              </a:lnSpc>
+              <a:buNone/>
+            </a:pPr>
+            <a:r>
+              <a:rPr lang="en-US" sz="1300" dirty="0">
+                <a:solidFill>
+                  <a:srgbClr val="C9D3F5"/>
+                </a:solidFill>
+                <a:latin typeface="Courier New" pitchFamily="34" charset="0"/>
+                <a:ea typeface="Courier New" pitchFamily="34" charset="-122"/>
+                <a:cs typeface="Courier New" pitchFamily="34" charset="-120"/>
+              </a:rPr>
+              <a:t>&lt;h2&gt;A Heading&lt;/h2&gt;</a:t>
+            </a:r>
+            <a:endParaRPr lang="en-US" sz="1300" dirty="0"/>
+          </a:p>
+          <a:p>
+            <a:pPr indent="0" marL="0">
+              <a:lnSpc>
+                <a:spcPct val="125000"/>
+              </a:lnSpc>
+              <a:buNone/>
+            </a:pPr>
+            <a:r>
+              <a:rPr lang="en-US" sz="1300" dirty="0">
+                <a:solidFill>
+                  <a:srgbClr val="C9D3F5"/>
+                </a:solidFill>
+                <a:latin typeface="Courier New" pitchFamily="34" charset="0"/>
+                <a:ea typeface="Courier New" pitchFamily="34" charset="-122"/>
+                <a:cs typeface="Courier New" pitchFamily="34" charset="-120"/>
+              </a:rPr>
+              <a:t>&lt;p&gt;Immediately after&lt;/p&gt;</a:t>
+            </a:r>
+            <a:endParaRPr lang="en-US" sz="1300" dirty="0"/>
+          </a:p>
+          <a:p>
+            <a:pPr indent="0" marL="0">
+              <a:lnSpc>
+                <a:spcPct val="125000"/>
+              </a:lnSpc>
+              <a:buNone/>
+            </a:pPr>
+            <a:r>
+              <a:rPr lang="en-US" sz="1300" dirty="0">
+                <a:solidFill>
+                  <a:srgbClr val="C9D3F5"/>
+                </a:solidFill>
+                <a:latin typeface="Courier New" pitchFamily="34" charset="0"/>
+                <a:ea typeface="Courier New" pitchFamily="34" charset="-122"/>
+                <a:cs typeface="Courier New" pitchFamily="34" charset="-120"/>
+              </a:rPr>
+              <a:t>&lt;p&gt;Further down&lt;/p&gt;</a:t>
+            </a:r>
+            <a:endParaRPr lang="en-US" sz="1300" dirty="0"/>
+          </a:p>
+        </p:txBody>
+      </p:sp>
+      <p:sp>
+        <p:nvSpPr>
+          <p:cNvPr id="6" name="Shape 4"/>
+          <p:cNvSpPr/>
+          <p:nvPr/>
+        </p:nvSpPr>
+        <p:spPr>
+          <a:xfrm>
+            <a:off x="6169000" y="1947672"/>
+            <a:ext cx="5492344" cy="4379976"/>
+          </a:xfrm>
+          <a:prstGeom prst="roundRect">
+            <a:avLst>
+              <a:gd name="adj" fmla="val 1253"/>
+            </a:avLst>
+          </a:prstGeom>
+          <a:solidFill>
+            <a:srgbClr val="FFFFFF"/>
+          </a:solidFill>
+          <a:ln w="12700">
+            <a:solidFill>
+              <a:srgbClr val="E2E2EE"/>
+            </a:solidFill>
+            <a:prstDash val="solid"/>
+          </a:ln>
+          <a:effectLst>
+            <a:outerShdw sx="100000" sy="100000" kx="0" ky="0" algn="bl" rotWithShape="0" blurRad="101600" dist="38100" dir="5400000">
+              <a:srgbClr val="000000">
+                <a:alpha val="12000"/>
+              </a:srgbClr>
+            </a:outerShdw>
+          </a:effectLst>
+        </p:spPr>
+      </p:sp>
+      <p:pic>
+        <p:nvPicPr>
+          <p:cNvPr id="7" name="Image 0" descr="D:/GitHub/mern-web-book/docs/assets/img/lecture-05/combinators-demo.png">    </p:cNvPr>
+          <p:cNvPicPr>
+            <a:picLocks noChangeAspect="1"/>
+          </p:cNvPicPr>
+          <p:nvPr/>
+        </p:nvPicPr>
+        <p:blipFill>
+          <a:blip r:embed="rId1"/>
+          <a:stretch>
+            <a:fillRect/>
+          </a:stretch>
+        </p:blipFill>
+        <p:spPr>
+          <a:xfrm>
+            <a:off x="6278728" y="3194381"/>
+            <a:ext cx="5272888" cy="1886557"/>
+          </a:xfrm>
+          <a:prstGeom prst="rect">
+            <a:avLst/>
+          </a:prstGeom>
+        </p:spPr>
+      </p:pic>
+      <p:sp>
+        <p:nvSpPr>
+          <p:cNvPr id="8" name="Text 5"/>
           <p:cNvSpPr txBox="1"/>
           <p:nvPr/>
         </p:nvSpPr>
         <p:spPr>
           <a:xfrm>
-            <a:off x="640080" y="3543300"/>
-            <a:ext cx="10911535" cy="2720340"/>
+            <a:off x="640080" y="6446520"/>
+            <a:ext cx="8686800" cy="292608"/>
           </a:xfrm>
           <a:prstGeom prst="rect">
             <a:avLst/>
@@ -6414,60 +6710,21 @@
           <a:ln/>
         </p:spPr>
         <p:txBody>
-          <a:bodyPr wrap="square" lIns="0" tIns="0" rIns="0" bIns="0" rtlCol="0" anchor="t"/>
-          <a:lstStyle/>
-          <a:p>
-            <a:pPr indent="0" marL="0">
-              <a:buNone/>
-            </a:pPr>
-            <a:r>
-              <a:rPr lang="en-US" sz="1300" dirty="0">
-                <a:solidFill>
-                  <a:srgbClr val="26262F"/>
+          <a:bodyPr wrap="square" lIns="0" tIns="0" rIns="0" bIns="0" rtlCol="0" anchor="ctr"/>
+          <a:lstStyle/>
+          <a:p>
+            <a:pPr algn="l" indent="0" marL="0">
+              <a:buNone/>
+            </a:pPr>
+            <a:r>
+              <a:rPr lang="en-US" sz="900" dirty="0">
+                <a:solidFill>
+                  <a:srgbClr val="5D5D72"/>
                 </a:solidFill>
                 <a:latin typeface="Calibri" pitchFamily="34" charset="0"/>
                 <a:ea typeface="Calibri" pitchFamily="34" charset="-122"/>
                 <a:cs typeface="Calibri" pitchFamily="34" charset="-120"/>
               </a:rPr>
-              <a:t>&gt; is stricter than a plain descendant selector (space) — it skips anything nested more than one level deep.</a:t>
-            </a:r>
-            <a:endParaRPr lang="en-US" sz="1300" dirty="0"/>
-          </a:p>
-        </p:txBody>
-      </p:sp>
-      <p:sp>
-        <p:nvSpPr>
-          <p:cNvPr id="7" name="Text 5"/>
-          <p:cNvSpPr txBox="1"/>
-          <p:nvPr/>
-        </p:nvSpPr>
-        <p:spPr>
-          <a:xfrm>
-            <a:off x="640080" y="6446520"/>
-            <a:ext cx="8686800" cy="292608"/>
-          </a:xfrm>
-          <a:prstGeom prst="rect">
-            <a:avLst/>
-          </a:prstGeom>
-          <a:noFill/>
-          <a:ln/>
-        </p:spPr>
-        <p:txBody>
-          <a:bodyPr wrap="square" lIns="0" tIns="0" rIns="0" bIns="0" rtlCol="0" anchor="ctr"/>
-          <a:lstStyle/>
-          <a:p>
-            <a:pPr algn="l" indent="0" marL="0">
-              <a:buNone/>
-            </a:pPr>
-            <a:r>
-              <a:rPr lang="en-US" sz="900" dirty="0">
-                <a:solidFill>
-                  <a:srgbClr val="5D5D72"/>
-                </a:solidFill>
-                <a:latin typeface="Calibri" pitchFamily="34" charset="0"/>
-                <a:ea typeface="Calibri" pitchFamily="34" charset="-122"/>
-                <a:cs typeface="Calibri" pitchFamily="34" charset="-120"/>
-              </a:rPr>
               <a:t>Usman Akram  •  COMSATS University Islamabad</a:t>
             </a:r>
             <a:endParaRPr lang="en-US" sz="900" dirty="0"/>
@@ -6476,7 +6733,7 @@
       </p:sp>
       <p:sp>
         <p:nvSpPr>
-          <p:cNvPr id="8" name="Text 6"/>
+          <p:cNvPr id="9" name="Text 6"/>
           <p:cNvSpPr txBox="1"/>
           <p:nvPr/>
         </p:nvSpPr>
@@ -7716,12 +7973,12 @@
         </p:nvSpPr>
         <p:spPr>
           <a:xfrm>
-            <a:off x="640080" y="2240280"/>
-            <a:ext cx="10911535" cy="2215515"/>
+            <a:off x="640080" y="3133725"/>
+            <a:ext cx="5272888" cy="2282190"/>
           </a:xfrm>
           <a:prstGeom prst="roundRect">
             <a:avLst>
-              <a:gd name="adj" fmla="val 3302"/>
+              <a:gd name="adj" fmla="val 3205"/>
             </a:avLst>
           </a:prstGeom>
           <a:solidFill>
@@ -7738,8 +7995,8 @@
         </p:nvSpPr>
         <p:spPr>
           <a:xfrm>
-            <a:off x="960120" y="2468880"/>
-            <a:ext cx="10271455" cy="1758315"/>
+            <a:off x="960120" y="3362325"/>
+            <a:ext cx="4632808" cy="1824990"/>
           </a:xfrm>
           <a:prstGeom prst="rect">
             <a:avLst/>
@@ -7758,7 +8015,7 @@
               <a:buNone/>
             </a:pPr>
             <a:r>
-              <a:rPr lang="en-US" sz="1250" dirty="0">
+              <a:rPr lang="en-US" sz="1300" dirty="0">
                 <a:solidFill>
                   <a:srgbClr val="C9D3F5"/>
                 </a:solidFill>
@@ -7768,7 +8025,7 @@
               </a:rPr>
               <a:t>li:first-child {</a:t>
             </a:r>
-            <a:endParaRPr lang="en-US" sz="1250" dirty="0"/>
+            <a:endParaRPr lang="en-US" sz="1300" dirty="0"/>
           </a:p>
           <a:p>
             <a:pPr indent="0" marL="0">
@@ -7778,7 +8035,7 @@
               <a:buNone/>
             </a:pPr>
             <a:r>
-              <a:rPr lang="en-US" sz="1250" dirty="0">
+              <a:rPr lang="en-US" sz="1300" dirty="0">
                 <a:solidFill>
                   <a:srgbClr val="C9D3F5"/>
                 </a:solidFill>
@@ -7788,7 +8045,7 @@
               </a:rPr>
               <a:t>  font-weight: bold;</a:t>
             </a:r>
-            <a:endParaRPr lang="en-US" sz="1250" dirty="0"/>
+            <a:endParaRPr lang="en-US" sz="1300" dirty="0"/>
           </a:p>
           <a:p>
             <a:pPr indent="0" marL="0">
@@ -7798,7 +8055,7 @@
               <a:buNone/>
             </a:pPr>
             <a:r>
-              <a:rPr lang="en-US" sz="1250" dirty="0">
+              <a:rPr lang="en-US" sz="1300" dirty="0">
                 <a:solidFill>
                   <a:srgbClr val="C9D3F5"/>
                 </a:solidFill>
@@ -7808,7 +8065,7 @@
               </a:rPr>
               <a:t>}</a:t>
             </a:r>
-            <a:endParaRPr lang="en-US" sz="1250" dirty="0"/>
+            <a:endParaRPr lang="en-US" sz="1300" dirty="0"/>
           </a:p>
           <a:p>
             <a:pPr indent="0" marL="0">
@@ -7817,7 +8074,7 @@
               </a:lnSpc>
               <a:buNone/>
             </a:pPr>
-            <a:endParaRPr lang="en-US" sz="1250" dirty="0"/>
+            <a:endParaRPr lang="en-US" sz="1300" dirty="0"/>
           </a:p>
           <a:p>
             <a:pPr indent="0" marL="0">
@@ -7827,7 +8084,7 @@
               <a:buNone/>
             </a:pPr>
             <a:r>
-              <a:rPr lang="en-US" sz="1250" dirty="0">
+              <a:rPr lang="en-US" sz="1300" dirty="0">
                 <a:solidFill>
                   <a:srgbClr val="C9D3F5"/>
                 </a:solidFill>
@@ -7837,7 +8094,7 @@
               </a:rPr>
               <a:t>button:disabled {</a:t>
             </a:r>
-            <a:endParaRPr lang="en-US" sz="1250" dirty="0"/>
+            <a:endParaRPr lang="en-US" sz="1300" dirty="0"/>
           </a:p>
           <a:p>
             <a:pPr indent="0" marL="0">
@@ -7847,7 +8104,7 @@
               <a:buNone/>
             </a:pPr>
             <a:r>
-              <a:rPr lang="en-US" sz="1250" dirty="0">
+              <a:rPr lang="en-US" sz="1300" dirty="0">
                 <a:solidFill>
                   <a:srgbClr val="C9D3F5"/>
                 </a:solidFill>
@@ -7857,7 +8114,7 @@
               </a:rPr>
               <a:t>  opacity: 0.5;</a:t>
             </a:r>
-            <a:endParaRPr lang="en-US" sz="1250" dirty="0"/>
+            <a:endParaRPr lang="en-US" sz="1300" dirty="0"/>
           </a:p>
           <a:p>
             <a:pPr indent="0" marL="0">
@@ -7867,7 +8124,7 @@
               <a:buNone/>
             </a:pPr>
             <a:r>
-              <a:rPr lang="en-US" sz="1250" dirty="0">
+              <a:rPr lang="en-US" sz="1300" dirty="0">
                 <a:solidFill>
                   <a:srgbClr val="C9D3F5"/>
                 </a:solidFill>
@@ -7877,7 +8134,7 @@
               </a:rPr>
               <a:t>}</a:t>
             </a:r>
-            <a:endParaRPr lang="en-US" sz="1250" dirty="0"/>
+            <a:endParaRPr lang="en-US" sz="1300" dirty="0"/>
           </a:p>
         </p:txBody>
       </p:sp>
@@ -7889,12 +8146,12 @@
         </p:nvSpPr>
         <p:spPr>
           <a:xfrm>
-            <a:off x="530352" y="4620387"/>
-            <a:ext cx="11130991" cy="1707261"/>
+            <a:off x="6169000" y="2221992"/>
+            <a:ext cx="5492344" cy="4105656"/>
           </a:xfrm>
           <a:prstGeom prst="roundRect">
             <a:avLst>
-              <a:gd name="adj" fmla="val 3214"/>
+              <a:gd name="adj" fmla="val 1336"/>
             </a:avLst>
           </a:prstGeom>
           <a:solidFill>
@@ -7931,8 +8188,8 @@
         </p:blipFill>
         <p:spPr>
           <a:xfrm>
-            <a:off x="5100715" y="4730115"/>
-            <a:ext cx="1990265" cy="1487805"/>
+            <a:off x="6591071" y="2537460"/>
+            <a:ext cx="4648200" cy="3474720"/>
           </a:xfrm>
           <a:prstGeom prst="rect">
             <a:avLst/>
@@ -8573,7 +8830,7 @@
         </p:nvSpPr>
         <p:spPr>
           <a:xfrm>
-            <a:off x="685800" y="2679192"/>
+            <a:off x="685800" y="2689860"/>
             <a:ext cx="457200" cy="457200"/>
           </a:xfrm>
           <a:prstGeom prst="ellipse">
@@ -8593,7 +8850,7 @@
         </p:nvSpPr>
         <p:spPr>
           <a:xfrm>
-            <a:off x="685800" y="2679192"/>
+            <a:off x="685800" y="2689860"/>
             <a:ext cx="457200" cy="457200"/>
           </a:xfrm>
           <a:prstGeom prst="rect">
@@ -8632,7 +8889,7 @@
         </p:nvSpPr>
         <p:spPr>
           <a:xfrm>
-            <a:off x="1371600" y="2606040"/>
+            <a:off x="1371600" y="2616708"/>
             <a:ext cx="10180015" cy="640080"/>
           </a:xfrm>
           <a:prstGeom prst="rect">
@@ -8671,7 +8928,7 @@
         </p:nvSpPr>
         <p:spPr>
           <a:xfrm>
-            <a:off x="685800" y="3392424"/>
+            <a:off x="685800" y="3413760"/>
             <a:ext cx="457200" cy="457200"/>
           </a:xfrm>
           <a:prstGeom prst="ellipse">
@@ -8691,7 +8948,7 @@
         </p:nvSpPr>
         <p:spPr>
           <a:xfrm>
-            <a:off x="685800" y="3392424"/>
+            <a:off x="685800" y="3413760"/>
             <a:ext cx="457200" cy="457200"/>
           </a:xfrm>
           <a:prstGeom prst="rect">
@@ -8730,7 +8987,7 @@
         </p:nvSpPr>
         <p:spPr>
           <a:xfrm>
-            <a:off x="1371600" y="3319272"/>
+            <a:off x="1371600" y="3340608"/>
             <a:ext cx="10180015" cy="640080"/>
           </a:xfrm>
           <a:prstGeom prst="rect">
@@ -8769,7 +9026,7 @@
         </p:nvSpPr>
         <p:spPr>
           <a:xfrm>
-            <a:off x="685800" y="4105656"/>
+            <a:off x="685800" y="4137660"/>
             <a:ext cx="457200" cy="457200"/>
           </a:xfrm>
           <a:prstGeom prst="ellipse">
@@ -8789,7 +9046,7 @@
         </p:nvSpPr>
         <p:spPr>
           <a:xfrm>
-            <a:off x="685800" y="4105656"/>
+            <a:off x="685800" y="4137660"/>
             <a:ext cx="457200" cy="457200"/>
           </a:xfrm>
           <a:prstGeom prst="rect">
@@ -8828,7 +9085,7 @@
         </p:nvSpPr>
         <p:spPr>
           <a:xfrm>
-            <a:off x="1371600" y="4032504"/>
+            <a:off x="1371600" y="4064508"/>
             <a:ext cx="10180015" cy="640080"/>
           </a:xfrm>
           <a:prstGeom prst="rect">
@@ -8867,7 +9124,7 @@
         </p:nvSpPr>
         <p:spPr>
           <a:xfrm>
-            <a:off x="685800" y="4818888"/>
+            <a:off x="685800" y="4861560"/>
             <a:ext cx="457200" cy="457200"/>
           </a:xfrm>
           <a:prstGeom prst="ellipse">
@@ -8887,7 +9144,7 @@
         </p:nvSpPr>
         <p:spPr>
           <a:xfrm>
-            <a:off x="685800" y="4818888"/>
+            <a:off x="685800" y="4861560"/>
             <a:ext cx="457200" cy="457200"/>
           </a:xfrm>
           <a:prstGeom prst="rect">
@@ -8926,7 +9183,7 @@
         </p:nvSpPr>
         <p:spPr>
           <a:xfrm>
-            <a:off x="1371600" y="4745736"/>
+            <a:off x="1371600" y="4788408"/>
             <a:ext cx="10180015" cy="640080"/>
           </a:xfrm>
           <a:prstGeom prst="rect">
@@ -8965,7 +9222,7 @@
         </p:nvSpPr>
         <p:spPr>
           <a:xfrm>
-            <a:off x="685800" y="5532120"/>
+            <a:off x="685800" y="5585460"/>
             <a:ext cx="457200" cy="457200"/>
           </a:xfrm>
           <a:prstGeom prst="ellipse">
@@ -8985,7 +9242,7 @@
         </p:nvSpPr>
         <p:spPr>
           <a:xfrm>
-            <a:off x="685800" y="5532120"/>
+            <a:off x="685800" y="5585460"/>
             <a:ext cx="457200" cy="457200"/>
           </a:xfrm>
           <a:prstGeom prst="rect">
@@ -9024,7 +9281,7 @@
         </p:nvSpPr>
         <p:spPr>
           <a:xfrm>
-            <a:off x="1371600" y="5458968"/>
+            <a:off x="1371600" y="5512308"/>
             <a:ext cx="10180015" cy="640080"/>
           </a:xfrm>
           <a:prstGeom prst="rect">
@@ -13202,7 +13459,7 @@
                 <a:ea typeface="Calibri" pitchFamily="34" charset="-122"/>
                 <a:cs typeface="Calibri" pitchFamily="34" charset="-120"/>
               </a:rPr>
-              <a:t>INHERITANCE</a:t>
+              <a:t>THE REAL FORMULA</a:t>
             </a:r>
             <a:endParaRPr lang="en-US" sz="1300" dirty="0"/>
           </a:p>
@@ -13241,44 +13498,1083 @@
                 <a:ea typeface="Cambria" pitchFamily="34" charset="-122"/>
                 <a:cs typeface="Cambria" pitchFamily="34" charset="-120"/>
               </a:rPr>
-              <a:t>An Example Where Inheritance Does NOT Happen</a:t>
+              <a:t>How Specificity Is Calculated</a:t>
             </a:r>
             <a:endParaRPr lang="en-US" sz="3400" dirty="0"/>
           </a:p>
         </p:txBody>
       </p:sp>
-      <p:sp>
-        <p:nvSpPr>
-          <p:cNvPr id="4" name="Shape 2"/>
-          <p:cNvSpPr/>
-          <p:nvPr/>
-        </p:nvSpPr>
-        <p:spPr>
-          <a:xfrm>
-            <a:off x="640080" y="1965960"/>
-            <a:ext cx="10911535" cy="3215640"/>
-          </a:xfrm>
-          <a:prstGeom prst="roundRect">
-            <a:avLst>
-              <a:gd name="adj" fmla="val 2275"/>
-            </a:avLst>
-          </a:prstGeom>
-          <a:solidFill>
-            <a:srgbClr val="1E1E4C"/>
-          </a:solidFill>
-          <a:ln/>
-        </p:spPr>
-      </p:sp>
-      <p:sp>
-        <p:nvSpPr>
-          <p:cNvPr id="5" name="Text 3"/>
+      <p:graphicFrame>
+        <p:nvGraphicFramePr>
+          <p:cNvPr id="27" name="Table 0"/>
+          <p:cNvGraphicFramePr>
+            <a:graphicFrameLocks noGrp="1"/>
+          </p:cNvGraphicFramePr>
+          <p:nvPr>
+            <p:extLst>
+              <p:ext uri="{D42A27DB-BD31-4B8C-83A1-F6EECF244321}">
+                <p14:modId xmlns:p14="http://schemas.microsoft.com/office/powerpoint/2010/main" val="1579011935"/>
+              </p:ext>
+            </p:extLst>
+          </p:nvPr>
+        </p:nvGraphicFramePr>
+        <p:xfrm>
+          <a:off x="640080" y="1965960"/>
+          <a:ext cx="10911535" cy="914400"/>
+        </p:xfrm>
+        <a:graphic>
+          <a:graphicData uri="http://schemas.openxmlformats.org/drawingml/2006/table">
+            <a:tbl>
+              <a:tblPr/>
+              <a:tblGrid>
+                <a:gridCol w="3291840"/>
+                <a:gridCol w="3108960"/>
+                <a:gridCol w="4572000"/>
+              </a:tblGrid>
+              <a:tr h="566928">
+                <a:tc>
+                  <a:txBody>
+                    <a:bodyPr/>
+                    <a:lstStyle/>
+                    <a:p>
+                      <a:pPr algn="ctr" indent="0" marL="0">
+                        <a:buNone/>
+                      </a:pPr>
+                      <a:r>
+                        <a:rPr lang="en-US" sz="1200" b="1" dirty="0">
+                          <a:solidFill>
+                            <a:srgbClr val="FFFFFF"/>
+                          </a:solidFill>
+                          <a:latin typeface="Calibri" pitchFamily="34" charset="0"/>
+                          <a:ea typeface="Calibri" pitchFamily="34" charset="-122"/>
+                          <a:cs typeface="Calibri" pitchFamily="34" charset="-120"/>
+                        </a:rPr>
+                        <a:t>Part of the Selector</a:t>
+                      </a:r>
+                      <a:endParaRPr lang="en-US" sz="1200" dirty="0">
+                        <a:latin typeface="Calibri" charset="0"/>
+                        <a:ea typeface="Calibri" charset="0"/>
+                        <a:cs typeface="Calibri" charset="0"/>
+                      </a:endParaRPr>
+                    </a:p>
+                  </a:txBody>
+                  <a:tcPr marL="91440" marR="91440" marT="45720" marB="45720" anchor="ctr">
+                    <a:lnL w="12700" cap="flat" cmpd="sng" algn="ctr">
+                      <a:solidFill>
+                        <a:srgbClr val="D8D8E6"/>
+                      </a:solidFill>
+                      <a:prstDash val="solid"/>
+                      <a:round/>
+                      <a:headEnd type="none" w="med" len="med"/>
+                      <a:tailEnd type="none" w="med" len="med"/>
+                    </a:lnL>
+                    <a:lnR w="12700" cap="flat" cmpd="sng" algn="ctr">
+                      <a:solidFill>
+                        <a:srgbClr val="D8D8E6"/>
+                      </a:solidFill>
+                      <a:prstDash val="solid"/>
+                      <a:round/>
+                      <a:headEnd type="none" w="med" len="med"/>
+                      <a:tailEnd type="none" w="med" len="med"/>
+                    </a:lnR>
+                    <a:lnT w="12700" cap="flat" cmpd="sng" algn="ctr">
+                      <a:solidFill>
+                        <a:srgbClr val="D8D8E6"/>
+                      </a:solidFill>
+                      <a:prstDash val="solid"/>
+                      <a:round/>
+                      <a:headEnd type="none" w="med" len="med"/>
+                      <a:tailEnd type="none" w="med" len="med"/>
+                    </a:lnT>
+                    <a:lnB w="12700" cap="flat" cmpd="sng" algn="ctr">
+                      <a:solidFill>
+                        <a:srgbClr val="D8D8E6"/>
+                      </a:solidFill>
+                      <a:prstDash val="solid"/>
+                      <a:round/>
+                      <a:headEnd type="none" w="med" len="med"/>
+                      <a:tailEnd type="none" w="med" len="med"/>
+                    </a:lnB>
+                    <a:solidFill>
+                      <a:srgbClr val="2B2B7A"/>
+                    </a:solidFill>
+                  </a:tcPr>
+                </a:tc>
+                <a:tc>
+                  <a:txBody>
+                    <a:bodyPr/>
+                    <a:lstStyle/>
+                    <a:p>
+                      <a:pPr algn="ctr" indent="0" marL="0">
+                        <a:buNone/>
+                      </a:pPr>
+                      <a:r>
+                        <a:rPr lang="en-US" sz="1200" b="1" dirty="0">
+                          <a:solidFill>
+                            <a:srgbClr val="FFFFFF"/>
+                          </a:solidFill>
+                          <a:latin typeface="Calibri" pitchFamily="34" charset="0"/>
+                          <a:ea typeface="Calibri" pitchFamily="34" charset="-122"/>
+                          <a:cs typeface="Calibri" pitchFamily="34" charset="-120"/>
+                        </a:rPr>
+                        <a:t>Category</a:t>
+                      </a:r>
+                      <a:endParaRPr lang="en-US" sz="1200" dirty="0">
+                        <a:latin typeface="Calibri" charset="0"/>
+                        <a:ea typeface="Calibri" charset="0"/>
+                        <a:cs typeface="Calibri" charset="0"/>
+                      </a:endParaRPr>
+                    </a:p>
+                  </a:txBody>
+                  <a:tcPr marL="91440" marR="91440" marT="45720" marB="45720" anchor="ctr">
+                    <a:lnL w="12700" cap="flat" cmpd="sng" algn="ctr">
+                      <a:solidFill>
+                        <a:srgbClr val="D8D8E6"/>
+                      </a:solidFill>
+                      <a:prstDash val="solid"/>
+                      <a:round/>
+                      <a:headEnd type="none" w="med" len="med"/>
+                      <a:tailEnd type="none" w="med" len="med"/>
+                    </a:lnL>
+                    <a:lnR w="12700" cap="flat" cmpd="sng" algn="ctr">
+                      <a:solidFill>
+                        <a:srgbClr val="D8D8E6"/>
+                      </a:solidFill>
+                      <a:prstDash val="solid"/>
+                      <a:round/>
+                      <a:headEnd type="none" w="med" len="med"/>
+                      <a:tailEnd type="none" w="med" len="med"/>
+                    </a:lnR>
+                    <a:lnT w="12700" cap="flat" cmpd="sng" algn="ctr">
+                      <a:solidFill>
+                        <a:srgbClr val="D8D8E6"/>
+                      </a:solidFill>
+                      <a:prstDash val="solid"/>
+                      <a:round/>
+                      <a:headEnd type="none" w="med" len="med"/>
+                      <a:tailEnd type="none" w="med" len="med"/>
+                    </a:lnT>
+                    <a:lnB w="12700" cap="flat" cmpd="sng" algn="ctr">
+                      <a:solidFill>
+                        <a:srgbClr val="D8D8E6"/>
+                      </a:solidFill>
+                      <a:prstDash val="solid"/>
+                      <a:round/>
+                      <a:headEnd type="none" w="med" len="med"/>
+                      <a:tailEnd type="none" w="med" len="med"/>
+                    </a:lnB>
+                    <a:solidFill>
+                      <a:srgbClr val="2B2B7A"/>
+                    </a:solidFill>
+                  </a:tcPr>
+                </a:tc>
+                <a:tc>
+                  <a:txBody>
+                    <a:bodyPr/>
+                    <a:lstStyle/>
+                    <a:p>
+                      <a:pPr algn="ctr" indent="0" marL="0">
+                        <a:buNone/>
+                      </a:pPr>
+                      <a:r>
+                        <a:rPr lang="en-US" sz="1200" b="1" dirty="0">
+                          <a:solidFill>
+                            <a:srgbClr val="FFFFFF"/>
+                          </a:solidFill>
+                          <a:latin typeface="Calibri" pitchFamily="34" charset="0"/>
+                          <a:ea typeface="Calibri" pitchFamily="34" charset="-122"/>
+                          <a:cs typeface="Calibri" pitchFamily="34" charset="-120"/>
+                        </a:rPr>
+                        <a:t>Column It Counts Toward</a:t>
+                      </a:r>
+                      <a:endParaRPr lang="en-US" sz="1200" dirty="0">
+                        <a:latin typeface="Calibri" charset="0"/>
+                        <a:ea typeface="Calibri" charset="0"/>
+                        <a:cs typeface="Calibri" charset="0"/>
+                      </a:endParaRPr>
+                    </a:p>
+                  </a:txBody>
+                  <a:tcPr marL="91440" marR="91440" marT="45720" marB="45720" anchor="ctr">
+                    <a:lnL w="12700" cap="flat" cmpd="sng" algn="ctr">
+                      <a:solidFill>
+                        <a:srgbClr val="D8D8E6"/>
+                      </a:solidFill>
+                      <a:prstDash val="solid"/>
+                      <a:round/>
+                      <a:headEnd type="none" w="med" len="med"/>
+                      <a:tailEnd type="none" w="med" len="med"/>
+                    </a:lnL>
+                    <a:lnR w="12700" cap="flat" cmpd="sng" algn="ctr">
+                      <a:solidFill>
+                        <a:srgbClr val="D8D8E6"/>
+                      </a:solidFill>
+                      <a:prstDash val="solid"/>
+                      <a:round/>
+                      <a:headEnd type="none" w="med" len="med"/>
+                      <a:tailEnd type="none" w="med" len="med"/>
+                    </a:lnR>
+                    <a:lnT w="12700" cap="flat" cmpd="sng" algn="ctr">
+                      <a:solidFill>
+                        <a:srgbClr val="D8D8E6"/>
+                      </a:solidFill>
+                      <a:prstDash val="solid"/>
+                      <a:round/>
+                      <a:headEnd type="none" w="med" len="med"/>
+                      <a:tailEnd type="none" w="med" len="med"/>
+                    </a:lnT>
+                    <a:lnB w="12700" cap="flat" cmpd="sng" algn="ctr">
+                      <a:solidFill>
+                        <a:srgbClr val="D8D8E6"/>
+                      </a:solidFill>
+                      <a:prstDash val="solid"/>
+                      <a:round/>
+                      <a:headEnd type="none" w="med" len="med"/>
+                      <a:tailEnd type="none" w="med" len="med"/>
+                    </a:lnB>
+                    <a:solidFill>
+                      <a:srgbClr val="2B2B7A"/>
+                    </a:solidFill>
+                  </a:tcPr>
+                </a:tc>
+              </a:tr>
+              <a:tr h="566928">
+                <a:tc>
+                  <a:txBody>
+                    <a:bodyPr/>
+                    <a:lstStyle/>
+                    <a:p>
+                      <a:pPr algn="l" indent="0" marL="0">
+                        <a:buNone/>
+                      </a:pPr>
+                      <a:r>
+                        <a:rPr lang="en-US" sz="1200" b="1" dirty="0">
+                          <a:solidFill>
+                            <a:srgbClr val="26262F"/>
+                          </a:solidFill>
+                          <a:latin typeface="Calibri" pitchFamily="34" charset="0"/>
+                          <a:ea typeface="Calibri" pitchFamily="34" charset="-122"/>
+                          <a:cs typeface="Calibri" pitchFamily="34" charset="-120"/>
+                        </a:rPr>
+                        <a:t>#nav</a:t>
+                      </a:r>
+                      <a:endParaRPr lang="en-US" sz="1200" dirty="0">
+                        <a:latin typeface="Calibri" charset="0"/>
+                        <a:ea typeface="Calibri" charset="0"/>
+                        <a:cs typeface="Calibri" charset="0"/>
+                      </a:endParaRPr>
+                    </a:p>
+                  </a:txBody>
+                  <a:tcPr marL="91440" marR="91440" marT="45720" marB="45720" anchor="ctr">
+                    <a:lnL w="12700" cap="flat" cmpd="sng" algn="ctr">
+                      <a:solidFill>
+                        <a:srgbClr val="D8D8E6"/>
+                      </a:solidFill>
+                      <a:prstDash val="solid"/>
+                      <a:round/>
+                      <a:headEnd type="none" w="med" len="med"/>
+                      <a:tailEnd type="none" w="med" len="med"/>
+                    </a:lnL>
+                    <a:lnR w="12700" cap="flat" cmpd="sng" algn="ctr">
+                      <a:solidFill>
+                        <a:srgbClr val="D8D8E6"/>
+                      </a:solidFill>
+                      <a:prstDash val="solid"/>
+                      <a:round/>
+                      <a:headEnd type="none" w="med" len="med"/>
+                      <a:tailEnd type="none" w="med" len="med"/>
+                    </a:lnR>
+                    <a:lnT w="12700" cap="flat" cmpd="sng" algn="ctr">
+                      <a:solidFill>
+                        <a:srgbClr val="D8D8E6"/>
+                      </a:solidFill>
+                      <a:prstDash val="solid"/>
+                      <a:round/>
+                      <a:headEnd type="none" w="med" len="med"/>
+                      <a:tailEnd type="none" w="med" len="med"/>
+                    </a:lnT>
+                    <a:lnB w="12700" cap="flat" cmpd="sng" algn="ctr">
+                      <a:solidFill>
+                        <a:srgbClr val="D8D8E6"/>
+                      </a:solidFill>
+                      <a:prstDash val="solid"/>
+                      <a:round/>
+                      <a:headEnd type="none" w="med" len="med"/>
+                      <a:tailEnd type="none" w="med" len="med"/>
+                    </a:lnB>
+                    <a:solidFill>
+                      <a:srgbClr val="FFFFFF"/>
+                    </a:solidFill>
+                  </a:tcPr>
+                </a:tc>
+                <a:tc>
+                  <a:txBody>
+                    <a:bodyPr/>
+                    <a:lstStyle/>
+                    <a:p>
+                      <a:pPr algn="ctr" indent="0" marL="0">
+                        <a:buNone/>
+                      </a:pPr>
+                      <a:r>
+                        <a:rPr lang="en-US" sz="1200" dirty="0">
+                          <a:solidFill>
+                            <a:srgbClr val="26262F"/>
+                          </a:solidFill>
+                          <a:latin typeface="Calibri" pitchFamily="34" charset="0"/>
+                          <a:ea typeface="Calibri" pitchFamily="34" charset="-122"/>
+                          <a:cs typeface="Calibri" pitchFamily="34" charset="-120"/>
+                        </a:rPr>
+                        <a:t>ID selector</a:t>
+                      </a:r>
+                      <a:endParaRPr lang="en-US" sz="1200" dirty="0">
+                        <a:latin typeface="Calibri" charset="0"/>
+                        <a:ea typeface="Calibri" charset="0"/>
+                        <a:cs typeface="Calibri" charset="0"/>
+                      </a:endParaRPr>
+                    </a:p>
+                  </a:txBody>
+                  <a:tcPr marL="91440" marR="91440" marT="45720" marB="45720" anchor="ctr">
+                    <a:lnL w="12700" cap="flat" cmpd="sng" algn="ctr">
+                      <a:solidFill>
+                        <a:srgbClr val="D8D8E6"/>
+                      </a:solidFill>
+                      <a:prstDash val="solid"/>
+                      <a:round/>
+                      <a:headEnd type="none" w="med" len="med"/>
+                      <a:tailEnd type="none" w="med" len="med"/>
+                    </a:lnL>
+                    <a:lnR w="12700" cap="flat" cmpd="sng" algn="ctr">
+                      <a:solidFill>
+                        <a:srgbClr val="D8D8E6"/>
+                      </a:solidFill>
+                      <a:prstDash val="solid"/>
+                      <a:round/>
+                      <a:headEnd type="none" w="med" len="med"/>
+                      <a:tailEnd type="none" w="med" len="med"/>
+                    </a:lnR>
+                    <a:lnT w="12700" cap="flat" cmpd="sng" algn="ctr">
+                      <a:solidFill>
+                        <a:srgbClr val="D8D8E6"/>
+                      </a:solidFill>
+                      <a:prstDash val="solid"/>
+                      <a:round/>
+                      <a:headEnd type="none" w="med" len="med"/>
+                      <a:tailEnd type="none" w="med" len="med"/>
+                    </a:lnT>
+                    <a:lnB w="12700" cap="flat" cmpd="sng" algn="ctr">
+                      <a:solidFill>
+                        <a:srgbClr val="D8D8E6"/>
+                      </a:solidFill>
+                      <a:prstDash val="solid"/>
+                      <a:round/>
+                      <a:headEnd type="none" w="med" len="med"/>
+                      <a:tailEnd type="none" w="med" len="med"/>
+                    </a:lnB>
+                    <a:solidFill>
+                      <a:srgbClr val="FFFFFF"/>
+                    </a:solidFill>
+                  </a:tcPr>
+                </a:tc>
+                <a:tc>
+                  <a:txBody>
+                    <a:bodyPr/>
+                    <a:lstStyle/>
+                    <a:p>
+                      <a:pPr algn="ctr" indent="0" marL="0">
+                        <a:buNone/>
+                      </a:pPr>
+                      <a:r>
+                        <a:rPr lang="en-US" sz="1200" dirty="0">
+                          <a:solidFill>
+                            <a:srgbClr val="26262F"/>
+                          </a:solidFill>
+                          <a:latin typeface="Calibri" pitchFamily="34" charset="0"/>
+                          <a:ea typeface="Calibri" pitchFamily="34" charset="-122"/>
+                          <a:cs typeface="Calibri" pitchFamily="34" charset="-120"/>
+                        </a:rPr>
+                        <a:t>IDs: +1</a:t>
+                      </a:r>
+                      <a:endParaRPr lang="en-US" sz="1200" dirty="0">
+                        <a:latin typeface="Calibri" charset="0"/>
+                        <a:ea typeface="Calibri" charset="0"/>
+                        <a:cs typeface="Calibri" charset="0"/>
+                      </a:endParaRPr>
+                    </a:p>
+                  </a:txBody>
+                  <a:tcPr marL="91440" marR="91440" marT="45720" marB="45720" anchor="ctr">
+                    <a:lnL w="12700" cap="flat" cmpd="sng" algn="ctr">
+                      <a:solidFill>
+                        <a:srgbClr val="D8D8E6"/>
+                      </a:solidFill>
+                      <a:prstDash val="solid"/>
+                      <a:round/>
+                      <a:headEnd type="none" w="med" len="med"/>
+                      <a:tailEnd type="none" w="med" len="med"/>
+                    </a:lnL>
+                    <a:lnR w="12700" cap="flat" cmpd="sng" algn="ctr">
+                      <a:solidFill>
+                        <a:srgbClr val="D8D8E6"/>
+                      </a:solidFill>
+                      <a:prstDash val="solid"/>
+                      <a:round/>
+                      <a:headEnd type="none" w="med" len="med"/>
+                      <a:tailEnd type="none" w="med" len="med"/>
+                    </a:lnR>
+                    <a:lnT w="12700" cap="flat" cmpd="sng" algn="ctr">
+                      <a:solidFill>
+                        <a:srgbClr val="D8D8E6"/>
+                      </a:solidFill>
+                      <a:prstDash val="solid"/>
+                      <a:round/>
+                      <a:headEnd type="none" w="med" len="med"/>
+                      <a:tailEnd type="none" w="med" len="med"/>
+                    </a:lnT>
+                    <a:lnB w="12700" cap="flat" cmpd="sng" algn="ctr">
+                      <a:solidFill>
+                        <a:srgbClr val="D8D8E6"/>
+                      </a:solidFill>
+                      <a:prstDash val="solid"/>
+                      <a:round/>
+                      <a:headEnd type="none" w="med" len="med"/>
+                      <a:tailEnd type="none" w="med" len="med"/>
+                    </a:lnB>
+                    <a:solidFill>
+                      <a:srgbClr val="FFFFFF"/>
+                    </a:solidFill>
+                  </a:tcPr>
+                </a:tc>
+              </a:tr>
+              <a:tr h="566928">
+                <a:tc>
+                  <a:txBody>
+                    <a:bodyPr/>
+                    <a:lstStyle/>
+                    <a:p>
+                      <a:pPr algn="l" indent="0" marL="0">
+                        <a:buNone/>
+                      </a:pPr>
+                      <a:r>
+                        <a:rPr lang="en-US" sz="1200" b="1" dirty="0">
+                          <a:solidFill>
+                            <a:srgbClr val="26262F"/>
+                          </a:solidFill>
+                          <a:latin typeface="Calibri" pitchFamily="34" charset="0"/>
+                          <a:ea typeface="Calibri" pitchFamily="34" charset="-122"/>
+                          <a:cs typeface="Calibri" pitchFamily="34" charset="-120"/>
+                        </a:rPr>
+                        <a:t>.item</a:t>
+                      </a:r>
+                      <a:endParaRPr lang="en-US" sz="1200" dirty="0">
+                        <a:latin typeface="Calibri" charset="0"/>
+                        <a:ea typeface="Calibri" charset="0"/>
+                        <a:cs typeface="Calibri" charset="0"/>
+                      </a:endParaRPr>
+                    </a:p>
+                  </a:txBody>
+                  <a:tcPr marL="91440" marR="91440" marT="45720" marB="45720" anchor="ctr">
+                    <a:lnL w="12700" cap="flat" cmpd="sng" algn="ctr">
+                      <a:solidFill>
+                        <a:srgbClr val="D8D8E6"/>
+                      </a:solidFill>
+                      <a:prstDash val="solid"/>
+                      <a:round/>
+                      <a:headEnd type="none" w="med" len="med"/>
+                      <a:tailEnd type="none" w="med" len="med"/>
+                    </a:lnL>
+                    <a:lnR w="12700" cap="flat" cmpd="sng" algn="ctr">
+                      <a:solidFill>
+                        <a:srgbClr val="D8D8E6"/>
+                      </a:solidFill>
+                      <a:prstDash val="solid"/>
+                      <a:round/>
+                      <a:headEnd type="none" w="med" len="med"/>
+                      <a:tailEnd type="none" w="med" len="med"/>
+                    </a:lnR>
+                    <a:lnT w="12700" cap="flat" cmpd="sng" algn="ctr">
+                      <a:solidFill>
+                        <a:srgbClr val="D8D8E6"/>
+                      </a:solidFill>
+                      <a:prstDash val="solid"/>
+                      <a:round/>
+                      <a:headEnd type="none" w="med" len="med"/>
+                      <a:tailEnd type="none" w="med" len="med"/>
+                    </a:lnT>
+                    <a:lnB w="12700" cap="flat" cmpd="sng" algn="ctr">
+                      <a:solidFill>
+                        <a:srgbClr val="D8D8E6"/>
+                      </a:solidFill>
+                      <a:prstDash val="solid"/>
+                      <a:round/>
+                      <a:headEnd type="none" w="med" len="med"/>
+                      <a:tailEnd type="none" w="med" len="med"/>
+                    </a:lnB>
+                    <a:solidFill>
+                      <a:srgbClr val="FFFFFF"/>
+                    </a:solidFill>
+                  </a:tcPr>
+                </a:tc>
+                <a:tc>
+                  <a:txBody>
+                    <a:bodyPr/>
+                    <a:lstStyle/>
+                    <a:p>
+                      <a:pPr algn="ctr" indent="0" marL="0">
+                        <a:buNone/>
+                      </a:pPr>
+                      <a:r>
+                        <a:rPr lang="en-US" sz="1200" dirty="0">
+                          <a:solidFill>
+                            <a:srgbClr val="26262F"/>
+                          </a:solidFill>
+                          <a:latin typeface="Calibri" pitchFamily="34" charset="0"/>
+                          <a:ea typeface="Calibri" pitchFamily="34" charset="-122"/>
+                          <a:cs typeface="Calibri" pitchFamily="34" charset="-120"/>
+                        </a:rPr>
+                        <a:t>Class selector</a:t>
+                      </a:r>
+                      <a:endParaRPr lang="en-US" sz="1200" dirty="0">
+                        <a:latin typeface="Calibri" charset="0"/>
+                        <a:ea typeface="Calibri" charset="0"/>
+                        <a:cs typeface="Calibri" charset="0"/>
+                      </a:endParaRPr>
+                    </a:p>
+                  </a:txBody>
+                  <a:tcPr marL="91440" marR="91440" marT="45720" marB="45720" anchor="ctr">
+                    <a:lnL w="12700" cap="flat" cmpd="sng" algn="ctr">
+                      <a:solidFill>
+                        <a:srgbClr val="D8D8E6"/>
+                      </a:solidFill>
+                      <a:prstDash val="solid"/>
+                      <a:round/>
+                      <a:headEnd type="none" w="med" len="med"/>
+                      <a:tailEnd type="none" w="med" len="med"/>
+                    </a:lnL>
+                    <a:lnR w="12700" cap="flat" cmpd="sng" algn="ctr">
+                      <a:solidFill>
+                        <a:srgbClr val="D8D8E6"/>
+                      </a:solidFill>
+                      <a:prstDash val="solid"/>
+                      <a:round/>
+                      <a:headEnd type="none" w="med" len="med"/>
+                      <a:tailEnd type="none" w="med" len="med"/>
+                    </a:lnR>
+                    <a:lnT w="12700" cap="flat" cmpd="sng" algn="ctr">
+                      <a:solidFill>
+                        <a:srgbClr val="D8D8E6"/>
+                      </a:solidFill>
+                      <a:prstDash val="solid"/>
+                      <a:round/>
+                      <a:headEnd type="none" w="med" len="med"/>
+                      <a:tailEnd type="none" w="med" len="med"/>
+                    </a:lnT>
+                    <a:lnB w="12700" cap="flat" cmpd="sng" algn="ctr">
+                      <a:solidFill>
+                        <a:srgbClr val="D8D8E6"/>
+                      </a:solidFill>
+                      <a:prstDash val="solid"/>
+                      <a:round/>
+                      <a:headEnd type="none" w="med" len="med"/>
+                      <a:tailEnd type="none" w="med" len="med"/>
+                    </a:lnB>
+                    <a:solidFill>
+                      <a:srgbClr val="FFFFFF"/>
+                    </a:solidFill>
+                  </a:tcPr>
+                </a:tc>
+                <a:tc>
+                  <a:txBody>
+                    <a:bodyPr/>
+                    <a:lstStyle/>
+                    <a:p>
+                      <a:pPr algn="ctr" indent="0" marL="0">
+                        <a:buNone/>
+                      </a:pPr>
+                      <a:r>
+                        <a:rPr lang="en-US" sz="1200" dirty="0">
+                          <a:solidFill>
+                            <a:srgbClr val="26262F"/>
+                          </a:solidFill>
+                          <a:latin typeface="Calibri" pitchFamily="34" charset="0"/>
+                          <a:ea typeface="Calibri" pitchFamily="34" charset="-122"/>
+                          <a:cs typeface="Calibri" pitchFamily="34" charset="-120"/>
+                        </a:rPr>
+                        <a:t>Classes / attrs / pseudo-classes: +1</a:t>
+                      </a:r>
+                      <a:endParaRPr lang="en-US" sz="1200" dirty="0">
+                        <a:latin typeface="Calibri" charset="0"/>
+                        <a:ea typeface="Calibri" charset="0"/>
+                        <a:cs typeface="Calibri" charset="0"/>
+                      </a:endParaRPr>
+                    </a:p>
+                  </a:txBody>
+                  <a:tcPr marL="91440" marR="91440" marT="45720" marB="45720" anchor="ctr">
+                    <a:lnL w="12700" cap="flat" cmpd="sng" algn="ctr">
+                      <a:solidFill>
+                        <a:srgbClr val="D8D8E6"/>
+                      </a:solidFill>
+                      <a:prstDash val="solid"/>
+                      <a:round/>
+                      <a:headEnd type="none" w="med" len="med"/>
+                      <a:tailEnd type="none" w="med" len="med"/>
+                    </a:lnL>
+                    <a:lnR w="12700" cap="flat" cmpd="sng" algn="ctr">
+                      <a:solidFill>
+                        <a:srgbClr val="D8D8E6"/>
+                      </a:solidFill>
+                      <a:prstDash val="solid"/>
+                      <a:round/>
+                      <a:headEnd type="none" w="med" len="med"/>
+                      <a:tailEnd type="none" w="med" len="med"/>
+                    </a:lnR>
+                    <a:lnT w="12700" cap="flat" cmpd="sng" algn="ctr">
+                      <a:solidFill>
+                        <a:srgbClr val="D8D8E6"/>
+                      </a:solidFill>
+                      <a:prstDash val="solid"/>
+                      <a:round/>
+                      <a:headEnd type="none" w="med" len="med"/>
+                      <a:tailEnd type="none" w="med" len="med"/>
+                    </a:lnT>
+                    <a:lnB w="12700" cap="flat" cmpd="sng" algn="ctr">
+                      <a:solidFill>
+                        <a:srgbClr val="D8D8E6"/>
+                      </a:solidFill>
+                      <a:prstDash val="solid"/>
+                      <a:round/>
+                      <a:headEnd type="none" w="med" len="med"/>
+                      <a:tailEnd type="none" w="med" len="med"/>
+                    </a:lnB>
+                    <a:solidFill>
+                      <a:srgbClr val="FFFFFF"/>
+                    </a:solidFill>
+                  </a:tcPr>
+                </a:tc>
+              </a:tr>
+              <a:tr h="566928">
+                <a:tc>
+                  <a:txBody>
+                    <a:bodyPr/>
+                    <a:lstStyle/>
+                    <a:p>
+                      <a:pPr algn="l" indent="0" marL="0">
+                        <a:buNone/>
+                      </a:pPr>
+                      <a:r>
+                        <a:rPr lang="en-US" sz="1200" b="1" dirty="0">
+                          <a:solidFill>
+                            <a:srgbClr val="26262F"/>
+                          </a:solidFill>
+                          <a:latin typeface="Calibri" pitchFamily="34" charset="0"/>
+                          <a:ea typeface="Calibri" pitchFamily="34" charset="-122"/>
+                          <a:cs typeface="Calibri" pitchFamily="34" charset="-120"/>
+                        </a:rPr>
+                        <a:t>:hover</a:t>
+                      </a:r>
+                      <a:endParaRPr lang="en-US" sz="1200" dirty="0">
+                        <a:latin typeface="Calibri" charset="0"/>
+                        <a:ea typeface="Calibri" charset="0"/>
+                        <a:cs typeface="Calibri" charset="0"/>
+                      </a:endParaRPr>
+                    </a:p>
+                  </a:txBody>
+                  <a:tcPr marL="91440" marR="91440" marT="45720" marB="45720" anchor="ctr">
+                    <a:lnL w="12700" cap="flat" cmpd="sng" algn="ctr">
+                      <a:solidFill>
+                        <a:srgbClr val="D8D8E6"/>
+                      </a:solidFill>
+                      <a:prstDash val="solid"/>
+                      <a:round/>
+                      <a:headEnd type="none" w="med" len="med"/>
+                      <a:tailEnd type="none" w="med" len="med"/>
+                    </a:lnL>
+                    <a:lnR w="12700" cap="flat" cmpd="sng" algn="ctr">
+                      <a:solidFill>
+                        <a:srgbClr val="D8D8E6"/>
+                      </a:solidFill>
+                      <a:prstDash val="solid"/>
+                      <a:round/>
+                      <a:headEnd type="none" w="med" len="med"/>
+                      <a:tailEnd type="none" w="med" len="med"/>
+                    </a:lnR>
+                    <a:lnT w="12700" cap="flat" cmpd="sng" algn="ctr">
+                      <a:solidFill>
+                        <a:srgbClr val="D8D8E6"/>
+                      </a:solidFill>
+                      <a:prstDash val="solid"/>
+                      <a:round/>
+                      <a:headEnd type="none" w="med" len="med"/>
+                      <a:tailEnd type="none" w="med" len="med"/>
+                    </a:lnT>
+                    <a:lnB w="12700" cap="flat" cmpd="sng" algn="ctr">
+                      <a:solidFill>
+                        <a:srgbClr val="D8D8E6"/>
+                      </a:solidFill>
+                      <a:prstDash val="solid"/>
+                      <a:round/>
+                      <a:headEnd type="none" w="med" len="med"/>
+                      <a:tailEnd type="none" w="med" len="med"/>
+                    </a:lnB>
+                    <a:solidFill>
+                      <a:srgbClr val="FFFFFF"/>
+                    </a:solidFill>
+                  </a:tcPr>
+                </a:tc>
+                <a:tc>
+                  <a:txBody>
+                    <a:bodyPr/>
+                    <a:lstStyle/>
+                    <a:p>
+                      <a:pPr algn="ctr" indent="0" marL="0">
+                        <a:buNone/>
+                      </a:pPr>
+                      <a:r>
+                        <a:rPr lang="en-US" sz="1200" dirty="0">
+                          <a:solidFill>
+                            <a:srgbClr val="26262F"/>
+                          </a:solidFill>
+                          <a:latin typeface="Calibri" pitchFamily="34" charset="0"/>
+                          <a:ea typeface="Calibri" pitchFamily="34" charset="-122"/>
+                          <a:cs typeface="Calibri" pitchFamily="34" charset="-120"/>
+                        </a:rPr>
+                        <a:t>Pseudo-class</a:t>
+                      </a:r>
+                      <a:endParaRPr lang="en-US" sz="1200" dirty="0">
+                        <a:latin typeface="Calibri" charset="0"/>
+                        <a:ea typeface="Calibri" charset="0"/>
+                        <a:cs typeface="Calibri" charset="0"/>
+                      </a:endParaRPr>
+                    </a:p>
+                  </a:txBody>
+                  <a:tcPr marL="91440" marR="91440" marT="45720" marB="45720" anchor="ctr">
+                    <a:lnL w="12700" cap="flat" cmpd="sng" algn="ctr">
+                      <a:solidFill>
+                        <a:srgbClr val="D8D8E6"/>
+                      </a:solidFill>
+                      <a:prstDash val="solid"/>
+                      <a:round/>
+                      <a:headEnd type="none" w="med" len="med"/>
+                      <a:tailEnd type="none" w="med" len="med"/>
+                    </a:lnL>
+                    <a:lnR w="12700" cap="flat" cmpd="sng" algn="ctr">
+                      <a:solidFill>
+                        <a:srgbClr val="D8D8E6"/>
+                      </a:solidFill>
+                      <a:prstDash val="solid"/>
+                      <a:round/>
+                      <a:headEnd type="none" w="med" len="med"/>
+                      <a:tailEnd type="none" w="med" len="med"/>
+                    </a:lnR>
+                    <a:lnT w="12700" cap="flat" cmpd="sng" algn="ctr">
+                      <a:solidFill>
+                        <a:srgbClr val="D8D8E6"/>
+                      </a:solidFill>
+                      <a:prstDash val="solid"/>
+                      <a:round/>
+                      <a:headEnd type="none" w="med" len="med"/>
+                      <a:tailEnd type="none" w="med" len="med"/>
+                    </a:lnT>
+                    <a:lnB w="12700" cap="flat" cmpd="sng" algn="ctr">
+                      <a:solidFill>
+                        <a:srgbClr val="D8D8E6"/>
+                      </a:solidFill>
+                      <a:prstDash val="solid"/>
+                      <a:round/>
+                      <a:headEnd type="none" w="med" len="med"/>
+                      <a:tailEnd type="none" w="med" len="med"/>
+                    </a:lnB>
+                    <a:solidFill>
+                      <a:srgbClr val="FFFFFF"/>
+                    </a:solidFill>
+                  </a:tcPr>
+                </a:tc>
+                <a:tc>
+                  <a:txBody>
+                    <a:bodyPr/>
+                    <a:lstStyle/>
+                    <a:p>
+                      <a:pPr algn="ctr" indent="0" marL="0">
+                        <a:buNone/>
+                      </a:pPr>
+                      <a:r>
+                        <a:rPr lang="en-US" sz="1200" dirty="0">
+                          <a:solidFill>
+                            <a:srgbClr val="26262F"/>
+                          </a:solidFill>
+                          <a:latin typeface="Calibri" pitchFamily="34" charset="0"/>
+                          <a:ea typeface="Calibri" pitchFamily="34" charset="-122"/>
+                          <a:cs typeface="Calibri" pitchFamily="34" charset="-120"/>
+                        </a:rPr>
+                        <a:t>Classes / attrs / pseudo-classes: +1</a:t>
+                      </a:r>
+                      <a:endParaRPr lang="en-US" sz="1200" dirty="0">
+                        <a:latin typeface="Calibri" charset="0"/>
+                        <a:ea typeface="Calibri" charset="0"/>
+                        <a:cs typeface="Calibri" charset="0"/>
+                      </a:endParaRPr>
+                    </a:p>
+                  </a:txBody>
+                  <a:tcPr marL="91440" marR="91440" marT="45720" marB="45720" anchor="ctr">
+                    <a:lnL w="12700" cap="flat" cmpd="sng" algn="ctr">
+                      <a:solidFill>
+                        <a:srgbClr val="D8D8E6"/>
+                      </a:solidFill>
+                      <a:prstDash val="solid"/>
+                      <a:round/>
+                      <a:headEnd type="none" w="med" len="med"/>
+                      <a:tailEnd type="none" w="med" len="med"/>
+                    </a:lnL>
+                    <a:lnR w="12700" cap="flat" cmpd="sng" algn="ctr">
+                      <a:solidFill>
+                        <a:srgbClr val="D8D8E6"/>
+                      </a:solidFill>
+                      <a:prstDash val="solid"/>
+                      <a:round/>
+                      <a:headEnd type="none" w="med" len="med"/>
+                      <a:tailEnd type="none" w="med" len="med"/>
+                    </a:lnR>
+                    <a:lnT w="12700" cap="flat" cmpd="sng" algn="ctr">
+                      <a:solidFill>
+                        <a:srgbClr val="D8D8E6"/>
+                      </a:solidFill>
+                      <a:prstDash val="solid"/>
+                      <a:round/>
+                      <a:headEnd type="none" w="med" len="med"/>
+                      <a:tailEnd type="none" w="med" len="med"/>
+                    </a:lnT>
+                    <a:lnB w="12700" cap="flat" cmpd="sng" algn="ctr">
+                      <a:solidFill>
+                        <a:srgbClr val="D8D8E6"/>
+                      </a:solidFill>
+                      <a:prstDash val="solid"/>
+                      <a:round/>
+                      <a:headEnd type="none" w="med" len="med"/>
+                      <a:tailEnd type="none" w="med" len="med"/>
+                    </a:lnB>
+                    <a:solidFill>
+                      <a:srgbClr val="FFFFFF"/>
+                    </a:solidFill>
+                  </a:tcPr>
+                </a:tc>
+              </a:tr>
+              <a:tr h="566928">
+                <a:tc>
+                  <a:txBody>
+                    <a:bodyPr/>
+                    <a:lstStyle/>
+                    <a:p>
+                      <a:pPr algn="l" indent="0" marL="0">
+                        <a:buNone/>
+                      </a:pPr>
+                      <a:r>
+                        <a:rPr lang="en-US" sz="1200" b="1" dirty="0">
+                          <a:solidFill>
+                            <a:srgbClr val="26262F"/>
+                          </a:solidFill>
+                          <a:latin typeface="Calibri" pitchFamily="34" charset="0"/>
+                          <a:ea typeface="Calibri" pitchFamily="34" charset="-122"/>
+                          <a:cs typeface="Calibri" pitchFamily="34" charset="-120"/>
+                        </a:rPr>
+                        <a:t>a</a:t>
+                      </a:r>
+                      <a:endParaRPr lang="en-US" sz="1200" dirty="0">
+                        <a:latin typeface="Calibri" charset="0"/>
+                        <a:ea typeface="Calibri" charset="0"/>
+                        <a:cs typeface="Calibri" charset="0"/>
+                      </a:endParaRPr>
+                    </a:p>
+                  </a:txBody>
+                  <a:tcPr marL="91440" marR="91440" marT="45720" marB="45720" anchor="ctr">
+                    <a:lnL w="12700" cap="flat" cmpd="sng" algn="ctr">
+                      <a:solidFill>
+                        <a:srgbClr val="D8D8E6"/>
+                      </a:solidFill>
+                      <a:prstDash val="solid"/>
+                      <a:round/>
+                      <a:headEnd type="none" w="med" len="med"/>
+                      <a:tailEnd type="none" w="med" len="med"/>
+                    </a:lnL>
+                    <a:lnR w="12700" cap="flat" cmpd="sng" algn="ctr">
+                      <a:solidFill>
+                        <a:srgbClr val="D8D8E6"/>
+                      </a:solidFill>
+                      <a:prstDash val="solid"/>
+                      <a:round/>
+                      <a:headEnd type="none" w="med" len="med"/>
+                      <a:tailEnd type="none" w="med" len="med"/>
+                    </a:lnR>
+                    <a:lnT w="12700" cap="flat" cmpd="sng" algn="ctr">
+                      <a:solidFill>
+                        <a:srgbClr val="D8D8E6"/>
+                      </a:solidFill>
+                      <a:prstDash val="solid"/>
+                      <a:round/>
+                      <a:headEnd type="none" w="med" len="med"/>
+                      <a:tailEnd type="none" w="med" len="med"/>
+                    </a:lnT>
+                    <a:lnB w="12700" cap="flat" cmpd="sng" algn="ctr">
+                      <a:solidFill>
+                        <a:srgbClr val="D8D8E6"/>
+                      </a:solidFill>
+                      <a:prstDash val="solid"/>
+                      <a:round/>
+                      <a:headEnd type="none" w="med" len="med"/>
+                      <a:tailEnd type="none" w="med" len="med"/>
+                    </a:lnB>
+                    <a:solidFill>
+                      <a:srgbClr val="FFFFFF"/>
+                    </a:solidFill>
+                  </a:tcPr>
+                </a:tc>
+                <a:tc>
+                  <a:txBody>
+                    <a:bodyPr/>
+                    <a:lstStyle/>
+                    <a:p>
+                      <a:pPr algn="ctr" indent="0" marL="0">
+                        <a:buNone/>
+                      </a:pPr>
+                      <a:r>
+                        <a:rPr lang="en-US" sz="1200" dirty="0">
+                          <a:solidFill>
+                            <a:srgbClr val="26262F"/>
+                          </a:solidFill>
+                          <a:latin typeface="Calibri" pitchFamily="34" charset="0"/>
+                          <a:ea typeface="Calibri" pitchFamily="34" charset="-122"/>
+                          <a:cs typeface="Calibri" pitchFamily="34" charset="-120"/>
+                        </a:rPr>
+                        <a:t>Element selector</a:t>
+                      </a:r>
+                      <a:endParaRPr lang="en-US" sz="1200" dirty="0">
+                        <a:latin typeface="Calibri" charset="0"/>
+                        <a:ea typeface="Calibri" charset="0"/>
+                        <a:cs typeface="Calibri" charset="0"/>
+                      </a:endParaRPr>
+                    </a:p>
+                  </a:txBody>
+                  <a:tcPr marL="91440" marR="91440" marT="45720" marB="45720" anchor="ctr">
+                    <a:lnL w="12700" cap="flat" cmpd="sng" algn="ctr">
+                      <a:solidFill>
+                        <a:srgbClr val="D8D8E6"/>
+                      </a:solidFill>
+                      <a:prstDash val="solid"/>
+                      <a:round/>
+                      <a:headEnd type="none" w="med" len="med"/>
+                      <a:tailEnd type="none" w="med" len="med"/>
+                    </a:lnL>
+                    <a:lnR w="12700" cap="flat" cmpd="sng" algn="ctr">
+                      <a:solidFill>
+                        <a:srgbClr val="D8D8E6"/>
+                      </a:solidFill>
+                      <a:prstDash val="solid"/>
+                      <a:round/>
+                      <a:headEnd type="none" w="med" len="med"/>
+                      <a:tailEnd type="none" w="med" len="med"/>
+                    </a:lnR>
+                    <a:lnT w="12700" cap="flat" cmpd="sng" algn="ctr">
+                      <a:solidFill>
+                        <a:srgbClr val="D8D8E6"/>
+                      </a:solidFill>
+                      <a:prstDash val="solid"/>
+                      <a:round/>
+                      <a:headEnd type="none" w="med" len="med"/>
+                      <a:tailEnd type="none" w="med" len="med"/>
+                    </a:lnT>
+                    <a:lnB w="12700" cap="flat" cmpd="sng" algn="ctr">
+                      <a:solidFill>
+                        <a:srgbClr val="D8D8E6"/>
+                      </a:solidFill>
+                      <a:prstDash val="solid"/>
+                      <a:round/>
+                      <a:headEnd type="none" w="med" len="med"/>
+                      <a:tailEnd type="none" w="med" len="med"/>
+                    </a:lnB>
+                    <a:solidFill>
+                      <a:srgbClr val="FFFFFF"/>
+                    </a:solidFill>
+                  </a:tcPr>
+                </a:tc>
+                <a:tc>
+                  <a:txBody>
+                    <a:bodyPr/>
+                    <a:lstStyle/>
+                    <a:p>
+                      <a:pPr algn="ctr" indent="0" marL="0">
+                        <a:buNone/>
+                      </a:pPr>
+                      <a:r>
+                        <a:rPr lang="en-US" sz="1200" dirty="0">
+                          <a:solidFill>
+                            <a:srgbClr val="26262F"/>
+                          </a:solidFill>
+                          <a:latin typeface="Calibri" pitchFamily="34" charset="0"/>
+                          <a:ea typeface="Calibri" pitchFamily="34" charset="-122"/>
+                          <a:cs typeface="Calibri" pitchFamily="34" charset="-120"/>
+                        </a:rPr>
+                        <a:t>Elements / pseudo-elements: +1</a:t>
+                      </a:r>
+                      <a:endParaRPr lang="en-US" sz="1200" dirty="0">
+                        <a:latin typeface="Calibri" charset="0"/>
+                        <a:ea typeface="Calibri" charset="0"/>
+                        <a:cs typeface="Calibri" charset="0"/>
+                      </a:endParaRPr>
+                    </a:p>
+                  </a:txBody>
+                  <a:tcPr marL="91440" marR="91440" marT="45720" marB="45720" anchor="ctr">
+                    <a:lnL w="12700" cap="flat" cmpd="sng" algn="ctr">
+                      <a:solidFill>
+                        <a:srgbClr val="D8D8E6"/>
+                      </a:solidFill>
+                      <a:prstDash val="solid"/>
+                      <a:round/>
+                      <a:headEnd type="none" w="med" len="med"/>
+                      <a:tailEnd type="none" w="med" len="med"/>
+                    </a:lnL>
+                    <a:lnR w="12700" cap="flat" cmpd="sng" algn="ctr">
+                      <a:solidFill>
+                        <a:srgbClr val="D8D8E6"/>
+                      </a:solidFill>
+                      <a:prstDash val="solid"/>
+                      <a:round/>
+                      <a:headEnd type="none" w="med" len="med"/>
+                      <a:tailEnd type="none" w="med" len="med"/>
+                    </a:lnR>
+                    <a:lnT w="12700" cap="flat" cmpd="sng" algn="ctr">
+                      <a:solidFill>
+                        <a:srgbClr val="D8D8E6"/>
+                      </a:solidFill>
+                      <a:prstDash val="solid"/>
+                      <a:round/>
+                      <a:headEnd type="none" w="med" len="med"/>
+                      <a:tailEnd type="none" w="med" len="med"/>
+                    </a:lnT>
+                    <a:lnB w="12700" cap="flat" cmpd="sng" algn="ctr">
+                      <a:solidFill>
+                        <a:srgbClr val="D8D8E6"/>
+                      </a:solidFill>
+                      <a:prstDash val="solid"/>
+                      <a:round/>
+                      <a:headEnd type="none" w="med" len="med"/>
+                      <a:tailEnd type="none" w="med" len="med"/>
+                    </a:lnB>
+                    <a:solidFill>
+                      <a:srgbClr val="FFFFFF"/>
+                    </a:solidFill>
+                  </a:tcPr>
+                </a:tc>
+              </a:tr>
+            </a:tbl>
+          </a:graphicData>
+        </a:graphic>
+      </p:graphicFrame>
+      <p:sp>
+        <p:nvSpPr>
+          <p:cNvPr id="5" name="Text 2"/>
           <p:cNvSpPr txBox="1"/>
           <p:nvPr/>
         </p:nvSpPr>
         <p:spPr>
           <a:xfrm>
-            <a:off x="960120" y="2194560"/>
-            <a:ext cx="10271455" cy="2758440"/>
+            <a:off x="640080" y="6035040"/>
+            <a:ext cx="10911535" cy="365760"/>
           </a:xfrm>
           <a:prstGeom prst="rect">
             <a:avLst/>
@@ -13287,241 +14583,30 @@
           <a:ln/>
         </p:spPr>
         <p:txBody>
-          <a:bodyPr wrap="square" lIns="0" tIns="0" rIns="0" bIns="0" rtlCol="0" anchor="t"/>
+          <a:bodyPr wrap="square" lIns="0" tIns="0" rIns="0" bIns="0" rtlCol="0" anchor="ctr"/>
           <a:lstStyle/>
           <a:p>
             <a:pPr indent="0" marL="0">
-              <a:lnSpc>
-                <a:spcPct val="125000"/>
-              </a:lnSpc>
-              <a:buNone/>
-            </a:pPr>
-            <a:r>
-              <a:rPr lang="en-US" sz="1400" dirty="0">
-                <a:solidFill>
-                  <a:srgbClr val="C9D3F5"/>
-                </a:solidFill>
-                <a:latin typeface="Courier New" pitchFamily="34" charset="0"/>
-                <a:ea typeface="Courier New" pitchFamily="34" charset="-122"/>
-                <a:cs typeface="Courier New" pitchFamily="34" charset="-120"/>
-              </a:rPr>
-              <a:t>.parent {</a:t>
-            </a:r>
-            <a:endParaRPr lang="en-US" sz="1400" dirty="0"/>
-          </a:p>
-          <a:p>
-            <a:pPr indent="0" marL="0">
-              <a:lnSpc>
-                <a:spcPct val="125000"/>
-              </a:lnSpc>
-              <a:buNone/>
-            </a:pPr>
-            <a:r>
-              <a:rPr lang="en-US" sz="1400" dirty="0">
-                <a:solidFill>
-                  <a:srgbClr val="C9D3F5"/>
-                </a:solidFill>
-                <a:latin typeface="Courier New" pitchFamily="34" charset="0"/>
-                <a:ea typeface="Courier New" pitchFamily="34" charset="-122"/>
-                <a:cs typeface="Courier New" pitchFamily="34" charset="-120"/>
-              </a:rPr>
-              <a:t>  border: 4px solid crimson;</a:t>
-            </a:r>
-            <a:endParaRPr lang="en-US" sz="1400" dirty="0"/>
-          </a:p>
-          <a:p>
-            <a:pPr indent="0" marL="0">
-              <a:lnSpc>
-                <a:spcPct val="125000"/>
-              </a:lnSpc>
-              <a:buNone/>
-            </a:pPr>
-            <a:r>
-              <a:rPr lang="en-US" sz="1400" dirty="0">
-                <a:solidFill>
-                  <a:srgbClr val="C9D3F5"/>
-                </a:solidFill>
-                <a:latin typeface="Courier New" pitchFamily="34" charset="0"/>
-                <a:ea typeface="Courier New" pitchFamily="34" charset="-122"/>
-                <a:cs typeface="Courier New" pitchFamily="34" charset="-120"/>
-              </a:rPr>
-              <a:t>  padding: 20px;</a:t>
-            </a:r>
-            <a:endParaRPr lang="en-US" sz="1400" dirty="0"/>
-          </a:p>
-          <a:p>
-            <a:pPr indent="0" marL="0">
-              <a:lnSpc>
-                <a:spcPct val="125000"/>
-              </a:lnSpc>
-              <a:buNone/>
-            </a:pPr>
-            <a:r>
-              <a:rPr lang="en-US" sz="1400" dirty="0">
-                <a:solidFill>
-                  <a:srgbClr val="C9D3F5"/>
-                </a:solidFill>
-                <a:latin typeface="Courier New" pitchFamily="34" charset="0"/>
-                <a:ea typeface="Courier New" pitchFamily="34" charset="-122"/>
-                <a:cs typeface="Courier New" pitchFamily="34" charset="-120"/>
-              </a:rPr>
-              <a:t>  color: darkblue;</a:t>
-            </a:r>
-            <a:endParaRPr lang="en-US" sz="1400" dirty="0"/>
-          </a:p>
-          <a:p>
-            <a:pPr indent="0" marL="0">
-              <a:lnSpc>
-                <a:spcPct val="125000"/>
-              </a:lnSpc>
-              <a:buNone/>
-            </a:pPr>
-            <a:r>
-              <a:rPr lang="en-US" sz="1400" dirty="0">
-                <a:solidFill>
-                  <a:srgbClr val="C9D3F5"/>
-                </a:solidFill>
-                <a:latin typeface="Courier New" pitchFamily="34" charset="0"/>
-                <a:ea typeface="Courier New" pitchFamily="34" charset="-122"/>
-                <a:cs typeface="Courier New" pitchFamily="34" charset="-120"/>
-              </a:rPr>
-              <a:t>}</a:t>
-            </a:r>
-            <a:endParaRPr lang="en-US" sz="1400" dirty="0"/>
-          </a:p>
-          <a:p>
-            <a:pPr indent="0" marL="0">
-              <a:lnSpc>
-                <a:spcPct val="125000"/>
-              </a:lnSpc>
-              <a:buNone/>
-            </a:pPr>
-            <a:endParaRPr lang="en-US" sz="1400" dirty="0"/>
-          </a:p>
-          <a:p>
-            <a:pPr indent="0" marL="0">
-              <a:lnSpc>
-                <a:spcPct val="125000"/>
-              </a:lnSpc>
-              <a:buNone/>
-            </a:pPr>
-            <a:r>
-              <a:rPr lang="en-US" sz="1400" dirty="0">
-                <a:solidFill>
-                  <a:srgbClr val="C9D3F5"/>
-                </a:solidFill>
-                <a:latin typeface="Courier New" pitchFamily="34" charset="0"/>
-                <a:ea typeface="Courier New" pitchFamily="34" charset="-122"/>
-                <a:cs typeface="Courier New" pitchFamily="34" charset="-120"/>
-              </a:rPr>
-              <a:t>&lt;div class="parent"&gt;</a:t>
-            </a:r>
-            <a:endParaRPr lang="en-US" sz="1400" dirty="0"/>
-          </a:p>
-          <a:p>
-            <a:pPr indent="0" marL="0">
-              <a:lnSpc>
-                <a:spcPct val="125000"/>
-              </a:lnSpc>
-              <a:buNone/>
-            </a:pPr>
-            <a:r>
-              <a:rPr lang="en-US" sz="1400" dirty="0">
-                <a:solidFill>
-                  <a:srgbClr val="C9D3F5"/>
-                </a:solidFill>
-                <a:latin typeface="Courier New" pitchFamily="34" charset="0"/>
-                <a:ea typeface="Courier New" pitchFamily="34" charset="-122"/>
-                <a:cs typeface="Courier New" pitchFamily="34" charset="-120"/>
-              </a:rPr>
-              <a:t>  Parent text is dark blue.</a:t>
-            </a:r>
-            <a:endParaRPr lang="en-US" sz="1400" dirty="0"/>
-          </a:p>
-          <a:p>
-            <a:pPr indent="0" marL="0">
-              <a:lnSpc>
-                <a:spcPct val="125000"/>
-              </a:lnSpc>
-              <a:buNone/>
-            </a:pPr>
-            <a:r>
-              <a:rPr lang="en-US" sz="1400" dirty="0">
-                <a:solidFill>
-                  <a:srgbClr val="C9D3F5"/>
-                </a:solidFill>
-                <a:latin typeface="Courier New" pitchFamily="34" charset="0"/>
-                <a:ea typeface="Courier New" pitchFamily="34" charset="-122"/>
-                <a:cs typeface="Courier New" pitchFamily="34" charset="-120"/>
-              </a:rPr>
-              <a:t>  &lt;p&gt;Child paragraph is dark blue too.&lt;/p&gt;</a:t>
-            </a:r>
-            <a:endParaRPr lang="en-US" sz="1400" dirty="0"/>
-          </a:p>
-          <a:p>
-            <a:pPr indent="0" marL="0">
-              <a:lnSpc>
-                <a:spcPct val="125000"/>
-              </a:lnSpc>
-              <a:buNone/>
-            </a:pPr>
-            <a:r>
-              <a:rPr lang="en-US" sz="1400" dirty="0">
-                <a:solidFill>
-                  <a:srgbClr val="C9D3F5"/>
-                </a:solidFill>
-                <a:latin typeface="Courier New" pitchFamily="34" charset="0"/>
-                <a:ea typeface="Courier New" pitchFamily="34" charset="-122"/>
-                <a:cs typeface="Courier New" pitchFamily="34" charset="-120"/>
-              </a:rPr>
-              <a:t>&lt;/div&gt;</a:t>
-            </a:r>
-            <a:endParaRPr lang="en-US" sz="1400" dirty="0"/>
-          </a:p>
-        </p:txBody>
-      </p:sp>
-      <p:sp>
-        <p:nvSpPr>
-          <p:cNvPr id="6" name="Text 4"/>
-          <p:cNvSpPr txBox="1"/>
-          <p:nvPr/>
-        </p:nvSpPr>
-        <p:spPr>
-          <a:xfrm>
-            <a:off x="640080" y="5410200"/>
-            <a:ext cx="10911535" cy="853440"/>
-          </a:xfrm>
-          <a:prstGeom prst="rect">
-            <a:avLst/>
-          </a:prstGeom>
-          <a:noFill/>
-          <a:ln/>
-        </p:spPr>
-        <p:txBody>
-          <a:bodyPr wrap="square" lIns="0" tIns="0" rIns="0" bIns="0" rtlCol="0" anchor="t"/>
-          <a:lstStyle/>
-          <a:p>
-            <a:pPr indent="0" marL="0">
-              <a:buNone/>
-            </a:pPr>
-            <a:r>
-              <a:rPr lang="en-US" sz="1300" dirty="0">
-                <a:solidFill>
-                  <a:srgbClr val="26262F"/>
+              <a:buNone/>
+            </a:pPr>
+            <a:r>
+              <a:rPr lang="en-US" sz="1150" i="1" dirty="0">
+                <a:solidFill>
+                  <a:srgbClr val="5D5D72"/>
                 </a:solidFill>
                 <a:latin typeface="Calibri" pitchFamily="34" charset="0"/>
                 <a:ea typeface="Calibri" pitchFamily="34" charset="-122"/>
                 <a:cs typeface="Calibri" pitchFamily="34" charset="-120"/>
               </a:rPr>
-              <a:t>color inherits, so the &lt;p&gt; is dark blue too. border and padding do NOT inherit — only .parent itself gets the crimson outline and padding.</a:t>
-            </a:r>
-            <a:endParaRPr lang="en-US" sz="1300" dirty="0"/>
-          </a:p>
-        </p:txBody>
-      </p:sp>
-      <p:sp>
-        <p:nvSpPr>
-          <p:cNvPr id="7" name="Text 5"/>
+              <a:t>#nav .item a:hover totals to (0 inline, 1 ID, 2 classes/pseudo, 1 element) = (0,1,2,1). Every part of nav ul li a is a plain element, so it totals to (0,0,0,4). Compare column by column, left to right: the IDs column differs first (1 vs. 0), so #nav .item a:hover wins outright — the comparison never even reaches the Elements column.</a:t>
+            </a:r>
+            <a:endParaRPr lang="en-US" sz="1150" dirty="0"/>
+          </a:p>
+        </p:txBody>
+      </p:sp>
+      <p:sp>
+        <p:nvSpPr>
+          <p:cNvPr id="6" name="Text 3"/>
           <p:cNvSpPr txBox="1"/>
           <p:nvPr/>
         </p:nvSpPr>
@@ -13560,7 +14645,7 @@
       </p:sp>
       <p:sp>
         <p:nvSpPr>
-          <p:cNvPr id="8" name="Text 6"/>
+          <p:cNvPr id="7" name="Text 4"/>
           <p:cNvSpPr txBox="1"/>
           <p:nvPr/>
         </p:nvSpPr>
@@ -13701,6 +14786,466 @@
                 <a:ea typeface="Cambria" pitchFamily="34" charset="-122"/>
                 <a:cs typeface="Cambria" pitchFamily="34" charset="-120"/>
               </a:rPr>
+              <a:t>An Example Where Inheritance Does NOT Happen</a:t>
+            </a:r>
+            <a:endParaRPr lang="en-US" sz="3400" dirty="0"/>
+          </a:p>
+        </p:txBody>
+      </p:sp>
+      <p:sp>
+        <p:nvSpPr>
+          <p:cNvPr id="4" name="Shape 2"/>
+          <p:cNvSpPr/>
+          <p:nvPr/>
+        </p:nvSpPr>
+        <p:spPr>
+          <a:xfrm>
+            <a:off x="640080" y="1965960"/>
+            <a:ext cx="10911535" cy="3215640"/>
+          </a:xfrm>
+          <a:prstGeom prst="roundRect">
+            <a:avLst>
+              <a:gd name="adj" fmla="val 2275"/>
+            </a:avLst>
+          </a:prstGeom>
+          <a:solidFill>
+            <a:srgbClr val="1E1E4C"/>
+          </a:solidFill>
+          <a:ln/>
+        </p:spPr>
+      </p:sp>
+      <p:sp>
+        <p:nvSpPr>
+          <p:cNvPr id="5" name="Text 3"/>
+          <p:cNvSpPr txBox="1"/>
+          <p:nvPr/>
+        </p:nvSpPr>
+        <p:spPr>
+          <a:xfrm>
+            <a:off x="960120" y="2194560"/>
+            <a:ext cx="10271455" cy="2758440"/>
+          </a:xfrm>
+          <a:prstGeom prst="rect">
+            <a:avLst/>
+          </a:prstGeom>
+          <a:noFill/>
+          <a:ln/>
+        </p:spPr>
+        <p:txBody>
+          <a:bodyPr wrap="square" lIns="0" tIns="0" rIns="0" bIns="0" rtlCol="0" anchor="t"/>
+          <a:lstStyle/>
+          <a:p>
+            <a:pPr indent="0" marL="0">
+              <a:lnSpc>
+                <a:spcPct val="125000"/>
+              </a:lnSpc>
+              <a:buNone/>
+            </a:pPr>
+            <a:r>
+              <a:rPr lang="en-US" sz="1400" dirty="0">
+                <a:solidFill>
+                  <a:srgbClr val="C9D3F5"/>
+                </a:solidFill>
+                <a:latin typeface="Courier New" pitchFamily="34" charset="0"/>
+                <a:ea typeface="Courier New" pitchFamily="34" charset="-122"/>
+                <a:cs typeface="Courier New" pitchFamily="34" charset="-120"/>
+              </a:rPr>
+              <a:t>.parent {</a:t>
+            </a:r>
+            <a:endParaRPr lang="en-US" sz="1400" dirty="0"/>
+          </a:p>
+          <a:p>
+            <a:pPr indent="0" marL="0">
+              <a:lnSpc>
+                <a:spcPct val="125000"/>
+              </a:lnSpc>
+              <a:buNone/>
+            </a:pPr>
+            <a:r>
+              <a:rPr lang="en-US" sz="1400" dirty="0">
+                <a:solidFill>
+                  <a:srgbClr val="C9D3F5"/>
+                </a:solidFill>
+                <a:latin typeface="Courier New" pitchFamily="34" charset="0"/>
+                <a:ea typeface="Courier New" pitchFamily="34" charset="-122"/>
+                <a:cs typeface="Courier New" pitchFamily="34" charset="-120"/>
+              </a:rPr>
+              <a:t>  border: 4px solid crimson;</a:t>
+            </a:r>
+            <a:endParaRPr lang="en-US" sz="1400" dirty="0"/>
+          </a:p>
+          <a:p>
+            <a:pPr indent="0" marL="0">
+              <a:lnSpc>
+                <a:spcPct val="125000"/>
+              </a:lnSpc>
+              <a:buNone/>
+            </a:pPr>
+            <a:r>
+              <a:rPr lang="en-US" sz="1400" dirty="0">
+                <a:solidFill>
+                  <a:srgbClr val="C9D3F5"/>
+                </a:solidFill>
+                <a:latin typeface="Courier New" pitchFamily="34" charset="0"/>
+                <a:ea typeface="Courier New" pitchFamily="34" charset="-122"/>
+                <a:cs typeface="Courier New" pitchFamily="34" charset="-120"/>
+              </a:rPr>
+              <a:t>  padding: 20px;</a:t>
+            </a:r>
+            <a:endParaRPr lang="en-US" sz="1400" dirty="0"/>
+          </a:p>
+          <a:p>
+            <a:pPr indent="0" marL="0">
+              <a:lnSpc>
+                <a:spcPct val="125000"/>
+              </a:lnSpc>
+              <a:buNone/>
+            </a:pPr>
+            <a:r>
+              <a:rPr lang="en-US" sz="1400" dirty="0">
+                <a:solidFill>
+                  <a:srgbClr val="C9D3F5"/>
+                </a:solidFill>
+                <a:latin typeface="Courier New" pitchFamily="34" charset="0"/>
+                <a:ea typeface="Courier New" pitchFamily="34" charset="-122"/>
+                <a:cs typeface="Courier New" pitchFamily="34" charset="-120"/>
+              </a:rPr>
+              <a:t>  color: darkblue;</a:t>
+            </a:r>
+            <a:endParaRPr lang="en-US" sz="1400" dirty="0"/>
+          </a:p>
+          <a:p>
+            <a:pPr indent="0" marL="0">
+              <a:lnSpc>
+                <a:spcPct val="125000"/>
+              </a:lnSpc>
+              <a:buNone/>
+            </a:pPr>
+            <a:r>
+              <a:rPr lang="en-US" sz="1400" dirty="0">
+                <a:solidFill>
+                  <a:srgbClr val="C9D3F5"/>
+                </a:solidFill>
+                <a:latin typeface="Courier New" pitchFamily="34" charset="0"/>
+                <a:ea typeface="Courier New" pitchFamily="34" charset="-122"/>
+                <a:cs typeface="Courier New" pitchFamily="34" charset="-120"/>
+              </a:rPr>
+              <a:t>}</a:t>
+            </a:r>
+            <a:endParaRPr lang="en-US" sz="1400" dirty="0"/>
+          </a:p>
+          <a:p>
+            <a:pPr indent="0" marL="0">
+              <a:lnSpc>
+                <a:spcPct val="125000"/>
+              </a:lnSpc>
+              <a:buNone/>
+            </a:pPr>
+            <a:endParaRPr lang="en-US" sz="1400" dirty="0"/>
+          </a:p>
+          <a:p>
+            <a:pPr indent="0" marL="0">
+              <a:lnSpc>
+                <a:spcPct val="125000"/>
+              </a:lnSpc>
+              <a:buNone/>
+            </a:pPr>
+            <a:r>
+              <a:rPr lang="en-US" sz="1400" dirty="0">
+                <a:solidFill>
+                  <a:srgbClr val="C9D3F5"/>
+                </a:solidFill>
+                <a:latin typeface="Courier New" pitchFamily="34" charset="0"/>
+                <a:ea typeface="Courier New" pitchFamily="34" charset="-122"/>
+                <a:cs typeface="Courier New" pitchFamily="34" charset="-120"/>
+              </a:rPr>
+              <a:t>&lt;div class="parent"&gt;</a:t>
+            </a:r>
+            <a:endParaRPr lang="en-US" sz="1400" dirty="0"/>
+          </a:p>
+          <a:p>
+            <a:pPr indent="0" marL="0">
+              <a:lnSpc>
+                <a:spcPct val="125000"/>
+              </a:lnSpc>
+              <a:buNone/>
+            </a:pPr>
+            <a:r>
+              <a:rPr lang="en-US" sz="1400" dirty="0">
+                <a:solidFill>
+                  <a:srgbClr val="C9D3F5"/>
+                </a:solidFill>
+                <a:latin typeface="Courier New" pitchFamily="34" charset="0"/>
+                <a:ea typeface="Courier New" pitchFamily="34" charset="-122"/>
+                <a:cs typeface="Courier New" pitchFamily="34" charset="-120"/>
+              </a:rPr>
+              <a:t>  Parent text is dark blue.</a:t>
+            </a:r>
+            <a:endParaRPr lang="en-US" sz="1400" dirty="0"/>
+          </a:p>
+          <a:p>
+            <a:pPr indent="0" marL="0">
+              <a:lnSpc>
+                <a:spcPct val="125000"/>
+              </a:lnSpc>
+              <a:buNone/>
+            </a:pPr>
+            <a:r>
+              <a:rPr lang="en-US" sz="1400" dirty="0">
+                <a:solidFill>
+                  <a:srgbClr val="C9D3F5"/>
+                </a:solidFill>
+                <a:latin typeface="Courier New" pitchFamily="34" charset="0"/>
+                <a:ea typeface="Courier New" pitchFamily="34" charset="-122"/>
+                <a:cs typeface="Courier New" pitchFamily="34" charset="-120"/>
+              </a:rPr>
+              <a:t>  &lt;p&gt;Child paragraph is dark blue too.&lt;/p&gt;</a:t>
+            </a:r>
+            <a:endParaRPr lang="en-US" sz="1400" dirty="0"/>
+          </a:p>
+          <a:p>
+            <a:pPr indent="0" marL="0">
+              <a:lnSpc>
+                <a:spcPct val="125000"/>
+              </a:lnSpc>
+              <a:buNone/>
+            </a:pPr>
+            <a:r>
+              <a:rPr lang="en-US" sz="1400" dirty="0">
+                <a:solidFill>
+                  <a:srgbClr val="C9D3F5"/>
+                </a:solidFill>
+                <a:latin typeface="Courier New" pitchFamily="34" charset="0"/>
+                <a:ea typeface="Courier New" pitchFamily="34" charset="-122"/>
+                <a:cs typeface="Courier New" pitchFamily="34" charset="-120"/>
+              </a:rPr>
+              <a:t>&lt;/div&gt;</a:t>
+            </a:r>
+            <a:endParaRPr lang="en-US" sz="1400" dirty="0"/>
+          </a:p>
+        </p:txBody>
+      </p:sp>
+      <p:sp>
+        <p:nvSpPr>
+          <p:cNvPr id="6" name="Text 4"/>
+          <p:cNvSpPr txBox="1"/>
+          <p:nvPr/>
+        </p:nvSpPr>
+        <p:spPr>
+          <a:xfrm>
+            <a:off x="640080" y="5410200"/>
+            <a:ext cx="10911535" cy="853440"/>
+          </a:xfrm>
+          <a:prstGeom prst="rect">
+            <a:avLst/>
+          </a:prstGeom>
+          <a:noFill/>
+          <a:ln/>
+        </p:spPr>
+        <p:txBody>
+          <a:bodyPr wrap="square" lIns="0" tIns="0" rIns="0" bIns="0" rtlCol="0" anchor="t"/>
+          <a:lstStyle/>
+          <a:p>
+            <a:pPr indent="0" marL="0">
+              <a:buNone/>
+            </a:pPr>
+            <a:r>
+              <a:rPr lang="en-US" sz="1300" dirty="0">
+                <a:solidFill>
+                  <a:srgbClr val="26262F"/>
+                </a:solidFill>
+                <a:latin typeface="Calibri" pitchFamily="34" charset="0"/>
+                <a:ea typeface="Calibri" pitchFamily="34" charset="-122"/>
+                <a:cs typeface="Calibri" pitchFamily="34" charset="-120"/>
+              </a:rPr>
+              <a:t>color inherits, so the &lt;p&gt; is dark blue too. border and padding do NOT inherit — only .parent itself gets the crimson outline and padding.</a:t>
+            </a:r>
+            <a:endParaRPr lang="en-US" sz="1300" dirty="0"/>
+          </a:p>
+        </p:txBody>
+      </p:sp>
+      <p:sp>
+        <p:nvSpPr>
+          <p:cNvPr id="7" name="Text 5"/>
+          <p:cNvSpPr txBox="1"/>
+          <p:nvPr/>
+        </p:nvSpPr>
+        <p:spPr>
+          <a:xfrm>
+            <a:off x="640080" y="6446520"/>
+            <a:ext cx="8686800" cy="292608"/>
+          </a:xfrm>
+          <a:prstGeom prst="rect">
+            <a:avLst/>
+          </a:prstGeom>
+          <a:noFill/>
+          <a:ln/>
+        </p:spPr>
+        <p:txBody>
+          <a:bodyPr wrap="square" lIns="0" tIns="0" rIns="0" bIns="0" rtlCol="0" anchor="ctr"/>
+          <a:lstStyle/>
+          <a:p>
+            <a:pPr algn="l" indent="0" marL="0">
+              <a:buNone/>
+            </a:pPr>
+            <a:r>
+              <a:rPr lang="en-US" sz="900" dirty="0">
+                <a:solidFill>
+                  <a:srgbClr val="5D5D72"/>
+                </a:solidFill>
+                <a:latin typeface="Calibri" pitchFamily="34" charset="0"/>
+                <a:ea typeface="Calibri" pitchFamily="34" charset="-122"/>
+                <a:cs typeface="Calibri" pitchFamily="34" charset="-120"/>
+              </a:rPr>
+              <a:t>Usman Akram  •  COMSATS University Islamabad</a:t>
+            </a:r>
+            <a:endParaRPr lang="en-US" sz="900" dirty="0"/>
+          </a:p>
+        </p:txBody>
+      </p:sp>
+      <p:sp>
+        <p:nvSpPr>
+          <p:cNvPr id="8" name="Text 6"/>
+          <p:cNvSpPr txBox="1"/>
+          <p:nvPr/>
+        </p:nvSpPr>
+        <p:spPr>
+          <a:xfrm>
+            <a:off x="11155680" y="6446520"/>
+            <a:ext cx="457200" cy="292608"/>
+          </a:xfrm>
+          <a:prstGeom prst="rect">
+            <a:avLst/>
+          </a:prstGeom>
+          <a:noFill/>
+          <a:ln/>
+        </p:spPr>
+        <p:txBody>
+          <a:bodyPr wrap="square" lIns="0" tIns="0" rIns="0" bIns="0" rtlCol="0" anchor="ctr"/>
+          <a:lstStyle/>
+          <a:p>
+            <a:pPr algn="r" indent="0" marL="0">
+              <a:buNone/>
+            </a:pPr>
+            <a:r>
+              <a:rPr lang="en-US" sz="900" dirty="0">
+                <a:solidFill>
+                  <a:srgbClr val="5D5D72"/>
+                </a:solidFill>
+                <a:latin typeface="Calibri" pitchFamily="34" charset="0"/>
+                <a:ea typeface="Calibri" pitchFamily="34" charset="-122"/>
+                <a:cs typeface="Calibri" pitchFamily="34" charset="-120"/>
+              </a:rPr>
+              <a:t>27</a:t>
+            </a:r>
+            <a:endParaRPr lang="en-US" sz="900" dirty="0"/>
+          </a:p>
+        </p:txBody>
+      </p:sp>
+    </p:spTree>
+  </p:cSld>
+  <p:clrMapOvr>
+    <a:masterClrMapping/>
+  </p:clrMapOvr>
+</p:sld>
+</file>
+
+<file path=ppt/slides/slide28.xml><?xml version="1.0" encoding="utf-8"?>
+<p:sld xmlns:a="http://schemas.openxmlformats.org/drawingml/2006/main" xmlns:r="http://schemas.openxmlformats.org/officeDocument/2006/relationships" xmlns:p="http://schemas.openxmlformats.org/presentationml/2006/main">
+  <p:cSld name="Slide 28">
+    <p:bg>
+      <p:bgPr>
+        <a:solidFill>
+          <a:srgbClr val="FFFFFF"/>
+        </a:solidFill>
+      </p:bgPr>
+    </p:bg>
+    <p:spTree>
+      <p:nvGrpSpPr>
+        <p:cNvPr id="1" name=""/>
+        <p:cNvGrpSpPr/>
+        <p:nvPr/>
+      </p:nvGrpSpPr>
+      <p:grpSpPr>
+        <a:xfrm>
+          <a:off x="0" y="0"/>
+          <a:ext cx="0" cy="0"/>
+          <a:chOff x="0" y="0"/>
+          <a:chExt cx="0" cy="0"/>
+        </a:xfrm>
+      </p:grpSpPr>
+      <p:sp>
+        <p:nvSpPr>
+          <p:cNvPr id="2" name="Text 0"/>
+          <p:cNvSpPr txBox="1"/>
+          <p:nvPr/>
+        </p:nvSpPr>
+        <p:spPr>
+          <a:xfrm>
+            <a:off x="640080" y="457200"/>
+            <a:ext cx="10058400" cy="365760"/>
+          </a:xfrm>
+          <a:prstGeom prst="rect">
+            <a:avLst/>
+          </a:prstGeom>
+          <a:noFill/>
+          <a:ln/>
+        </p:spPr>
+        <p:txBody>
+          <a:bodyPr wrap="square" lIns="0" tIns="0" rIns="0" bIns="0" rtlCol="0" anchor="ctr"/>
+          <a:lstStyle/>
+          <a:p>
+            <a:pPr algn="l" indent="0" marL="0">
+              <a:buNone/>
+            </a:pPr>
+            <a:r>
+              <a:rPr lang="en-US" sz="1300" b="1" spc="300" kern="0" dirty="0">
+                <a:solidFill>
+                  <a:srgbClr val="FF8A3D"/>
+                </a:solidFill>
+                <a:latin typeface="Calibri" pitchFamily="34" charset="0"/>
+                <a:ea typeface="Calibri" pitchFamily="34" charset="-122"/>
+                <a:cs typeface="Calibri" pitchFamily="34" charset="-120"/>
+              </a:rPr>
+              <a:t>INHERITANCE</a:t>
+            </a:r>
+            <a:endParaRPr lang="en-US" sz="1300" dirty="0"/>
+          </a:p>
+        </p:txBody>
+      </p:sp>
+      <p:sp>
+        <p:nvSpPr>
+          <p:cNvPr id="3" name="Text 1"/>
+          <p:cNvSpPr txBox="1"/>
+          <p:nvPr/>
+        </p:nvSpPr>
+        <p:spPr>
+          <a:xfrm>
+            <a:off x="640080" y="841248"/>
+            <a:ext cx="10881360" cy="914400"/>
+          </a:xfrm>
+          <a:prstGeom prst="rect">
+            <a:avLst/>
+          </a:prstGeom>
+          <a:noFill/>
+          <a:ln/>
+        </p:spPr>
+        <p:txBody>
+          <a:bodyPr wrap="square" lIns="0" tIns="0" rIns="0" bIns="0" rtlCol="0" anchor="ctr"/>
+          <a:lstStyle/>
+          <a:p>
+            <a:pPr algn="l" indent="0" marL="0">
+              <a:buNone/>
+            </a:pPr>
+            <a:r>
+              <a:rPr lang="en-US" sz="3400" b="1" dirty="0">
+                <a:solidFill>
+                  <a:srgbClr val="2B2B7A"/>
+                </a:solidFill>
+                <a:latin typeface="Cambria" pitchFamily="34" charset="0"/>
+                <a:ea typeface="Cambria" pitchFamily="34" charset="-122"/>
+                <a:cs typeface="Cambria" pitchFamily="34" charset="-120"/>
+              </a:rPr>
               <a:t>Inherited vs. Not Inherited</a:t>
             </a:r>
             <a:endParaRPr lang="en-US" sz="3400" dirty="0"/>
@@ -13709,7 +15254,7 @@
       </p:sp>
       <p:graphicFrame>
         <p:nvGraphicFramePr>
-          <p:cNvPr id="28" name="Table 0"/>
+          <p:cNvPr id="29" name="Table 0"/>
           <p:cNvGraphicFramePr>
             <a:graphicFrameLocks noGrp="1"/>
           </p:cNvGraphicFramePr>
@@ -14637,396 +16182,6 @@
                 <a:ea typeface="Calibri" pitchFamily="34" charset="-122"/>
                 <a:cs typeface="Calibri" pitchFamily="34" charset="-120"/>
               </a:rPr>
-              <a:t>27</a:t>
-            </a:r>
-            <a:endParaRPr lang="en-US" sz="900" dirty="0"/>
-          </a:p>
-        </p:txBody>
-      </p:sp>
-    </p:spTree>
-  </p:cSld>
-  <p:clrMapOvr>
-    <a:masterClrMapping/>
-  </p:clrMapOvr>
-</p:sld>
-</file>
-
-<file path=ppt/slides/slide28.xml><?xml version="1.0" encoding="utf-8"?>
-<p:sld xmlns:a="http://schemas.openxmlformats.org/drawingml/2006/main" xmlns:r="http://schemas.openxmlformats.org/officeDocument/2006/relationships" xmlns:p="http://schemas.openxmlformats.org/presentationml/2006/main">
-  <p:cSld name="Slide 28">
-    <p:bg>
-      <p:bgPr>
-        <a:solidFill>
-          <a:srgbClr val="FFFFFF"/>
-        </a:solidFill>
-      </p:bgPr>
-    </p:bg>
-    <p:spTree>
-      <p:nvGrpSpPr>
-        <p:cNvPr id="1" name=""/>
-        <p:cNvGrpSpPr/>
-        <p:nvPr/>
-      </p:nvGrpSpPr>
-      <p:grpSpPr>
-        <a:xfrm>
-          <a:off x="0" y="0"/>
-          <a:ext cx="0" cy="0"/>
-          <a:chOff x="0" y="0"/>
-          <a:chExt cx="0" cy="0"/>
-        </a:xfrm>
-      </p:grpSpPr>
-      <p:sp>
-        <p:nvSpPr>
-          <p:cNvPr id="2" name="Text 0"/>
-          <p:cNvSpPr txBox="1"/>
-          <p:nvPr/>
-        </p:nvSpPr>
-        <p:spPr>
-          <a:xfrm>
-            <a:off x="640080" y="457200"/>
-            <a:ext cx="10058400" cy="365760"/>
-          </a:xfrm>
-          <a:prstGeom prst="rect">
-            <a:avLst/>
-          </a:prstGeom>
-          <a:noFill/>
-          <a:ln/>
-        </p:spPr>
-        <p:txBody>
-          <a:bodyPr wrap="square" lIns="0" tIns="0" rIns="0" bIns="0" rtlCol="0" anchor="ctr"/>
-          <a:lstStyle/>
-          <a:p>
-            <a:pPr algn="l" indent="0" marL="0">
-              <a:buNone/>
-            </a:pPr>
-            <a:r>
-              <a:rPr lang="en-US" sz="1300" b="1" spc="300" kern="0" dirty="0">
-                <a:solidFill>
-                  <a:srgbClr val="FF8A3D"/>
-                </a:solidFill>
-                <a:latin typeface="Calibri" pitchFamily="34" charset="0"/>
-                <a:ea typeface="Calibri" pitchFamily="34" charset="-122"/>
-                <a:cs typeface="Calibri" pitchFamily="34" charset="-120"/>
-              </a:rPr>
-              <a:t>COLOUR</a:t>
-            </a:r>
-            <a:endParaRPr lang="en-US" sz="1300" dirty="0"/>
-          </a:p>
-        </p:txBody>
-      </p:sp>
-      <p:sp>
-        <p:nvSpPr>
-          <p:cNvPr id="3" name="Text 1"/>
-          <p:cNvSpPr txBox="1"/>
-          <p:nvPr/>
-        </p:nvSpPr>
-        <p:spPr>
-          <a:xfrm>
-            <a:off x="640080" y="841248"/>
-            <a:ext cx="10881360" cy="914400"/>
-          </a:xfrm>
-          <a:prstGeom prst="rect">
-            <a:avLst/>
-          </a:prstGeom>
-          <a:noFill/>
-          <a:ln/>
-        </p:spPr>
-        <p:txBody>
-          <a:bodyPr wrap="square" lIns="0" tIns="0" rIns="0" bIns="0" rtlCol="0" anchor="ctr"/>
-          <a:lstStyle/>
-          <a:p>
-            <a:pPr algn="l" indent="0" marL="0">
-              <a:buNone/>
-            </a:pPr>
-            <a:r>
-              <a:rPr lang="en-US" sz="3400" b="1" dirty="0">
-                <a:solidFill>
-                  <a:srgbClr val="2B2B7A"/>
-                </a:solidFill>
-                <a:latin typeface="Cambria" pitchFamily="34" charset="0"/>
-                <a:ea typeface="Cambria" pitchFamily="34" charset="-122"/>
-                <a:cs typeface="Cambria" pitchFamily="34" charset="-120"/>
-              </a:rPr>
-              <a:t>Five Ways to Write a Colour</a:t>
-            </a:r>
-            <a:endParaRPr lang="en-US" sz="3400" dirty="0"/>
-          </a:p>
-        </p:txBody>
-      </p:sp>
-      <p:sp>
-        <p:nvSpPr>
-          <p:cNvPr id="4" name="Shape 2"/>
-          <p:cNvSpPr/>
-          <p:nvPr/>
-        </p:nvSpPr>
-        <p:spPr>
-          <a:xfrm>
-            <a:off x="640080" y="1965960"/>
-            <a:ext cx="10911535" cy="1739265"/>
-          </a:xfrm>
-          <a:prstGeom prst="roundRect">
-            <a:avLst>
-              <a:gd name="adj" fmla="val 4206"/>
-            </a:avLst>
-          </a:prstGeom>
-          <a:solidFill>
-            <a:srgbClr val="1E1E4C"/>
-          </a:solidFill>
-          <a:ln/>
-        </p:spPr>
-      </p:sp>
-      <p:sp>
-        <p:nvSpPr>
-          <p:cNvPr id="5" name="Text 3"/>
-          <p:cNvSpPr txBox="1"/>
-          <p:nvPr/>
-        </p:nvSpPr>
-        <p:spPr>
-          <a:xfrm>
-            <a:off x="960120" y="2194560"/>
-            <a:ext cx="10271455" cy="1282065"/>
-          </a:xfrm>
-          <a:prstGeom prst="rect">
-            <a:avLst/>
-          </a:prstGeom>
-          <a:noFill/>
-          <a:ln/>
-        </p:spPr>
-        <p:txBody>
-          <a:bodyPr wrap="square" lIns="0" tIns="0" rIns="0" bIns="0" rtlCol="0" anchor="t"/>
-          <a:lstStyle/>
-          <a:p>
-            <a:pPr indent="0" marL="0">
-              <a:lnSpc>
-                <a:spcPct val="125000"/>
-              </a:lnSpc>
-              <a:buNone/>
-            </a:pPr>
-            <a:r>
-              <a:rPr lang="en-US" sz="1250" dirty="0">
-                <a:solidFill>
-                  <a:srgbClr val="C9D3F5"/>
-                </a:solidFill>
-                <a:latin typeface="Courier New" pitchFamily="34" charset="0"/>
-                <a:ea typeface="Courier New" pitchFamily="34" charset="-122"/>
-                <a:cs typeface="Courier New" pitchFamily="34" charset="-120"/>
-              </a:rPr>
-              <a:t>.a { color: red; }                  /* named colour */</a:t>
-            </a:r>
-            <a:endParaRPr lang="en-US" sz="1250" dirty="0"/>
-          </a:p>
-          <a:p>
-            <a:pPr indent="0" marL="0">
-              <a:lnSpc>
-                <a:spcPct val="125000"/>
-              </a:lnSpc>
-              <a:buNone/>
-            </a:pPr>
-            <a:r>
-              <a:rPr lang="en-US" sz="1250" dirty="0">
-                <a:solidFill>
-                  <a:srgbClr val="C9D3F5"/>
-                </a:solidFill>
-                <a:latin typeface="Courier New" pitchFamily="34" charset="0"/>
-                <a:ea typeface="Courier New" pitchFamily="34" charset="-122"/>
-                <a:cs typeface="Courier New" pitchFamily="34" charset="-120"/>
-              </a:rPr>
-              <a:t>.b { color: #ff0000; }              /* hex code */</a:t>
-            </a:r>
-            <a:endParaRPr lang="en-US" sz="1250" dirty="0"/>
-          </a:p>
-          <a:p>
-            <a:pPr indent="0" marL="0">
-              <a:lnSpc>
-                <a:spcPct val="125000"/>
-              </a:lnSpc>
-              <a:buNone/>
-            </a:pPr>
-            <a:r>
-              <a:rPr lang="en-US" sz="1250" dirty="0">
-                <a:solidFill>
-                  <a:srgbClr val="C9D3F5"/>
-                </a:solidFill>
-                <a:latin typeface="Courier New" pitchFamily="34" charset="0"/>
-                <a:ea typeface="Courier New" pitchFamily="34" charset="-122"/>
-                <a:cs typeface="Courier New" pitchFamily="34" charset="-120"/>
-              </a:rPr>
-              <a:t>.c { color: rgb(255, 0, 0); }       /* red, green, blue */</a:t>
-            </a:r>
-            <a:endParaRPr lang="en-US" sz="1250" dirty="0"/>
-          </a:p>
-          <a:p>
-            <a:pPr indent="0" marL="0">
-              <a:lnSpc>
-                <a:spcPct val="125000"/>
-              </a:lnSpc>
-              <a:buNone/>
-            </a:pPr>
-            <a:r>
-              <a:rPr lang="en-US" sz="1250" dirty="0">
-                <a:solidFill>
-                  <a:srgbClr val="C9D3F5"/>
-                </a:solidFill>
-                <a:latin typeface="Courier New" pitchFamily="34" charset="0"/>
-                <a:ea typeface="Courier New" pitchFamily="34" charset="-122"/>
-                <a:cs typeface="Courier New" pitchFamily="34" charset="-120"/>
-              </a:rPr>
-              <a:t>.d { color: rgba(255, 0, 0, 0.5); } /* rgb + alpha */</a:t>
-            </a:r>
-            <a:endParaRPr lang="en-US" sz="1250" dirty="0"/>
-          </a:p>
-          <a:p>
-            <a:pPr indent="0" marL="0">
-              <a:lnSpc>
-                <a:spcPct val="125000"/>
-              </a:lnSpc>
-              <a:buNone/>
-            </a:pPr>
-            <a:r>
-              <a:rPr lang="en-US" sz="1250" dirty="0">
-                <a:solidFill>
-                  <a:srgbClr val="C9D3F5"/>
-                </a:solidFill>
-                <a:latin typeface="Courier New" pitchFamily="34" charset="0"/>
-                <a:ea typeface="Courier New" pitchFamily="34" charset="-122"/>
-                <a:cs typeface="Courier New" pitchFamily="34" charset="-120"/>
-              </a:rPr>
-              <a:t>.e { color: hsl(0, 100%, 50%); }    /* hue, sat, lightness */</a:t>
-            </a:r>
-            <a:endParaRPr lang="en-US" sz="1250" dirty="0"/>
-          </a:p>
-        </p:txBody>
-      </p:sp>
-      <p:sp>
-        <p:nvSpPr>
-          <p:cNvPr id="6" name="Shape 4"/>
-          <p:cNvSpPr/>
-          <p:nvPr/>
-        </p:nvSpPr>
-        <p:spPr>
-          <a:xfrm>
-            <a:off x="530352" y="3869817"/>
-            <a:ext cx="11130991" cy="2457831"/>
-          </a:xfrm>
-          <a:prstGeom prst="roundRect">
-            <a:avLst>
-              <a:gd name="adj" fmla="val 2232"/>
-            </a:avLst>
-          </a:prstGeom>
-          <a:solidFill>
-            <a:srgbClr val="FFFFFF"/>
-          </a:solidFill>
-          <a:ln w="12700">
-            <a:solidFill>
-              <a:srgbClr val="E2E2EE"/>
-            </a:solidFill>
-            <a:prstDash val="solid"/>
-          </a:ln>
-          <a:effectLst>
-            <a:outerShdw sx="100000" sy="100000" kx="0" ky="0" algn="bl" rotWithShape="0" blurRad="101600" dist="38100" dir="5400000">
-              <a:srgbClr val="000000">
-                <a:alpha val="12000"/>
-              </a:srgbClr>
-            </a:outerShdw>
-          </a:effectLst>
-        </p:spPr>
-      </p:sp>
-      <p:pic>
-        <p:nvPicPr>
-          <p:cNvPr id="7" name="Image 0" descr="D:/GitHub/mern-web-book/docs/assets/img/lecture-05/color-values.png">    </p:cNvPr>
-          <p:cNvPicPr>
-            <a:picLocks noChangeAspect="1"/>
-          </p:cNvPicPr>
-          <p:nvPr/>
-        </p:nvPicPr>
-        <p:blipFill>
-          <a:blip r:embed="rId1"/>
-          <a:stretch>
-            <a:fillRect/>
-          </a:stretch>
-        </p:blipFill>
-        <p:spPr>
-          <a:xfrm>
-            <a:off x="3781381" y="3979545"/>
-            <a:ext cx="4628934" cy="2238375"/>
-          </a:xfrm>
-          <a:prstGeom prst="rect">
-            <a:avLst/>
-          </a:prstGeom>
-        </p:spPr>
-      </p:pic>
-      <p:sp>
-        <p:nvSpPr>
-          <p:cNvPr id="8" name="Text 5"/>
-          <p:cNvSpPr txBox="1"/>
-          <p:nvPr/>
-        </p:nvSpPr>
-        <p:spPr>
-          <a:xfrm>
-            <a:off x="640080" y="6446520"/>
-            <a:ext cx="8686800" cy="292608"/>
-          </a:xfrm>
-          <a:prstGeom prst="rect">
-            <a:avLst/>
-          </a:prstGeom>
-          <a:noFill/>
-          <a:ln/>
-        </p:spPr>
-        <p:txBody>
-          <a:bodyPr wrap="square" lIns="0" tIns="0" rIns="0" bIns="0" rtlCol="0" anchor="ctr"/>
-          <a:lstStyle/>
-          <a:p>
-            <a:pPr algn="l" indent="0" marL="0">
-              <a:buNone/>
-            </a:pPr>
-            <a:r>
-              <a:rPr lang="en-US" sz="900" dirty="0">
-                <a:solidFill>
-                  <a:srgbClr val="5D5D72"/>
-                </a:solidFill>
-                <a:latin typeface="Calibri" pitchFamily="34" charset="0"/>
-                <a:ea typeface="Calibri" pitchFamily="34" charset="-122"/>
-                <a:cs typeface="Calibri" pitchFamily="34" charset="-120"/>
-              </a:rPr>
-              <a:t>Usman Akram  •  COMSATS University Islamabad</a:t>
-            </a:r>
-            <a:endParaRPr lang="en-US" sz="900" dirty="0"/>
-          </a:p>
-        </p:txBody>
-      </p:sp>
-      <p:sp>
-        <p:nvSpPr>
-          <p:cNvPr id="9" name="Text 6"/>
-          <p:cNvSpPr txBox="1"/>
-          <p:nvPr/>
-        </p:nvSpPr>
-        <p:spPr>
-          <a:xfrm>
-            <a:off x="11155680" y="6446520"/>
-            <a:ext cx="457200" cy="292608"/>
-          </a:xfrm>
-          <a:prstGeom prst="rect">
-            <a:avLst/>
-          </a:prstGeom>
-          <a:noFill/>
-          <a:ln/>
-        </p:spPr>
-        <p:txBody>
-          <a:bodyPr wrap="square" lIns="0" tIns="0" rIns="0" bIns="0" rtlCol="0" anchor="ctr"/>
-          <a:lstStyle/>
-          <a:p>
-            <a:pPr algn="r" indent="0" marL="0">
-              <a:buNone/>
-            </a:pPr>
-            <a:r>
-              <a:rPr lang="en-US" sz="900" dirty="0">
-                <a:solidFill>
-                  <a:srgbClr val="5D5D72"/>
-                </a:solidFill>
-                <a:latin typeface="Calibri" pitchFamily="34" charset="0"/>
-                <a:ea typeface="Calibri" pitchFamily="34" charset="-122"/>
-                <a:cs typeface="Calibri" pitchFamily="34" charset="-120"/>
-              </a:rPr>
               <a:t>28</a:t>
             </a:r>
             <a:endParaRPr lang="en-US" sz="900" dirty="0"/>
@@ -15098,7 +16253,7 @@
                 <a:ea typeface="Calibri" pitchFamily="34" charset="-122"/>
                 <a:cs typeface="Calibri" pitchFamily="34" charset="-120"/>
               </a:rPr>
-              <a:t>FONTS</a:t>
+              <a:t>COLOUR</a:t>
             </a:r>
             <a:endParaRPr lang="en-US" sz="1300" dirty="0"/>
           </a:p>
@@ -15137,7 +16292,7 @@
                 <a:ea typeface="Cambria" pitchFamily="34" charset="-122"/>
                 <a:cs typeface="Cambria" pitchFamily="34" charset="-120"/>
               </a:rPr>
-              <a:t>Font Properties</a:t>
+              <a:t>Five Ways to Write a Colour</a:t>
             </a:r>
             <a:endParaRPr lang="en-US" sz="3400" dirty="0"/>
           </a:p>
@@ -15145,57 +16300,18 @@
       </p:sp>
       <p:sp>
         <p:nvSpPr>
-          <p:cNvPr id="4" name="Text 2"/>
-          <p:cNvSpPr txBox="1"/>
-          <p:nvPr/>
-        </p:nvSpPr>
-        <p:spPr>
-          <a:xfrm>
-            <a:off x="640080" y="1691640"/>
-            <a:ext cx="10911535" cy="411480"/>
-          </a:xfrm>
-          <a:prstGeom prst="rect">
-            <a:avLst/>
-          </a:prstGeom>
-          <a:noFill/>
-          <a:ln/>
-        </p:spPr>
-        <p:txBody>
-          <a:bodyPr wrap="square" lIns="0" tIns="0" rIns="0" bIns="0" rtlCol="0" anchor="ctr"/>
-          <a:lstStyle/>
-          <a:p>
-            <a:pPr indent="0" marL="0">
-              <a:buNone/>
-            </a:pPr>
-            <a:r>
-              <a:rPr lang="en-US" sz="1350" i="1" dirty="0">
-                <a:solidFill>
-                  <a:srgbClr val="5D5D72"/>
-                </a:solidFill>
-                <a:latin typeface="Calibri" pitchFamily="34" charset="0"/>
-                <a:ea typeface="Calibri" pitchFamily="34" charset="-122"/>
-                <a:cs typeface="Calibri" pitchFamily="34" charset="-120"/>
-              </a:rPr>
-              <a:t>font-family (a fallback list), font-size, font-weight, font-style — combined via the font shorthand too.</a:t>
-            </a:r>
-            <a:endParaRPr lang="en-US" sz="1350" dirty="0"/>
-          </a:p>
-        </p:txBody>
-      </p:sp>
-      <p:sp>
-        <p:nvSpPr>
-          <p:cNvPr id="5" name="Shape 3"/>
+          <p:cNvPr id="4" name="Shape 2"/>
           <p:cNvSpPr/>
           <p:nvPr/>
         </p:nvSpPr>
         <p:spPr>
           <a:xfrm>
-            <a:off x="640080" y="2240280"/>
-            <a:ext cx="10911535" cy="1977390"/>
+            <a:off x="640080" y="1965960"/>
+            <a:ext cx="10911535" cy="1739265"/>
           </a:xfrm>
           <a:prstGeom prst="roundRect">
             <a:avLst>
-              <a:gd name="adj" fmla="val 3699"/>
+              <a:gd name="adj" fmla="val 4206"/>
             </a:avLst>
           </a:prstGeom>
           <a:solidFill>
@@ -15206,14 +16322,14 @@
       </p:sp>
       <p:sp>
         <p:nvSpPr>
-          <p:cNvPr id="6" name="Text 4"/>
+          <p:cNvPr id="5" name="Text 3"/>
           <p:cNvSpPr txBox="1"/>
           <p:nvPr/>
         </p:nvSpPr>
         <p:spPr>
           <a:xfrm>
-            <a:off x="960120" y="2468880"/>
-            <a:ext cx="10271455" cy="1520190"/>
+            <a:off x="960120" y="2194560"/>
+            <a:ext cx="10271455" cy="1282065"/>
           </a:xfrm>
           <a:prstGeom prst="rect">
             <a:avLst/>
@@ -15240,7 +16356,7 @@
                 <a:ea typeface="Courier New" pitchFamily="34" charset="-122"/>
                 <a:cs typeface="Courier New" pitchFamily="34" charset="-120"/>
               </a:rPr>
-              <a:t>p {</a:t>
+              <a:t>.a { color: red; }                  /* named colour */</a:t>
             </a:r>
             <a:endParaRPr lang="en-US" sz="1250" dirty="0"/>
           </a:p>
@@ -15260,7 +16376,7 @@
                 <a:ea typeface="Courier New" pitchFamily="34" charset="-122"/>
                 <a:cs typeface="Courier New" pitchFamily="34" charset="-120"/>
               </a:rPr>
-              <a:t>  font-family: "Helvetica Neue", Arial, sans-serif;</a:t>
+              <a:t>.b { color: #ff0000; }              /* hex code */</a:t>
             </a:r>
             <a:endParaRPr lang="en-US" sz="1250" dirty="0"/>
           </a:p>
@@ -15280,7 +16396,7 @@
                 <a:ea typeface="Courier New" pitchFamily="34" charset="-122"/>
                 <a:cs typeface="Courier New" pitchFamily="34" charset="-120"/>
               </a:rPr>
-              <a:t>  font-size: 16px;</a:t>
+              <a:t>.c { color: rgb(255, 0, 0); }       /* red, green, blue */</a:t>
             </a:r>
             <a:endParaRPr lang="en-US" sz="1250" dirty="0"/>
           </a:p>
@@ -15300,7 +16416,7 @@
                 <a:ea typeface="Courier New" pitchFamily="34" charset="-122"/>
                 <a:cs typeface="Courier New" pitchFamily="34" charset="-120"/>
               </a:rPr>
-              <a:t>  font-weight: bold;</a:t>
+              <a:t>.d { color: rgba(255, 0, 0, 0.5); } /* rgb + alpha */</a:t>
             </a:r>
             <a:endParaRPr lang="en-US" sz="1250" dirty="0"/>
           </a:p>
@@ -15320,46 +16436,26 @@
                 <a:ea typeface="Courier New" pitchFamily="34" charset="-122"/>
                 <a:cs typeface="Courier New" pitchFamily="34" charset="-120"/>
               </a:rPr>
-              <a:t>  font-style: italic;</a:t>
+              <a:t>.e { color: hsl(0, 100%, 50%); }    /* hue, sat, lightness */</a:t>
             </a:r>
             <a:endParaRPr lang="en-US" sz="1250" dirty="0"/>
           </a:p>
-          <a:p>
-            <a:pPr indent="0" marL="0">
-              <a:lnSpc>
-                <a:spcPct val="125000"/>
-              </a:lnSpc>
-              <a:buNone/>
-            </a:pPr>
-            <a:r>
-              <a:rPr lang="en-US" sz="1250" dirty="0">
-                <a:solidFill>
-                  <a:srgbClr val="C9D3F5"/>
-                </a:solidFill>
-                <a:latin typeface="Courier New" pitchFamily="34" charset="0"/>
-                <a:ea typeface="Courier New" pitchFamily="34" charset="-122"/>
-                <a:cs typeface="Courier New" pitchFamily="34" charset="-120"/>
-              </a:rPr>
-              <a:t>}</a:t>
-            </a:r>
-            <a:endParaRPr lang="en-US" sz="1250" dirty="0"/>
-          </a:p>
-        </p:txBody>
-      </p:sp>
-      <p:sp>
-        <p:nvSpPr>
-          <p:cNvPr id="7" name="Shape 5"/>
+        </p:txBody>
+      </p:sp>
+      <p:sp>
+        <p:nvSpPr>
+          <p:cNvPr id="6" name="Shape 4"/>
           <p:cNvSpPr/>
           <p:nvPr/>
         </p:nvSpPr>
         <p:spPr>
           <a:xfrm>
-            <a:off x="530352" y="4382262"/>
-            <a:ext cx="11130991" cy="1945386"/>
+            <a:off x="530352" y="3869817"/>
+            <a:ext cx="11130991" cy="2457831"/>
           </a:xfrm>
           <a:prstGeom prst="roundRect">
             <a:avLst>
-              <a:gd name="adj" fmla="val 2820"/>
+              <a:gd name="adj" fmla="val 2232"/>
             </a:avLst>
           </a:prstGeom>
           <a:solidFill>
@@ -15382,7 +16478,7 @@
       </p:sp>
       <p:pic>
         <p:nvPicPr>
-          <p:cNvPr id="8" name="Image 0" descr="D:/GitHub/mern-web-book/docs/assets/img/lecture-05/font-properties.png">    </p:cNvPr>
+          <p:cNvPr id="7" name="Image 0" descr="D:/GitHub/mern-web-book/docs/assets/img/lecture-05/color-values.png">    </p:cNvPr>
           <p:cNvPicPr>
             <a:picLocks noChangeAspect="1"/>
           </p:cNvPicPr>
@@ -15396,8 +16492,8 @@
         </p:blipFill>
         <p:spPr>
           <a:xfrm>
-            <a:off x="640080" y="5049654"/>
-            <a:ext cx="10911535" cy="610602"/>
+            <a:off x="3781381" y="3979545"/>
+            <a:ext cx="4628934" cy="2238375"/>
           </a:xfrm>
           <a:prstGeom prst="rect">
             <a:avLst/>
@@ -15406,7 +16502,7 @@
       </p:pic>
       <p:sp>
         <p:nvSpPr>
-          <p:cNvPr id="9" name="Text 6"/>
+          <p:cNvPr id="8" name="Text 5"/>
           <p:cNvSpPr txBox="1"/>
           <p:nvPr/>
         </p:nvSpPr>
@@ -15445,7 +16541,7 @@
       </p:sp>
       <p:sp>
         <p:nvSpPr>
-          <p:cNvPr id="10" name="Text 7"/>
+          <p:cNvPr id="9" name="Text 6"/>
           <p:cNvSpPr txBox="1"/>
           <p:nvPr/>
         </p:nvSpPr>
@@ -16127,7 +17223,7 @@
                 <a:ea typeface="Calibri" pitchFamily="34" charset="-122"/>
                 <a:cs typeface="Calibri" pitchFamily="34" charset="-120"/>
               </a:rPr>
-              <a:t>TEXT</a:t>
+              <a:t>FONTS</a:t>
             </a:r>
             <a:endParaRPr lang="en-US" sz="1300" dirty="0"/>
           </a:p>
@@ -16166,7 +17262,7 @@
                 <a:ea typeface="Cambria" pitchFamily="34" charset="-122"/>
                 <a:cs typeface="Cambria" pitchFamily="34" charset="-120"/>
               </a:rPr>
-              <a:t>Text Properties</a:t>
+              <a:t>Font Properties</a:t>
             </a:r>
             <a:endParaRPr lang="en-US" sz="3400" dirty="0"/>
           </a:p>
@@ -16174,18 +17270,57 @@
       </p:sp>
       <p:sp>
         <p:nvSpPr>
-          <p:cNvPr id="4" name="Shape 2"/>
+          <p:cNvPr id="4" name="Text 2"/>
+          <p:cNvSpPr txBox="1"/>
+          <p:nvPr/>
+        </p:nvSpPr>
+        <p:spPr>
+          <a:xfrm>
+            <a:off x="640080" y="1691640"/>
+            <a:ext cx="10911535" cy="411480"/>
+          </a:xfrm>
+          <a:prstGeom prst="rect">
+            <a:avLst/>
+          </a:prstGeom>
+          <a:noFill/>
+          <a:ln/>
+        </p:spPr>
+        <p:txBody>
+          <a:bodyPr wrap="square" lIns="0" tIns="0" rIns="0" bIns="0" rtlCol="0" anchor="ctr"/>
+          <a:lstStyle/>
+          <a:p>
+            <a:pPr indent="0" marL="0">
+              <a:buNone/>
+            </a:pPr>
+            <a:r>
+              <a:rPr lang="en-US" sz="1350" i="1" dirty="0">
+                <a:solidFill>
+                  <a:srgbClr val="5D5D72"/>
+                </a:solidFill>
+                <a:latin typeface="Calibri" pitchFamily="34" charset="0"/>
+                <a:ea typeface="Calibri" pitchFamily="34" charset="-122"/>
+                <a:cs typeface="Calibri" pitchFamily="34" charset="-120"/>
+              </a:rPr>
+              <a:t>font-family (a fallback list), font-size, font-weight, font-style — combined via the font shorthand too.</a:t>
+            </a:r>
+            <a:endParaRPr lang="en-US" sz="1350" dirty="0"/>
+          </a:p>
+        </p:txBody>
+      </p:sp>
+      <p:sp>
+        <p:nvSpPr>
+          <p:cNvPr id="5" name="Shape 3"/>
           <p:cNvSpPr/>
           <p:nvPr/>
         </p:nvSpPr>
         <p:spPr>
           <a:xfrm>
-            <a:off x="640080" y="1965960"/>
-            <a:ext cx="10911535" cy="2215515"/>
+            <a:off x="640080" y="2240280"/>
+            <a:ext cx="10911535" cy="1977390"/>
           </a:xfrm>
           <a:prstGeom prst="roundRect">
             <a:avLst>
-              <a:gd name="adj" fmla="val 3302"/>
+              <a:gd name="adj" fmla="val 3699"/>
             </a:avLst>
           </a:prstGeom>
           <a:solidFill>
@@ -16196,14 +17331,14 @@
       </p:sp>
       <p:sp>
         <p:nvSpPr>
-          <p:cNvPr id="5" name="Text 3"/>
+          <p:cNvPr id="6" name="Text 4"/>
           <p:cNvSpPr txBox="1"/>
           <p:nvPr/>
         </p:nvSpPr>
         <p:spPr>
           <a:xfrm>
-            <a:off x="960120" y="2194560"/>
-            <a:ext cx="10271455" cy="1758315"/>
+            <a:off x="960120" y="2468880"/>
+            <a:ext cx="10271455" cy="1520190"/>
           </a:xfrm>
           <a:prstGeom prst="rect">
             <a:avLst/>
@@ -16250,7 +17385,7 @@
                 <a:ea typeface="Courier New" pitchFamily="34" charset="-122"/>
                 <a:cs typeface="Courier New" pitchFamily="34" charset="-120"/>
               </a:rPr>
-              <a:t>  text-align: center;</a:t>
+              <a:t>  font-family: "Helvetica Neue", Arial, sans-serif;</a:t>
             </a:r>
             <a:endParaRPr lang="en-US" sz="1250" dirty="0"/>
           </a:p>
@@ -16270,7 +17405,7 @@
                 <a:ea typeface="Courier New" pitchFamily="34" charset="-122"/>
                 <a:cs typeface="Courier New" pitchFamily="34" charset="-120"/>
               </a:rPr>
-              <a:t>  text-decoration: underline;</a:t>
+              <a:t>  font-size: 16px;</a:t>
             </a:r>
             <a:endParaRPr lang="en-US" sz="1250" dirty="0"/>
           </a:p>
@@ -16290,7 +17425,7 @@
                 <a:ea typeface="Courier New" pitchFamily="34" charset="-122"/>
                 <a:cs typeface="Courier New" pitchFamily="34" charset="-120"/>
               </a:rPr>
-              <a:t>  text-transform: uppercase;</a:t>
+              <a:t>  font-weight: bold;</a:t>
             </a:r>
             <a:endParaRPr lang="en-US" sz="1250" dirty="0"/>
           </a:p>
@@ -16310,7 +17445,7 @@
                 <a:ea typeface="Courier New" pitchFamily="34" charset="-122"/>
                 <a:cs typeface="Courier New" pitchFamily="34" charset="-120"/>
               </a:rPr>
-              <a:t>  line-height: 1.6;</a:t>
+              <a:t>  font-style: italic;</a:t>
             </a:r>
             <a:endParaRPr lang="en-US" sz="1250" dirty="0"/>
           </a:p>
@@ -16330,46 +17465,26 @@
                 <a:ea typeface="Courier New" pitchFamily="34" charset="-122"/>
                 <a:cs typeface="Courier New" pitchFamily="34" charset="-120"/>
               </a:rPr>
-              <a:t>  letter-spacing: 0.5px;</a:t>
+              <a:t>}</a:t>
             </a:r>
             <a:endParaRPr lang="en-US" sz="1250" dirty="0"/>
           </a:p>
-          <a:p>
-            <a:pPr indent="0" marL="0">
-              <a:lnSpc>
-                <a:spcPct val="125000"/>
-              </a:lnSpc>
-              <a:buNone/>
-            </a:pPr>
-            <a:r>
-              <a:rPr lang="en-US" sz="1250" dirty="0">
-                <a:solidFill>
-                  <a:srgbClr val="C9D3F5"/>
-                </a:solidFill>
-                <a:latin typeface="Courier New" pitchFamily="34" charset="0"/>
-                <a:ea typeface="Courier New" pitchFamily="34" charset="-122"/>
-                <a:cs typeface="Courier New" pitchFamily="34" charset="-120"/>
-              </a:rPr>
-              <a:t>}</a:t>
-            </a:r>
-            <a:endParaRPr lang="en-US" sz="1250" dirty="0"/>
-          </a:p>
-        </p:txBody>
-      </p:sp>
-      <p:sp>
-        <p:nvSpPr>
-          <p:cNvPr id="6" name="Shape 4"/>
+        </p:txBody>
+      </p:sp>
+      <p:sp>
+        <p:nvSpPr>
+          <p:cNvPr id="7" name="Shape 5"/>
           <p:cNvSpPr/>
           <p:nvPr/>
         </p:nvSpPr>
         <p:spPr>
           <a:xfrm>
-            <a:off x="530352" y="4346067"/>
-            <a:ext cx="11130991" cy="1981581"/>
+            <a:off x="530352" y="4382262"/>
+            <a:ext cx="11130991" cy="1945386"/>
           </a:xfrm>
           <a:prstGeom prst="roundRect">
             <a:avLst>
-              <a:gd name="adj" fmla="val 2769"/>
+              <a:gd name="adj" fmla="val 2820"/>
             </a:avLst>
           </a:prstGeom>
           <a:solidFill>
@@ -16392,7 +17507,7 @@
       </p:sp>
       <p:pic>
         <p:nvPicPr>
-          <p:cNvPr id="7" name="Image 0" descr="D:/GitHub/mern-web-book/docs/assets/img/lecture-05/text-properties.png">    </p:cNvPr>
+          <p:cNvPr id="8" name="Image 0" descr="D:/GitHub/mern-web-book/docs/assets/img/lecture-05/font-properties.png">    </p:cNvPr>
           <p:cNvPicPr>
             <a:picLocks noChangeAspect="1"/>
           </p:cNvPicPr>
@@ -16406,8 +17521,8 @@
         </p:blipFill>
         <p:spPr>
           <a:xfrm>
-            <a:off x="1700435" y="4455795"/>
-            <a:ext cx="8790826" cy="1762125"/>
+            <a:off x="640080" y="5049654"/>
+            <a:ext cx="10911535" cy="610602"/>
           </a:xfrm>
           <a:prstGeom prst="rect">
             <a:avLst/>
@@ -16416,7 +17531,7 @@
       </p:pic>
       <p:sp>
         <p:nvSpPr>
-          <p:cNvPr id="8" name="Text 5"/>
+          <p:cNvPr id="9" name="Text 6"/>
           <p:cNvSpPr txBox="1"/>
           <p:nvPr/>
         </p:nvSpPr>
@@ -16455,7 +17570,7 @@
       </p:sp>
       <p:sp>
         <p:nvSpPr>
-          <p:cNvPr id="9" name="Text 6"/>
+          <p:cNvPr id="10" name="Text 7"/>
           <p:cNvSpPr txBox="1"/>
           <p:nvPr/>
         </p:nvSpPr>
@@ -16557,7 +17672,7 @@
                 <a:ea typeface="Calibri" pitchFamily="34" charset="-122"/>
                 <a:cs typeface="Calibri" pitchFamily="34" charset="-120"/>
               </a:rPr>
-              <a:t>BACKGROUNDS</a:t>
+              <a:t>TEXT</a:t>
             </a:r>
             <a:endParaRPr lang="en-US" sz="1300" dirty="0"/>
           </a:p>
@@ -16596,7 +17711,7 @@
                 <a:ea typeface="Cambria" pitchFamily="34" charset="-122"/>
                 <a:cs typeface="Cambria" pitchFamily="34" charset="-120"/>
               </a:rPr>
-              <a:t>Background Properties</a:t>
+              <a:t>Text Properties</a:t>
             </a:r>
             <a:endParaRPr lang="en-US" sz="3400" dirty="0"/>
           </a:p>
@@ -16611,11 +17726,11 @@
         <p:spPr>
           <a:xfrm>
             <a:off x="640080" y="1965960"/>
-            <a:ext cx="10911535" cy="2415540"/>
+            <a:ext cx="10911535" cy="2215515"/>
           </a:xfrm>
           <a:prstGeom prst="roundRect">
             <a:avLst>
-              <a:gd name="adj" fmla="val 3028"/>
+              <a:gd name="adj" fmla="val 3302"/>
             </a:avLst>
           </a:prstGeom>
           <a:solidFill>
@@ -16633,7 +17748,7 @@
         <p:spPr>
           <a:xfrm>
             <a:off x="960120" y="2194560"/>
-            <a:ext cx="10271455" cy="1958340"/>
+            <a:ext cx="10271455" cy="1758315"/>
           </a:xfrm>
           <a:prstGeom prst="rect">
             <a:avLst/>
@@ -16652,7 +17767,7 @@
               <a:buNone/>
             </a:pPr>
             <a:r>
-              <a:rPr lang="en-US" sz="1400" dirty="0">
+              <a:rPr lang="en-US" sz="1250" dirty="0">
                 <a:solidFill>
                   <a:srgbClr val="C9D3F5"/>
                 </a:solidFill>
@@ -16660,9 +17775,9 @@
                 <a:ea typeface="Courier New" pitchFamily="34" charset="-122"/>
                 <a:cs typeface="Courier New" pitchFamily="34" charset="-120"/>
               </a:rPr>
-              <a:t>.card {</a:t>
-            </a:r>
-            <a:endParaRPr lang="en-US" sz="1400" dirty="0"/>
+              <a:t>p {</a:t>
+            </a:r>
+            <a:endParaRPr lang="en-US" sz="1250" dirty="0"/>
           </a:p>
           <a:p>
             <a:pPr indent="0" marL="0">
@@ -16672,7 +17787,7 @@
               <a:buNone/>
             </a:pPr>
             <a:r>
-              <a:rPr lang="en-US" sz="1400" dirty="0">
+              <a:rPr lang="en-US" sz="1250" dirty="0">
                 <a:solidFill>
                   <a:srgbClr val="C9D3F5"/>
                 </a:solidFill>
@@ -16680,9 +17795,9 @@
                 <a:ea typeface="Courier New" pitchFamily="34" charset="-122"/>
                 <a:cs typeface="Courier New" pitchFamily="34" charset="-120"/>
               </a:rPr>
-              <a:t>  background-color: #f5f5f5;</a:t>
-            </a:r>
-            <a:endParaRPr lang="en-US" sz="1400" dirty="0"/>
+              <a:t>  text-align: center;</a:t>
+            </a:r>
+            <a:endParaRPr lang="en-US" sz="1250" dirty="0"/>
           </a:p>
           <a:p>
             <a:pPr indent="0" marL="0">
@@ -16692,7 +17807,7 @@
               <a:buNone/>
             </a:pPr>
             <a:r>
-              <a:rPr lang="en-US" sz="1400" dirty="0">
+              <a:rPr lang="en-US" sz="1250" dirty="0">
                 <a:solidFill>
                   <a:srgbClr val="C9D3F5"/>
                 </a:solidFill>
@@ -16700,9 +17815,9 @@
                 <a:ea typeface="Courier New" pitchFamily="34" charset="-122"/>
                 <a:cs typeface="Courier New" pitchFamily="34" charset="-120"/>
               </a:rPr>
-              <a:t>  background-image: url("pattern.png");</a:t>
-            </a:r>
-            <a:endParaRPr lang="en-US" sz="1400" dirty="0"/>
+              <a:t>  text-decoration: underline;</a:t>
+            </a:r>
+            <a:endParaRPr lang="en-US" sz="1250" dirty="0"/>
           </a:p>
           <a:p>
             <a:pPr indent="0" marL="0">
@@ -16712,7 +17827,7 @@
               <a:buNone/>
             </a:pPr>
             <a:r>
-              <a:rPr lang="en-US" sz="1400" dirty="0">
+              <a:rPr lang="en-US" sz="1250" dirty="0">
                 <a:solidFill>
                   <a:srgbClr val="C9D3F5"/>
                 </a:solidFill>
@@ -16720,9 +17835,9 @@
                 <a:ea typeface="Courier New" pitchFamily="34" charset="-122"/>
                 <a:cs typeface="Courier New" pitchFamily="34" charset="-120"/>
               </a:rPr>
-              <a:t>  background-repeat: no-repeat;</a:t>
-            </a:r>
-            <a:endParaRPr lang="en-US" sz="1400" dirty="0"/>
+              <a:t>  text-transform: uppercase;</a:t>
+            </a:r>
+            <a:endParaRPr lang="en-US" sz="1250" dirty="0"/>
           </a:p>
           <a:p>
             <a:pPr indent="0" marL="0">
@@ -16732,7 +17847,7 @@
               <a:buNone/>
             </a:pPr>
             <a:r>
-              <a:rPr lang="en-US" sz="1400" dirty="0">
+              <a:rPr lang="en-US" sz="1250" dirty="0">
                 <a:solidFill>
                   <a:srgbClr val="C9D3F5"/>
                 </a:solidFill>
@@ -16740,9 +17855,9 @@
                 <a:ea typeface="Courier New" pitchFamily="34" charset="-122"/>
                 <a:cs typeface="Courier New" pitchFamily="34" charset="-120"/>
               </a:rPr>
-              <a:t>  background-position: center;</a:t>
-            </a:r>
-            <a:endParaRPr lang="en-US" sz="1400" dirty="0"/>
+              <a:t>  line-height: 1.6;</a:t>
+            </a:r>
+            <a:endParaRPr lang="en-US" sz="1250" dirty="0"/>
           </a:p>
           <a:p>
             <a:pPr indent="0" marL="0">
@@ -16752,7 +17867,7 @@
               <a:buNone/>
             </a:pPr>
             <a:r>
-              <a:rPr lang="en-US" sz="1400" dirty="0">
+              <a:rPr lang="en-US" sz="1250" dirty="0">
                 <a:solidFill>
                   <a:srgbClr val="C9D3F5"/>
                 </a:solidFill>
@@ -16760,9 +17875,9 @@
                 <a:ea typeface="Courier New" pitchFamily="34" charset="-122"/>
                 <a:cs typeface="Courier New" pitchFamily="34" charset="-120"/>
               </a:rPr>
-              <a:t>  background-size: cover;</a:t>
-            </a:r>
-            <a:endParaRPr lang="en-US" sz="1400" dirty="0"/>
+              <a:t>  letter-spacing: 0.5px;</a:t>
+            </a:r>
+            <a:endParaRPr lang="en-US" sz="1250" dirty="0"/>
           </a:p>
           <a:p>
             <a:pPr indent="0" marL="0">
@@ -16772,7 +17887,7 @@
               <a:buNone/>
             </a:pPr>
             <a:r>
-              <a:rPr lang="en-US" sz="1400" dirty="0">
+              <a:rPr lang="en-US" sz="1250" dirty="0">
                 <a:solidFill>
                   <a:srgbClr val="C9D3F5"/>
                 </a:solidFill>
@@ -16782,20 +17897,78 @@
               </a:rPr>
               <a:t>}</a:t>
             </a:r>
-            <a:endParaRPr lang="en-US" sz="1400" dirty="0"/>
-          </a:p>
-        </p:txBody>
-      </p:sp>
-      <p:sp>
-        <p:nvSpPr>
-          <p:cNvPr id="6" name="Text 4"/>
+            <a:endParaRPr lang="en-US" sz="1250" dirty="0"/>
+          </a:p>
+        </p:txBody>
+      </p:sp>
+      <p:sp>
+        <p:nvSpPr>
+          <p:cNvPr id="6" name="Shape 4"/>
+          <p:cNvSpPr/>
+          <p:nvPr/>
+        </p:nvSpPr>
+        <p:spPr>
+          <a:xfrm>
+            <a:off x="530352" y="4346067"/>
+            <a:ext cx="11130991" cy="1981581"/>
+          </a:xfrm>
+          <a:prstGeom prst="roundRect">
+            <a:avLst>
+              <a:gd name="adj" fmla="val 2769"/>
+            </a:avLst>
+          </a:prstGeom>
+          <a:solidFill>
+            <a:srgbClr val="FFFFFF"/>
+          </a:solidFill>
+          <a:ln w="12700">
+            <a:solidFill>
+              <a:srgbClr val="E2E2EE"/>
+            </a:solidFill>
+            <a:prstDash val="solid"/>
+          </a:ln>
+          <a:effectLst>
+            <a:outerShdw sx="100000" sy="100000" kx="0" ky="0" algn="bl" rotWithShape="0" blurRad="101600" dist="38100" dir="5400000">
+              <a:srgbClr val="000000">
+                <a:alpha val="12000"/>
+              </a:srgbClr>
+            </a:outerShdw>
+          </a:effectLst>
+        </p:spPr>
+      </p:sp>
+      <p:pic>
+        <p:nvPicPr>
+          <p:cNvPr id="7" name="Image 0" descr="D:/GitHub/mern-web-book/docs/assets/img/lecture-05/text-properties.png">    </p:cNvPr>
+          <p:cNvPicPr>
+            <a:picLocks noChangeAspect="1"/>
+          </p:cNvPicPr>
+          <p:nvPr/>
+        </p:nvPicPr>
+        <p:blipFill>
+          <a:blip r:embed="rId1"/>
+          <a:stretch>
+            <a:fillRect/>
+          </a:stretch>
+        </p:blipFill>
+        <p:spPr>
+          <a:xfrm>
+            <a:off x="1700435" y="4455795"/>
+            <a:ext cx="8790826" cy="1762125"/>
+          </a:xfrm>
+          <a:prstGeom prst="rect">
+            <a:avLst/>
+          </a:prstGeom>
+        </p:spPr>
+      </p:pic>
+      <p:sp>
+        <p:nvSpPr>
+          <p:cNvPr id="8" name="Text 5"/>
           <p:cNvSpPr txBox="1"/>
           <p:nvPr/>
         </p:nvSpPr>
         <p:spPr>
           <a:xfrm>
-            <a:off x="640080" y="4610100"/>
-            <a:ext cx="10911535" cy="1653540"/>
+            <a:off x="640080" y="6446520"/>
+            <a:ext cx="8686800" cy="292608"/>
           </a:xfrm>
           <a:prstGeom prst="rect">
             <a:avLst/>
@@ -16804,60 +17977,21 @@
           <a:ln/>
         </p:spPr>
         <p:txBody>
-          <a:bodyPr wrap="square" lIns="0" tIns="0" rIns="0" bIns="0" rtlCol="0" anchor="t"/>
-          <a:lstStyle/>
-          <a:p>
-            <a:pPr indent="0" marL="0">
-              <a:buNone/>
-            </a:pPr>
-            <a:r>
-              <a:rPr lang="en-US" sz="1300" dirty="0">
-                <a:solidFill>
-                  <a:srgbClr val="26262F"/>
+          <a:bodyPr wrap="square" lIns="0" tIns="0" rIns="0" bIns="0" rtlCol="0" anchor="ctr"/>
+          <a:lstStyle/>
+          <a:p>
+            <a:pPr algn="l" indent="0" marL="0">
+              <a:buNone/>
+            </a:pPr>
+            <a:r>
+              <a:rPr lang="en-US" sz="900" dirty="0">
+                <a:solidFill>
+                  <a:srgbClr val="5D5D72"/>
                 </a:solidFill>
                 <a:latin typeface="Calibri" pitchFamily="34" charset="0"/>
                 <a:ea typeface="Calibri" pitchFamily="34" charset="-122"/>
                 <a:cs typeface="Calibri" pitchFamily="34" charset="-120"/>
               </a:rPr>
-              <a:t>A background shorthand combines several of these into one declaration, just like font does.</a:t>
-            </a:r>
-            <a:endParaRPr lang="en-US" sz="1300" dirty="0"/>
-          </a:p>
-        </p:txBody>
-      </p:sp>
-      <p:sp>
-        <p:nvSpPr>
-          <p:cNvPr id="7" name="Text 5"/>
-          <p:cNvSpPr txBox="1"/>
-          <p:nvPr/>
-        </p:nvSpPr>
-        <p:spPr>
-          <a:xfrm>
-            <a:off x="640080" y="6446520"/>
-            <a:ext cx="8686800" cy="292608"/>
-          </a:xfrm>
-          <a:prstGeom prst="rect">
-            <a:avLst/>
-          </a:prstGeom>
-          <a:noFill/>
-          <a:ln/>
-        </p:spPr>
-        <p:txBody>
-          <a:bodyPr wrap="square" lIns="0" tIns="0" rIns="0" bIns="0" rtlCol="0" anchor="ctr"/>
-          <a:lstStyle/>
-          <a:p>
-            <a:pPr algn="l" indent="0" marL="0">
-              <a:buNone/>
-            </a:pPr>
-            <a:r>
-              <a:rPr lang="en-US" sz="900" dirty="0">
-                <a:solidFill>
-                  <a:srgbClr val="5D5D72"/>
-                </a:solidFill>
-                <a:latin typeface="Calibri" pitchFamily="34" charset="0"/>
-                <a:ea typeface="Calibri" pitchFamily="34" charset="-122"/>
-                <a:cs typeface="Calibri" pitchFamily="34" charset="-120"/>
-              </a:rPr>
               <a:t>Usman Akram  •  COMSATS University Islamabad</a:t>
             </a:r>
             <a:endParaRPr lang="en-US" sz="900" dirty="0"/>
@@ -16866,7 +18000,7 @@
       </p:sp>
       <p:sp>
         <p:nvSpPr>
-          <p:cNvPr id="8" name="Text 6"/>
+          <p:cNvPr id="9" name="Text 6"/>
           <p:cNvSpPr txBox="1"/>
           <p:nvPr/>
         </p:nvSpPr>
@@ -16914,6 +18048,417 @@
 <file path=ppt/slides/slide32.xml><?xml version="1.0" encoding="utf-8"?>
 <p:sld xmlns:a="http://schemas.openxmlformats.org/drawingml/2006/main" xmlns:r="http://schemas.openxmlformats.org/officeDocument/2006/relationships" xmlns:p="http://schemas.openxmlformats.org/presentationml/2006/main">
   <p:cSld name="Slide 32">
+    <p:bg>
+      <p:bgPr>
+        <a:solidFill>
+          <a:srgbClr val="FFFFFF"/>
+        </a:solidFill>
+      </p:bgPr>
+    </p:bg>
+    <p:spTree>
+      <p:nvGrpSpPr>
+        <p:cNvPr id="1" name=""/>
+        <p:cNvGrpSpPr/>
+        <p:nvPr/>
+      </p:nvGrpSpPr>
+      <p:grpSpPr>
+        <a:xfrm>
+          <a:off x="0" y="0"/>
+          <a:ext cx="0" cy="0"/>
+          <a:chOff x="0" y="0"/>
+          <a:chExt cx="0" cy="0"/>
+        </a:xfrm>
+      </p:grpSpPr>
+      <p:sp>
+        <p:nvSpPr>
+          <p:cNvPr id="2" name="Text 0"/>
+          <p:cNvSpPr txBox="1"/>
+          <p:nvPr/>
+        </p:nvSpPr>
+        <p:spPr>
+          <a:xfrm>
+            <a:off x="640080" y="457200"/>
+            <a:ext cx="10058400" cy="365760"/>
+          </a:xfrm>
+          <a:prstGeom prst="rect">
+            <a:avLst/>
+          </a:prstGeom>
+          <a:noFill/>
+          <a:ln/>
+        </p:spPr>
+        <p:txBody>
+          <a:bodyPr wrap="square" lIns="0" tIns="0" rIns="0" bIns="0" rtlCol="0" anchor="ctr"/>
+          <a:lstStyle/>
+          <a:p>
+            <a:pPr algn="l" indent="0" marL="0">
+              <a:buNone/>
+            </a:pPr>
+            <a:r>
+              <a:rPr lang="en-US" sz="1300" b="1" spc="300" kern="0" dirty="0">
+                <a:solidFill>
+                  <a:srgbClr val="FF8A3D"/>
+                </a:solidFill>
+                <a:latin typeface="Calibri" pitchFamily="34" charset="0"/>
+                <a:ea typeface="Calibri" pitchFamily="34" charset="-122"/>
+                <a:cs typeface="Calibri" pitchFamily="34" charset="-120"/>
+              </a:rPr>
+              <a:t>BACKGROUNDS</a:t>
+            </a:r>
+            <a:endParaRPr lang="en-US" sz="1300" dirty="0"/>
+          </a:p>
+        </p:txBody>
+      </p:sp>
+      <p:sp>
+        <p:nvSpPr>
+          <p:cNvPr id="3" name="Text 1"/>
+          <p:cNvSpPr txBox="1"/>
+          <p:nvPr/>
+        </p:nvSpPr>
+        <p:spPr>
+          <a:xfrm>
+            <a:off x="640080" y="841248"/>
+            <a:ext cx="10881360" cy="914400"/>
+          </a:xfrm>
+          <a:prstGeom prst="rect">
+            <a:avLst/>
+          </a:prstGeom>
+          <a:noFill/>
+          <a:ln/>
+        </p:spPr>
+        <p:txBody>
+          <a:bodyPr wrap="square" lIns="0" tIns="0" rIns="0" bIns="0" rtlCol="0" anchor="ctr"/>
+          <a:lstStyle/>
+          <a:p>
+            <a:pPr algn="l" indent="0" marL="0">
+              <a:buNone/>
+            </a:pPr>
+            <a:r>
+              <a:rPr lang="en-US" sz="3400" b="1" dirty="0">
+                <a:solidFill>
+                  <a:srgbClr val="2B2B7A"/>
+                </a:solidFill>
+                <a:latin typeface="Cambria" pitchFamily="34" charset="0"/>
+                <a:ea typeface="Cambria" pitchFamily="34" charset="-122"/>
+                <a:cs typeface="Cambria" pitchFamily="34" charset="-120"/>
+              </a:rPr>
+              <a:t>Background Properties</a:t>
+            </a:r>
+            <a:endParaRPr lang="en-US" sz="3400" dirty="0"/>
+          </a:p>
+        </p:txBody>
+      </p:sp>
+      <p:sp>
+        <p:nvSpPr>
+          <p:cNvPr id="4" name="Shape 2"/>
+          <p:cNvSpPr/>
+          <p:nvPr/>
+        </p:nvSpPr>
+        <p:spPr>
+          <a:xfrm>
+            <a:off x="640080" y="1965960"/>
+            <a:ext cx="10911535" cy="2415540"/>
+          </a:xfrm>
+          <a:prstGeom prst="roundRect">
+            <a:avLst>
+              <a:gd name="adj" fmla="val 3028"/>
+            </a:avLst>
+          </a:prstGeom>
+          <a:solidFill>
+            <a:srgbClr val="1E1E4C"/>
+          </a:solidFill>
+          <a:ln/>
+        </p:spPr>
+      </p:sp>
+      <p:sp>
+        <p:nvSpPr>
+          <p:cNvPr id="5" name="Text 3"/>
+          <p:cNvSpPr txBox="1"/>
+          <p:nvPr/>
+        </p:nvSpPr>
+        <p:spPr>
+          <a:xfrm>
+            <a:off x="960120" y="2194560"/>
+            <a:ext cx="10271455" cy="1958340"/>
+          </a:xfrm>
+          <a:prstGeom prst="rect">
+            <a:avLst/>
+          </a:prstGeom>
+          <a:noFill/>
+          <a:ln/>
+        </p:spPr>
+        <p:txBody>
+          <a:bodyPr wrap="square" lIns="0" tIns="0" rIns="0" bIns="0" rtlCol="0" anchor="t"/>
+          <a:lstStyle/>
+          <a:p>
+            <a:pPr indent="0" marL="0">
+              <a:lnSpc>
+                <a:spcPct val="125000"/>
+              </a:lnSpc>
+              <a:buNone/>
+            </a:pPr>
+            <a:r>
+              <a:rPr lang="en-US" sz="1400" dirty="0">
+                <a:solidFill>
+                  <a:srgbClr val="C9D3F5"/>
+                </a:solidFill>
+                <a:latin typeface="Courier New" pitchFamily="34" charset="0"/>
+                <a:ea typeface="Courier New" pitchFamily="34" charset="-122"/>
+                <a:cs typeface="Courier New" pitchFamily="34" charset="-120"/>
+              </a:rPr>
+              <a:t>.card {</a:t>
+            </a:r>
+            <a:endParaRPr lang="en-US" sz="1400" dirty="0"/>
+          </a:p>
+          <a:p>
+            <a:pPr indent="0" marL="0">
+              <a:lnSpc>
+                <a:spcPct val="125000"/>
+              </a:lnSpc>
+              <a:buNone/>
+            </a:pPr>
+            <a:r>
+              <a:rPr lang="en-US" sz="1400" dirty="0">
+                <a:solidFill>
+                  <a:srgbClr val="C9D3F5"/>
+                </a:solidFill>
+                <a:latin typeface="Courier New" pitchFamily="34" charset="0"/>
+                <a:ea typeface="Courier New" pitchFamily="34" charset="-122"/>
+                <a:cs typeface="Courier New" pitchFamily="34" charset="-120"/>
+              </a:rPr>
+              <a:t>  background-color: #f5f5f5;</a:t>
+            </a:r>
+            <a:endParaRPr lang="en-US" sz="1400" dirty="0"/>
+          </a:p>
+          <a:p>
+            <a:pPr indent="0" marL="0">
+              <a:lnSpc>
+                <a:spcPct val="125000"/>
+              </a:lnSpc>
+              <a:buNone/>
+            </a:pPr>
+            <a:r>
+              <a:rPr lang="en-US" sz="1400" dirty="0">
+                <a:solidFill>
+                  <a:srgbClr val="C9D3F5"/>
+                </a:solidFill>
+                <a:latin typeface="Courier New" pitchFamily="34" charset="0"/>
+                <a:ea typeface="Courier New" pitchFamily="34" charset="-122"/>
+                <a:cs typeface="Courier New" pitchFamily="34" charset="-120"/>
+              </a:rPr>
+              <a:t>  background-image: url("pattern.png");</a:t>
+            </a:r>
+            <a:endParaRPr lang="en-US" sz="1400" dirty="0"/>
+          </a:p>
+          <a:p>
+            <a:pPr indent="0" marL="0">
+              <a:lnSpc>
+                <a:spcPct val="125000"/>
+              </a:lnSpc>
+              <a:buNone/>
+            </a:pPr>
+            <a:r>
+              <a:rPr lang="en-US" sz="1400" dirty="0">
+                <a:solidFill>
+                  <a:srgbClr val="C9D3F5"/>
+                </a:solidFill>
+                <a:latin typeface="Courier New" pitchFamily="34" charset="0"/>
+                <a:ea typeface="Courier New" pitchFamily="34" charset="-122"/>
+                <a:cs typeface="Courier New" pitchFamily="34" charset="-120"/>
+              </a:rPr>
+              <a:t>  background-repeat: no-repeat;</a:t>
+            </a:r>
+            <a:endParaRPr lang="en-US" sz="1400" dirty="0"/>
+          </a:p>
+          <a:p>
+            <a:pPr indent="0" marL="0">
+              <a:lnSpc>
+                <a:spcPct val="125000"/>
+              </a:lnSpc>
+              <a:buNone/>
+            </a:pPr>
+            <a:r>
+              <a:rPr lang="en-US" sz="1400" dirty="0">
+                <a:solidFill>
+                  <a:srgbClr val="C9D3F5"/>
+                </a:solidFill>
+                <a:latin typeface="Courier New" pitchFamily="34" charset="0"/>
+                <a:ea typeface="Courier New" pitchFamily="34" charset="-122"/>
+                <a:cs typeface="Courier New" pitchFamily="34" charset="-120"/>
+              </a:rPr>
+              <a:t>  background-position: center;</a:t>
+            </a:r>
+            <a:endParaRPr lang="en-US" sz="1400" dirty="0"/>
+          </a:p>
+          <a:p>
+            <a:pPr indent="0" marL="0">
+              <a:lnSpc>
+                <a:spcPct val="125000"/>
+              </a:lnSpc>
+              <a:buNone/>
+            </a:pPr>
+            <a:r>
+              <a:rPr lang="en-US" sz="1400" dirty="0">
+                <a:solidFill>
+                  <a:srgbClr val="C9D3F5"/>
+                </a:solidFill>
+                <a:latin typeface="Courier New" pitchFamily="34" charset="0"/>
+                <a:ea typeface="Courier New" pitchFamily="34" charset="-122"/>
+                <a:cs typeface="Courier New" pitchFamily="34" charset="-120"/>
+              </a:rPr>
+              <a:t>  background-size: cover;</a:t>
+            </a:r>
+            <a:endParaRPr lang="en-US" sz="1400" dirty="0"/>
+          </a:p>
+          <a:p>
+            <a:pPr indent="0" marL="0">
+              <a:lnSpc>
+                <a:spcPct val="125000"/>
+              </a:lnSpc>
+              <a:buNone/>
+            </a:pPr>
+            <a:r>
+              <a:rPr lang="en-US" sz="1400" dirty="0">
+                <a:solidFill>
+                  <a:srgbClr val="C9D3F5"/>
+                </a:solidFill>
+                <a:latin typeface="Courier New" pitchFamily="34" charset="0"/>
+                <a:ea typeface="Courier New" pitchFamily="34" charset="-122"/>
+                <a:cs typeface="Courier New" pitchFamily="34" charset="-120"/>
+              </a:rPr>
+              <a:t>}</a:t>
+            </a:r>
+            <a:endParaRPr lang="en-US" sz="1400" dirty="0"/>
+          </a:p>
+        </p:txBody>
+      </p:sp>
+      <p:sp>
+        <p:nvSpPr>
+          <p:cNvPr id="6" name="Text 4"/>
+          <p:cNvSpPr txBox="1"/>
+          <p:nvPr/>
+        </p:nvSpPr>
+        <p:spPr>
+          <a:xfrm>
+            <a:off x="640080" y="4610100"/>
+            <a:ext cx="10911535" cy="1653540"/>
+          </a:xfrm>
+          <a:prstGeom prst="rect">
+            <a:avLst/>
+          </a:prstGeom>
+          <a:noFill/>
+          <a:ln/>
+        </p:spPr>
+        <p:txBody>
+          <a:bodyPr wrap="square" lIns="0" tIns="0" rIns="0" bIns="0" rtlCol="0" anchor="t"/>
+          <a:lstStyle/>
+          <a:p>
+            <a:pPr indent="0" marL="0">
+              <a:buNone/>
+            </a:pPr>
+            <a:r>
+              <a:rPr lang="en-US" sz="1300" dirty="0">
+                <a:solidFill>
+                  <a:srgbClr val="26262F"/>
+                </a:solidFill>
+                <a:latin typeface="Calibri" pitchFamily="34" charset="0"/>
+                <a:ea typeface="Calibri" pitchFamily="34" charset="-122"/>
+                <a:cs typeface="Calibri" pitchFamily="34" charset="-120"/>
+              </a:rPr>
+              <a:t>A background shorthand combines several of these into one declaration, just like font does.</a:t>
+            </a:r>
+            <a:endParaRPr lang="en-US" sz="1300" dirty="0"/>
+          </a:p>
+        </p:txBody>
+      </p:sp>
+      <p:sp>
+        <p:nvSpPr>
+          <p:cNvPr id="7" name="Text 5"/>
+          <p:cNvSpPr txBox="1"/>
+          <p:nvPr/>
+        </p:nvSpPr>
+        <p:spPr>
+          <a:xfrm>
+            <a:off x="640080" y="6446520"/>
+            <a:ext cx="8686800" cy="292608"/>
+          </a:xfrm>
+          <a:prstGeom prst="rect">
+            <a:avLst/>
+          </a:prstGeom>
+          <a:noFill/>
+          <a:ln/>
+        </p:spPr>
+        <p:txBody>
+          <a:bodyPr wrap="square" lIns="0" tIns="0" rIns="0" bIns="0" rtlCol="0" anchor="ctr"/>
+          <a:lstStyle/>
+          <a:p>
+            <a:pPr algn="l" indent="0" marL="0">
+              <a:buNone/>
+            </a:pPr>
+            <a:r>
+              <a:rPr lang="en-US" sz="900" dirty="0">
+                <a:solidFill>
+                  <a:srgbClr val="5D5D72"/>
+                </a:solidFill>
+                <a:latin typeface="Calibri" pitchFamily="34" charset="0"/>
+                <a:ea typeface="Calibri" pitchFamily="34" charset="-122"/>
+                <a:cs typeface="Calibri" pitchFamily="34" charset="-120"/>
+              </a:rPr>
+              <a:t>Usman Akram  •  COMSATS University Islamabad</a:t>
+            </a:r>
+            <a:endParaRPr lang="en-US" sz="900" dirty="0"/>
+          </a:p>
+        </p:txBody>
+      </p:sp>
+      <p:sp>
+        <p:nvSpPr>
+          <p:cNvPr id="8" name="Text 6"/>
+          <p:cNvSpPr txBox="1"/>
+          <p:nvPr/>
+        </p:nvSpPr>
+        <p:spPr>
+          <a:xfrm>
+            <a:off x="11155680" y="6446520"/>
+            <a:ext cx="457200" cy="292608"/>
+          </a:xfrm>
+          <a:prstGeom prst="rect">
+            <a:avLst/>
+          </a:prstGeom>
+          <a:noFill/>
+          <a:ln/>
+        </p:spPr>
+        <p:txBody>
+          <a:bodyPr wrap="square" lIns="0" tIns="0" rIns="0" bIns="0" rtlCol="0" anchor="ctr"/>
+          <a:lstStyle/>
+          <a:p>
+            <a:pPr algn="r" indent="0" marL="0">
+              <a:buNone/>
+            </a:pPr>
+            <a:r>
+              <a:rPr lang="en-US" sz="900" dirty="0">
+                <a:solidFill>
+                  <a:srgbClr val="5D5D72"/>
+                </a:solidFill>
+                <a:latin typeface="Calibri" pitchFamily="34" charset="0"/>
+                <a:ea typeface="Calibri" pitchFamily="34" charset="-122"/>
+                <a:cs typeface="Calibri" pitchFamily="34" charset="-120"/>
+              </a:rPr>
+              <a:t>32</a:t>
+            </a:r>
+            <a:endParaRPr lang="en-US" sz="900" dirty="0"/>
+          </a:p>
+        </p:txBody>
+      </p:sp>
+    </p:spTree>
+  </p:cSld>
+  <p:clrMapOvr>
+    <a:masterClrMapping/>
+  </p:clrMapOvr>
+</p:sld>
+</file>
+
+<file path=ppt/slides/slide33.xml><?xml version="1.0" encoding="utf-8"?>
+<p:sld xmlns:a="http://schemas.openxmlformats.org/drawingml/2006/main" xmlns:r="http://schemas.openxmlformats.org/officeDocument/2006/relationships" xmlns:p="http://schemas.openxmlformats.org/presentationml/2006/main">
+  <p:cSld name="Slide 33">
     <p:bg>
       <p:bgPr>
         <a:solidFill>
@@ -17081,7 +18626,7 @@
         <p:spPr>
           <a:xfrm>
             <a:off x="1463040" y="2194560"/>
-            <a:ext cx="10058400" cy="640080"/>
+            <a:ext cx="10058400" cy="624840"/>
           </a:xfrm>
           <a:prstGeom prst="rect">
             <a:avLst/>
@@ -17119,7 +18664,7 @@
         </p:nvSpPr>
         <p:spPr>
           <a:xfrm>
-            <a:off x="822960" y="2971800"/>
+            <a:off x="822960" y="2956560"/>
             <a:ext cx="438912" cy="438912"/>
           </a:xfrm>
           <a:prstGeom prst="ellipse">
@@ -17139,7 +18684,7 @@
         </p:nvSpPr>
         <p:spPr>
           <a:xfrm>
-            <a:off x="822960" y="2971800"/>
+            <a:off x="822960" y="2956560"/>
             <a:ext cx="438912" cy="438912"/>
           </a:xfrm>
           <a:prstGeom prst="rect">
@@ -17178,8 +18723,8 @@
         </p:nvSpPr>
         <p:spPr>
           <a:xfrm>
-            <a:off x="1463040" y="2880360"/>
-            <a:ext cx="10058400" cy="640080"/>
+            <a:off x="1463040" y="2865120"/>
+            <a:ext cx="10058400" cy="624840"/>
           </a:xfrm>
           <a:prstGeom prst="rect">
             <a:avLst/>
@@ -17217,7 +18762,7 @@
         </p:nvSpPr>
         <p:spPr>
           <a:xfrm>
-            <a:off x="822960" y="3657600"/>
+            <a:off x="822960" y="3627120"/>
             <a:ext cx="438912" cy="438912"/>
           </a:xfrm>
           <a:prstGeom prst="ellipse">
@@ -17237,7 +18782,7 @@
         </p:nvSpPr>
         <p:spPr>
           <a:xfrm>
-            <a:off x="822960" y="3657600"/>
+            <a:off x="822960" y="3627120"/>
             <a:ext cx="438912" cy="438912"/>
           </a:xfrm>
           <a:prstGeom prst="rect">
@@ -17276,8 +18821,8 @@
         </p:nvSpPr>
         <p:spPr>
           <a:xfrm>
-            <a:off x="1463040" y="3566160"/>
-            <a:ext cx="10058400" cy="640080"/>
+            <a:off x="1463040" y="3535680"/>
+            <a:ext cx="10058400" cy="624840"/>
           </a:xfrm>
           <a:prstGeom prst="rect">
             <a:avLst/>
@@ -17315,7 +18860,7 @@
         </p:nvSpPr>
         <p:spPr>
           <a:xfrm>
-            <a:off x="822960" y="4343400"/>
+            <a:off x="822960" y="4297680"/>
             <a:ext cx="438912" cy="438912"/>
           </a:xfrm>
           <a:prstGeom prst="ellipse">
@@ -17335,7 +18880,7 @@
         </p:nvSpPr>
         <p:spPr>
           <a:xfrm>
-            <a:off x="822960" y="4343400"/>
+            <a:off x="822960" y="4297680"/>
             <a:ext cx="438912" cy="438912"/>
           </a:xfrm>
           <a:prstGeom prst="rect">
@@ -17374,8 +18919,8 @@
         </p:nvSpPr>
         <p:spPr>
           <a:xfrm>
-            <a:off x="1463040" y="4251960"/>
-            <a:ext cx="10058400" cy="640080"/>
+            <a:off x="1463040" y="4206240"/>
+            <a:ext cx="10058400" cy="624840"/>
           </a:xfrm>
           <a:prstGeom prst="rect">
             <a:avLst/>
@@ -17413,7 +18958,7 @@
         </p:nvSpPr>
         <p:spPr>
           <a:xfrm>
-            <a:off x="822960" y="5029200"/>
+            <a:off x="822960" y="4968240"/>
             <a:ext cx="438912" cy="438912"/>
           </a:xfrm>
           <a:prstGeom prst="ellipse">
@@ -17433,7 +18978,7 @@
         </p:nvSpPr>
         <p:spPr>
           <a:xfrm>
-            <a:off x="822960" y="5029200"/>
+            <a:off x="822960" y="4968240"/>
             <a:ext cx="438912" cy="438912"/>
           </a:xfrm>
           <a:prstGeom prst="rect">
@@ -17472,8 +19017,8 @@
         </p:nvSpPr>
         <p:spPr>
           <a:xfrm>
-            <a:off x="1463040" y="4937760"/>
-            <a:ext cx="10058400" cy="640080"/>
+            <a:off x="1463040" y="4876800"/>
+            <a:ext cx="10058400" cy="624840"/>
           </a:xfrm>
           <a:prstGeom prst="rect">
             <a:avLst/>
@@ -17511,7 +19056,7 @@
         </p:nvSpPr>
         <p:spPr>
           <a:xfrm>
-            <a:off x="822960" y="5715000"/>
+            <a:off x="822960" y="5638800"/>
             <a:ext cx="438912" cy="438912"/>
           </a:xfrm>
           <a:prstGeom prst="ellipse">
@@ -17531,7 +19076,7 @@
         </p:nvSpPr>
         <p:spPr>
           <a:xfrm>
-            <a:off x="822960" y="5715000"/>
+            <a:off x="822960" y="5638800"/>
             <a:ext cx="438912" cy="438912"/>
           </a:xfrm>
           <a:prstGeom prst="rect">
@@ -17570,8 +19115,8 @@
         </p:nvSpPr>
         <p:spPr>
           <a:xfrm>
-            <a:off x="1463040" y="5623560"/>
-            <a:ext cx="10058400" cy="640080"/>
+            <a:off x="1463040" y="5547360"/>
+            <a:ext cx="10058400" cy="624840"/>
           </a:xfrm>
           <a:prstGeom prst="rect">
             <a:avLst/>
@@ -17673,7 +19218,7 @@
                 <a:ea typeface="Calibri" pitchFamily="34" charset="-122"/>
                 <a:cs typeface="Calibri" pitchFamily="34" charset="-120"/>
               </a:rPr>
-              <a:t>32</a:t>
+              <a:t>33</a:t>
             </a:r>
             <a:endParaRPr lang="en-US" sz="900" dirty="0"/>
           </a:p>

</xml_diff>

<commit_message>
Lectures 1-10: replace mermaid diagrams with native high-res PowerPoint shapes
- New deckBuilder "diagram" slide type: hand-placed rect/diamond/roundRect
  shapes with arrow-connected edges and labels, for flowcharts with
  branching decisions -- a native-shapes replacement for a mermaid
  flowchart, reusable across all future lecture decks
- Lecture 4: new "flow" slide for the form-submit sequence
  (user fills form -> submit -> request -> server processes -> response)
- Lecture 5: new "diagram" slide for the cascade conflict-resolution
  flowchart (importance -> specificity -> source order)
- Lecture 8: new "diagram" slide for the vendor-prefix workflow
- Lecture 10: two new "flow" slides -- the mobile-first breakpoint ladder,
  and the Sass-source-to-compiled-CSS pipeline

Lecture 9's mermaid grid-areas diagram was left as-is: the deck already
has a real browser screenshot of the same named-grid-areas layout, which
demonstrates the concept better than an abstract box diagram would.
</commit_message>
<xml_diff>
--- a/slides/CSC336-Lecture-05-CSS-Fundamentals.pptx
+++ b/slides/CSC336-Lecture-05-CSS-Fundamentals.pptx
@@ -38,9 +38,10 @@
     <p:sldId id="286" r:id="rId32"/>
     <p:sldId id="287" r:id="rId33"/>
     <p:sldId id="288" r:id="rId34"/>
+    <p:sldId id="289" r:id="rId35"/>
   </p:sldIdLst>
   <p:notesMasterIdLst>
-    <p:notesMasterId r:id="rId35"/>
+    <p:notesMasterId r:id="rId36"/>
   </p:notesMasterIdLst>
   <p:sldSz cx="12192000" cy="6858000"/>
   <p:notesSz cx="6858000" cy="12192000"/>
@@ -2846,6 +2847,94 @@
             <a:fld id="{F7021451-1387-4CA6-816F-3879F97B5CBC}" type="slidenum">
               <a:rPr lang="en-US"/>
               <a:t>33</a:t>
+            </a:fld>
+            <a:endParaRPr lang="en-US"/>
+          </a:p>
+        </p:txBody>
+      </p:sp>
+    </p:spTree>
+    <p:extLst>
+      <p:ext uri="{BB962C8B-B14F-4D97-AF65-F5344CB8AC3E}">
+        <p14:creationId xmlns:p14="http://schemas.microsoft.com/office/powerpoint/2010/main" val="1024086991"/>
+      </p:ext>
+    </p:extLst>
+  </p:cSld>
+  <p:clrMapOvr>
+    <a:masterClrMapping/>
+  </p:clrMapOvr>
+</p:notes>
+</file>
+
+<file path=ppt/notesSlides/notesSlide34.xml><?xml version="1.0" encoding="utf-8"?>
+<p:notes xmlns:a="http://schemas.openxmlformats.org/drawingml/2006/main" xmlns:r="http://schemas.openxmlformats.org/officeDocument/2006/relationships" xmlns:p="http://schemas.openxmlformats.org/presentationml/2006/main">
+  <p:cSld>
+    <p:spTree>
+      <p:nvGrpSpPr>
+        <p:cNvPr id="1" name=""/>
+        <p:cNvGrpSpPr/>
+        <p:nvPr/>
+      </p:nvGrpSpPr>
+      <p:grpSpPr>
+        <a:xfrm>
+          <a:off x="0" y="0"/>
+          <a:ext cx="0" cy="0"/>
+          <a:chOff x="0" y="0"/>
+          <a:chExt cx="0" cy="0"/>
+        </a:xfrm>
+      </p:grpSpPr>
+      <p:sp>
+        <p:nvSpPr>
+          <p:cNvPr id="2" name="Slide Image Placeholder 1"/>
+          <p:cNvSpPr>
+            <a:spLocks noGrp="1" noRot="1" noChangeAspect="1"/>
+          </p:cNvSpPr>
+          <p:nvPr>
+            <p:ph type="sldImg"/>
+          </p:nvPr>
+        </p:nvSpPr>
+        <p:spPr/>
+      </p:sp>
+      <p:sp>
+        <p:nvSpPr>
+          <p:cNvPr id="3" name="Notes Placeholder 2"/>
+          <p:cNvSpPr>
+            <a:spLocks noGrp="1"/>
+          </p:cNvSpPr>
+          <p:nvPr>
+            <p:ph type="body" idx="1"/>
+          </p:nvPr>
+        </p:nvSpPr>
+        <p:spPr/>
+        <p:txBody>
+          <a:bodyPr/>
+          <a:lstStyle/>
+          <a:p>
+            <a:r>
+              <a:rPr lang="en-US" dirty="0"/>
+              <a:t/>
+            </a:r>
+            <a:endParaRPr lang="en-US" dirty="0"/>
+          </a:p>
+        </p:txBody>
+      </p:sp>
+      <p:sp>
+        <p:nvSpPr>
+          <p:cNvPr id="4" name="Slide Number Placeholder 3"/>
+          <p:cNvSpPr>
+            <a:spLocks noGrp="1"/>
+          </p:cNvSpPr>
+          <p:nvPr>
+            <p:ph type="sldNum" sz="quarter" idx="10"/>
+          </p:nvPr>
+        </p:nvSpPr>
+        <p:spPr/>
+        <p:txBody>
+          <a:bodyPr/>
+          <a:lstStyle/>
+          <a:p>
+            <a:fld id="{F7021451-1387-4CA6-816F-3879F97B5CBC}" type="slidenum">
+              <a:rPr lang="en-US"/>
+              <a:t>34</a:t>
             </a:fld>
             <a:endParaRPr lang="en-US"/>
           </a:p>
@@ -12211,7 +12300,7 @@
                 <a:ea typeface="Cambria" pitchFamily="34" charset="-122"/>
                 <a:cs typeface="Cambria" pitchFamily="34" charset="-120"/>
               </a:rPr>
-              <a:t>Case 5 in Code</a:t>
+              <a:t>The Resolution Flowchart</a:t>
             </a:r>
             <a:endParaRPr lang="en-US" sz="3400" dirty="0"/>
           </a:p>
@@ -12225,13 +12314,295 @@
         </p:nvSpPr>
         <p:spPr>
           <a:xfrm>
-            <a:off x="640080" y="1965960"/>
-            <a:ext cx="10911535" cy="1615440"/>
-          </a:xfrm>
-          <a:prstGeom prst="roundRect">
-            <a:avLst>
-              <a:gd name="adj" fmla="val 4528"/>
-            </a:avLst>
+            <a:off x="6080760" y="2651760"/>
+            <a:ext cx="9144" cy="228600"/>
+          </a:xfrm>
+          <a:prstGeom prst="line">
+            <a:avLst/>
+          </a:prstGeom>
+          <a:noFill/>
+          <a:ln w="25400">
+            <a:solidFill>
+              <a:srgbClr val="5D5D72"/>
+            </a:solidFill>
+            <a:prstDash val="solid"/>
+            <a:tailEnd type="triangle"/>
+          </a:ln>
+        </p:spPr>
+      </p:sp>
+      <p:sp>
+        <p:nvSpPr>
+          <p:cNvPr id="5" name="Shape 3"/>
+          <p:cNvSpPr/>
+          <p:nvPr/>
+        </p:nvSpPr>
+        <p:spPr>
+          <a:xfrm flipH="1">
+            <a:off x="2286000" y="3429000"/>
+            <a:ext cx="2468880" cy="731520"/>
+          </a:xfrm>
+          <a:prstGeom prst="line">
+            <a:avLst/>
+          </a:prstGeom>
+          <a:noFill/>
+          <a:ln w="25400">
+            <a:solidFill>
+              <a:srgbClr val="5D5D72"/>
+            </a:solidFill>
+            <a:prstDash val="solid"/>
+            <a:tailEnd type="triangle"/>
+          </a:ln>
+        </p:spPr>
+      </p:sp>
+      <p:sp>
+        <p:nvSpPr>
+          <p:cNvPr id="6" name="Text 4"/>
+          <p:cNvSpPr txBox="1"/>
+          <p:nvPr/>
+        </p:nvSpPr>
+        <p:spPr>
+          <a:xfrm>
+            <a:off x="2606040" y="3648456"/>
+            <a:ext cx="1828800" cy="292608"/>
+          </a:xfrm>
+          <a:prstGeom prst="rect">
+            <a:avLst/>
+          </a:prstGeom>
+          <a:solidFill>
+            <a:srgbClr val="FFFFFF"/>
+          </a:solidFill>
+          <a:ln/>
+        </p:spPr>
+        <p:txBody>
+          <a:bodyPr wrap="square" lIns="0" tIns="0" rIns="0" bIns="0" rtlCol="0" anchor="ctr"/>
+          <a:lstStyle/>
+          <a:p>
+            <a:pPr algn="ctr" indent="0" marL="0">
+              <a:buNone/>
+            </a:pPr>
+            <a:r>
+              <a:rPr lang="en-US" sz="1050" i="1" dirty="0">
+                <a:solidFill>
+                  <a:srgbClr val="5D5D72"/>
+                </a:solidFill>
+                <a:latin typeface="Calibri" pitchFamily="34" charset="0"/>
+                <a:ea typeface="Calibri" pitchFamily="34" charset="-122"/>
+                <a:cs typeface="Calibri" pitchFamily="34" charset="-120"/>
+              </a:rPr>
+              <a:t>One is !important</a:t>
+            </a:r>
+            <a:endParaRPr lang="en-US" sz="1050" dirty="0"/>
+          </a:p>
+        </p:txBody>
+      </p:sp>
+      <p:sp>
+        <p:nvSpPr>
+          <p:cNvPr id="7" name="Shape 5"/>
+          <p:cNvSpPr/>
+          <p:nvPr/>
+        </p:nvSpPr>
+        <p:spPr>
+          <a:xfrm>
+            <a:off x="5852160" y="3657600"/>
+            <a:ext cx="365760" cy="502920"/>
+          </a:xfrm>
+          <a:prstGeom prst="line">
+            <a:avLst/>
+          </a:prstGeom>
+          <a:noFill/>
+          <a:ln w="25400">
+            <a:solidFill>
+              <a:srgbClr val="5D5D72"/>
+            </a:solidFill>
+            <a:prstDash val="solid"/>
+            <a:tailEnd type="triangle"/>
+          </a:ln>
+        </p:spPr>
+      </p:sp>
+      <p:sp>
+        <p:nvSpPr>
+          <p:cNvPr id="8" name="Text 6"/>
+          <p:cNvSpPr txBox="1"/>
+          <p:nvPr/>
+        </p:nvSpPr>
+        <p:spPr>
+          <a:xfrm>
+            <a:off x="5120640" y="3762756"/>
+            <a:ext cx="1828800" cy="292608"/>
+          </a:xfrm>
+          <a:prstGeom prst="rect">
+            <a:avLst/>
+          </a:prstGeom>
+          <a:solidFill>
+            <a:srgbClr val="FFFFFF"/>
+          </a:solidFill>
+          <a:ln/>
+        </p:spPr>
+        <p:txBody>
+          <a:bodyPr wrap="square" lIns="0" tIns="0" rIns="0" bIns="0" rtlCol="0" anchor="ctr"/>
+          <a:lstStyle/>
+          <a:p>
+            <a:pPr algn="ctr" indent="0" marL="0">
+              <a:buNone/>
+            </a:pPr>
+            <a:r>
+              <a:rPr lang="en-US" sz="1050" i="1" dirty="0">
+                <a:solidFill>
+                  <a:srgbClr val="5D5D72"/>
+                </a:solidFill>
+                <a:latin typeface="Calibri" pitchFamily="34" charset="0"/>
+                <a:ea typeface="Calibri" pitchFamily="34" charset="-122"/>
+                <a:cs typeface="Calibri" pitchFamily="34" charset="-120"/>
+              </a:rPr>
+              <a:t>Both / neither</a:t>
+            </a:r>
+            <a:endParaRPr lang="en-US" sz="1050" dirty="0"/>
+          </a:p>
+        </p:txBody>
+      </p:sp>
+      <p:sp>
+        <p:nvSpPr>
+          <p:cNvPr id="9" name="Shape 7"/>
+          <p:cNvSpPr/>
+          <p:nvPr/>
+        </p:nvSpPr>
+        <p:spPr>
+          <a:xfrm flipH="1">
+            <a:off x="4434840" y="4846320"/>
+            <a:ext cx="1051560" cy="411480"/>
+          </a:xfrm>
+          <a:prstGeom prst="line">
+            <a:avLst/>
+          </a:prstGeom>
+          <a:noFill/>
+          <a:ln w="25400">
+            <a:solidFill>
+              <a:srgbClr val="5D5D72"/>
+            </a:solidFill>
+            <a:prstDash val="solid"/>
+            <a:tailEnd type="triangle"/>
+          </a:ln>
+        </p:spPr>
+      </p:sp>
+      <p:sp>
+        <p:nvSpPr>
+          <p:cNvPr id="10" name="Text 8"/>
+          <p:cNvSpPr txBox="1"/>
+          <p:nvPr/>
+        </p:nvSpPr>
+        <p:spPr>
+          <a:xfrm>
+            <a:off x="4046220" y="4905756"/>
+            <a:ext cx="1828800" cy="292608"/>
+          </a:xfrm>
+          <a:prstGeom prst="rect">
+            <a:avLst/>
+          </a:prstGeom>
+          <a:solidFill>
+            <a:srgbClr val="FFFFFF"/>
+          </a:solidFill>
+          <a:ln/>
+        </p:spPr>
+        <p:txBody>
+          <a:bodyPr wrap="square" lIns="0" tIns="0" rIns="0" bIns="0" rtlCol="0" anchor="ctr"/>
+          <a:lstStyle/>
+          <a:p>
+            <a:pPr algn="ctr" indent="0" marL="0">
+              <a:buNone/>
+            </a:pPr>
+            <a:r>
+              <a:rPr lang="en-US" sz="1050" i="1" dirty="0">
+                <a:solidFill>
+                  <a:srgbClr val="5D5D72"/>
+                </a:solidFill>
+                <a:latin typeface="Calibri" pitchFamily="34" charset="0"/>
+                <a:ea typeface="Calibri" pitchFamily="34" charset="-122"/>
+                <a:cs typeface="Calibri" pitchFamily="34" charset="-120"/>
+              </a:rPr>
+              <a:t>One higher</a:t>
+            </a:r>
+            <a:endParaRPr lang="en-US" sz="1050" dirty="0"/>
+          </a:p>
+        </p:txBody>
+      </p:sp>
+      <p:sp>
+        <p:nvSpPr>
+          <p:cNvPr id="11" name="Shape 9"/>
+          <p:cNvSpPr/>
+          <p:nvPr/>
+        </p:nvSpPr>
+        <p:spPr>
+          <a:xfrm>
+            <a:off x="6766560" y="4846320"/>
+            <a:ext cx="1463040" cy="411480"/>
+          </a:xfrm>
+          <a:prstGeom prst="line">
+            <a:avLst/>
+          </a:prstGeom>
+          <a:noFill/>
+          <a:ln w="25400">
+            <a:solidFill>
+              <a:srgbClr val="5D5D72"/>
+            </a:solidFill>
+            <a:prstDash val="solid"/>
+            <a:tailEnd type="triangle"/>
+          </a:ln>
+        </p:spPr>
+      </p:sp>
+      <p:sp>
+        <p:nvSpPr>
+          <p:cNvPr id="12" name="Text 10"/>
+          <p:cNvSpPr txBox="1"/>
+          <p:nvPr/>
+        </p:nvSpPr>
+        <p:spPr>
+          <a:xfrm>
+            <a:off x="6583680" y="4905756"/>
+            <a:ext cx="1828800" cy="292608"/>
+          </a:xfrm>
+          <a:prstGeom prst="rect">
+            <a:avLst/>
+          </a:prstGeom>
+          <a:solidFill>
+            <a:srgbClr val="FFFFFF"/>
+          </a:solidFill>
+          <a:ln/>
+        </p:spPr>
+        <p:txBody>
+          <a:bodyPr wrap="square" lIns="0" tIns="0" rIns="0" bIns="0" rtlCol="0" anchor="ctr"/>
+          <a:lstStyle/>
+          <a:p>
+            <a:pPr algn="ctr" indent="0" marL="0">
+              <a:buNone/>
+            </a:pPr>
+            <a:r>
+              <a:rPr lang="en-US" sz="1050" i="1" dirty="0">
+                <a:solidFill>
+                  <a:srgbClr val="5D5D72"/>
+                </a:solidFill>
+                <a:latin typeface="Calibri" pitchFamily="34" charset="0"/>
+                <a:ea typeface="Calibri" pitchFamily="34" charset="-122"/>
+                <a:cs typeface="Calibri" pitchFamily="34" charset="-120"/>
+              </a:rPr>
+              <a:t>Equal specificity</a:t>
+            </a:r>
+            <a:endParaRPr lang="en-US" sz="1050" dirty="0"/>
+          </a:p>
+        </p:txBody>
+      </p:sp>
+      <p:sp>
+        <p:nvSpPr>
+          <p:cNvPr id="13" name="Shape 11"/>
+          <p:cNvSpPr/>
+          <p:nvPr/>
+        </p:nvSpPr>
+        <p:spPr>
+          <a:xfrm>
+            <a:off x="4114800" y="2103120"/>
+            <a:ext cx="3931920" cy="548640"/>
+          </a:xfrm>
+          <a:prstGeom prst="rect">
+            <a:avLst/>
           </a:prstGeom>
           <a:solidFill>
             <a:srgbClr val="1E1E4C"/>
@@ -12241,14 +12612,14 @@
       </p:sp>
       <p:sp>
         <p:nvSpPr>
-          <p:cNvPr id="5" name="Text 3"/>
+          <p:cNvPr id="14" name="Text 12"/>
           <p:cNvSpPr txBox="1"/>
           <p:nvPr/>
         </p:nvSpPr>
         <p:spPr>
           <a:xfrm>
-            <a:off x="960120" y="2194560"/>
-            <a:ext cx="10271455" cy="1158240"/>
+            <a:off x="4169664" y="2103120"/>
+            <a:ext cx="3822192" cy="548640"/>
           </a:xfrm>
           <a:prstGeom prst="rect">
             <a:avLst/>
@@ -12257,151 +12628,512 @@
           <a:ln/>
         </p:spPr>
         <p:txBody>
-          <a:bodyPr wrap="square" lIns="0" tIns="0" rIns="0" bIns="0" rtlCol="0" anchor="t"/>
-          <a:lstStyle/>
-          <a:p>
-            <a:pPr indent="0" marL="0">
+          <a:bodyPr wrap="square" lIns="0" tIns="0" rIns="0" bIns="0" rtlCol="0" anchor="ctr"/>
+          <a:lstStyle/>
+          <a:p>
+            <a:pPr algn="ctr" indent="0" marL="0">
               <a:lnSpc>
-                <a:spcPct val="125000"/>
+                <a:spcPct val="105000"/>
               </a:lnSpc>
               <a:buNone/>
             </a:pPr>
             <a:r>
-              <a:rPr lang="en-US" sz="1400" dirty="0">
-                <a:solidFill>
-                  <a:srgbClr val="C9D3F5"/>
-                </a:solidFill>
-                <a:latin typeface="Courier New" pitchFamily="34" charset="0"/>
-                <a:ea typeface="Courier New" pitchFamily="34" charset="-122"/>
-                <a:cs typeface="Courier New" pitchFamily="34" charset="-120"/>
-              </a:rPr>
-              <a:t>&lt;p id="lead" style="color: purple;"&gt;...&lt;/p&gt;</a:t>
-            </a:r>
-            <a:endParaRPr lang="en-US" sz="1400" dirty="0"/>
-          </a:p>
-          <a:p>
-            <a:pPr indent="0" marL="0">
-              <a:lnSpc>
-                <a:spcPct val="125000"/>
-              </a:lnSpc>
-              <a:buNone/>
-            </a:pPr>
-            <a:endParaRPr lang="en-US" sz="1400" dirty="0"/>
-          </a:p>
-          <a:p>
-            <a:pPr indent="0" marL="0">
-              <a:lnSpc>
-                <a:spcPct val="125000"/>
-              </a:lnSpc>
-              <a:buNone/>
-            </a:pPr>
-            <a:r>
-              <a:rPr lang="en-US" sz="1400" dirty="0">
-                <a:solidFill>
-                  <a:srgbClr val="C9D3F5"/>
-                </a:solidFill>
-                <a:latin typeface="Courier New" pitchFamily="34" charset="0"/>
-                <a:ea typeface="Courier New" pitchFamily="34" charset="-122"/>
-                <a:cs typeface="Courier New" pitchFamily="34" charset="-120"/>
-              </a:rPr>
-              <a:t>#lead { color: blue; }              /* loses to inline */</a:t>
-            </a:r>
-            <a:endParaRPr lang="en-US" sz="1400" dirty="0"/>
-          </a:p>
-          <a:p>
-            <a:pPr indent="0" marL="0">
-              <a:lnSpc>
-                <a:spcPct val="125000"/>
-              </a:lnSpc>
-              <a:buNone/>
-            </a:pPr>
-            <a:r>
-              <a:rPr lang="en-US" sz="1400" dirty="0">
-                <a:solidFill>
-                  <a:srgbClr val="C9D3F5"/>
-                </a:solidFill>
-                <a:latin typeface="Courier New" pitchFamily="34" charset="0"/>
-                <a:ea typeface="Courier New" pitchFamily="34" charset="-122"/>
-                <a:cs typeface="Courier New" pitchFamily="34" charset="-120"/>
-              </a:rPr>
-              <a:t>#lead { color: green !important; } /* beats inline   */</a:t>
-            </a:r>
-            <a:endParaRPr lang="en-US" sz="1400" dirty="0"/>
-          </a:p>
-        </p:txBody>
-      </p:sp>
-      <p:sp>
-        <p:nvSpPr>
-          <p:cNvPr id="6" name="Text 4"/>
-          <p:cNvSpPr txBox="1"/>
-          <p:nvPr/>
-        </p:nvSpPr>
-        <p:spPr>
-          <a:xfrm>
-            <a:off x="640080" y="3810000"/>
-            <a:ext cx="10911535" cy="2453640"/>
-          </a:xfrm>
-          <a:prstGeom prst="rect">
-            <a:avLst/>
-          </a:prstGeom>
-          <a:noFill/>
-          <a:ln/>
-        </p:spPr>
-        <p:txBody>
-          <a:bodyPr wrap="square" lIns="0" tIns="0" rIns="0" bIns="0" rtlCol="0" anchor="t"/>
-          <a:lstStyle/>
-          <a:p>
-            <a:pPr indent="0" marL="0">
-              <a:buNone/>
-            </a:pPr>
-            <a:r>
-              <a:rPr lang="en-US" sz="1300" dirty="0">
-                <a:solidFill>
-                  <a:srgbClr val="26262F"/>
+              <a:rPr lang="en-US" sz="1250" b="1" dirty="0">
+                <a:solidFill>
+                  <a:srgbClr val="FFFFFF"/>
                 </a:solidFill>
                 <a:latin typeface="Calibri" pitchFamily="34" charset="0"/>
                 <a:ea typeface="Calibri" pitchFamily="34" charset="-122"/>
                 <a:cs typeface="Calibri" pitchFamily="34" charset="-120"/>
               </a:rPr>
-              <a:t>Without the !important line, the paragraph is purple. With it, green — one of the few times !important is the right tool.</a:t>
-            </a:r>
-            <a:endParaRPr lang="en-US" sz="1300" dirty="0"/>
-          </a:p>
-        </p:txBody>
-      </p:sp>
-      <p:sp>
-        <p:nvSpPr>
-          <p:cNvPr id="7" name="Text 5"/>
-          <p:cNvSpPr txBox="1"/>
-          <p:nvPr/>
-        </p:nvSpPr>
-        <p:spPr>
-          <a:xfrm>
-            <a:off x="640080" y="6446520"/>
-            <a:ext cx="8686800" cy="292608"/>
-          </a:xfrm>
-          <a:prstGeom prst="rect">
-            <a:avLst/>
-          </a:prstGeom>
-          <a:noFill/>
-          <a:ln/>
-        </p:spPr>
-        <p:txBody>
-          <a:bodyPr wrap="square" lIns="0" tIns="0" rIns="0" bIns="0" rtlCol="0" anchor="ctr"/>
-          <a:lstStyle/>
-          <a:p>
-            <a:pPr algn="l" indent="0" marL="0">
-              <a:buNone/>
-            </a:pPr>
-            <a:r>
-              <a:rPr lang="en-US" sz="900" dirty="0">
-                <a:solidFill>
-                  <a:srgbClr val="5D5D72"/>
+              <a:t>Conflicting declarations</a:t>
+            </a:r>
+            <a:endParaRPr lang="en-US" sz="1250" dirty="0"/>
+          </a:p>
+          <a:p>
+            <a:pPr algn="ctr" indent="0" marL="0">
+              <a:lnSpc>
+                <a:spcPct val="105000"/>
+              </a:lnSpc>
+              <a:buNone/>
+            </a:pPr>
+            <a:r>
+              <a:rPr lang="en-US" sz="1250" b="1" dirty="0">
+                <a:solidFill>
+                  <a:srgbClr val="FFFFFF"/>
                 </a:solidFill>
                 <a:latin typeface="Calibri" pitchFamily="34" charset="0"/>
                 <a:ea typeface="Calibri" pitchFamily="34" charset="-122"/>
                 <a:cs typeface="Calibri" pitchFamily="34" charset="-120"/>
               </a:rPr>
+              <a:t>on the same property</a:t>
+            </a:r>
+            <a:endParaRPr lang="en-US" sz="1250" dirty="0"/>
+          </a:p>
+        </p:txBody>
+      </p:sp>
+      <p:sp>
+        <p:nvSpPr>
+          <p:cNvPr id="15" name="Shape 13"/>
+          <p:cNvSpPr/>
+          <p:nvPr/>
+        </p:nvSpPr>
+        <p:spPr>
+          <a:xfrm>
+            <a:off x="4206240" y="2880360"/>
+            <a:ext cx="3749040" cy="777240"/>
+          </a:xfrm>
+          <a:prstGeom prst="diamond">
+            <a:avLst/>
+          </a:prstGeom>
+          <a:solidFill>
+            <a:srgbClr val="FF8A3D"/>
+          </a:solidFill>
+          <a:ln/>
+        </p:spPr>
+      </p:sp>
+      <p:sp>
+        <p:nvSpPr>
+          <p:cNvPr id="16" name="Text 14"/>
+          <p:cNvSpPr txBox="1"/>
+          <p:nvPr/>
+        </p:nvSpPr>
+        <p:spPr>
+          <a:xfrm>
+            <a:off x="4261104" y="2880360"/>
+            <a:ext cx="3639312" cy="777240"/>
+          </a:xfrm>
+          <a:prstGeom prst="rect">
+            <a:avLst/>
+          </a:prstGeom>
+          <a:noFill/>
+          <a:ln/>
+        </p:spPr>
+        <p:txBody>
+          <a:bodyPr wrap="square" lIns="0" tIns="0" rIns="0" bIns="0" rtlCol="0" anchor="ctr"/>
+          <a:lstStyle/>
+          <a:p>
+            <a:pPr algn="ctr" indent="0" marL="0">
+              <a:lnSpc>
+                <a:spcPct val="105000"/>
+              </a:lnSpc>
+              <a:buNone/>
+            </a:pPr>
+            <a:r>
+              <a:rPr lang="en-US" sz="1150" b="1" dirty="0">
+                <a:solidFill>
+                  <a:srgbClr val="FFFFFF"/>
+                </a:solidFill>
+                <a:latin typeface="Calibri" pitchFamily="34" charset="0"/>
+                <a:ea typeface="Calibri" pitchFamily="34" charset="-122"/>
+                <a:cs typeface="Calibri" pitchFamily="34" charset="-120"/>
+              </a:rPr>
+              <a:t>Differ in</a:t>
+            </a:r>
+            <a:endParaRPr lang="en-US" sz="1150" dirty="0"/>
+          </a:p>
+          <a:p>
+            <a:pPr algn="ctr" indent="0" marL="0">
+              <a:lnSpc>
+                <a:spcPct val="105000"/>
+              </a:lnSpc>
+              <a:buNone/>
+            </a:pPr>
+            <a:r>
+              <a:rPr lang="en-US" sz="1150" b="1" dirty="0">
+                <a:solidFill>
+                  <a:srgbClr val="FFFFFF"/>
+                </a:solidFill>
+                <a:latin typeface="Calibri" pitchFamily="34" charset="0"/>
+                <a:ea typeface="Calibri" pitchFamily="34" charset="-122"/>
+                <a:cs typeface="Calibri" pitchFamily="34" charset="-120"/>
+              </a:rPr>
+              <a:t>!important status?</a:t>
+            </a:r>
+            <a:endParaRPr lang="en-US" sz="1150" dirty="0"/>
+          </a:p>
+        </p:txBody>
+      </p:sp>
+      <p:sp>
+        <p:nvSpPr>
+          <p:cNvPr id="17" name="Shape 15"/>
+          <p:cNvSpPr/>
+          <p:nvPr/>
+        </p:nvSpPr>
+        <p:spPr>
+          <a:xfrm>
+            <a:off x="822960" y="4160520"/>
+            <a:ext cx="2926080" cy="548640"/>
+          </a:xfrm>
+          <a:prstGeom prst="rect">
+            <a:avLst/>
+          </a:prstGeom>
+          <a:solidFill>
+            <a:srgbClr val="3FA66B"/>
+          </a:solidFill>
+          <a:ln/>
+        </p:spPr>
+      </p:sp>
+      <p:sp>
+        <p:nvSpPr>
+          <p:cNvPr id="18" name="Text 16"/>
+          <p:cNvSpPr txBox="1"/>
+          <p:nvPr/>
+        </p:nvSpPr>
+        <p:spPr>
+          <a:xfrm>
+            <a:off x="877824" y="4160520"/>
+            <a:ext cx="2816352" cy="548640"/>
+          </a:xfrm>
+          <a:prstGeom prst="rect">
+            <a:avLst/>
+          </a:prstGeom>
+          <a:noFill/>
+          <a:ln/>
+        </p:spPr>
+        <p:txBody>
+          <a:bodyPr wrap="square" lIns="0" tIns="0" rIns="0" bIns="0" rtlCol="0" anchor="ctr"/>
+          <a:lstStyle/>
+          <a:p>
+            <a:pPr algn="ctr" indent="0" marL="0">
+              <a:lnSpc>
+                <a:spcPct val="105000"/>
+              </a:lnSpc>
+              <a:buNone/>
+            </a:pPr>
+            <a:r>
+              <a:rPr lang="en-US" sz="1200" b="1" dirty="0">
+                <a:solidFill>
+                  <a:srgbClr val="FFFFFF"/>
+                </a:solidFill>
+                <a:latin typeface="Calibri" pitchFamily="34" charset="0"/>
+                <a:ea typeface="Calibri" pitchFamily="34" charset="-122"/>
+                <a:cs typeface="Calibri" pitchFamily="34" charset="-120"/>
+              </a:rPr>
+              <a:t>The !important</a:t>
+            </a:r>
+            <a:endParaRPr lang="en-US" sz="1200" dirty="0"/>
+          </a:p>
+          <a:p>
+            <a:pPr algn="ctr" indent="0" marL="0">
+              <a:lnSpc>
+                <a:spcPct val="105000"/>
+              </a:lnSpc>
+              <a:buNone/>
+            </a:pPr>
+            <a:r>
+              <a:rPr lang="en-US" sz="1200" b="1" dirty="0">
+                <a:solidFill>
+                  <a:srgbClr val="FFFFFF"/>
+                </a:solidFill>
+                <a:latin typeface="Calibri" pitchFamily="34" charset="0"/>
+                <a:ea typeface="Calibri" pitchFamily="34" charset="-122"/>
+                <a:cs typeface="Calibri" pitchFamily="34" charset="-120"/>
+              </a:rPr>
+              <a:t>declaration wins</a:t>
+            </a:r>
+            <a:endParaRPr lang="en-US" sz="1200" dirty="0"/>
+          </a:p>
+        </p:txBody>
+      </p:sp>
+      <p:sp>
+        <p:nvSpPr>
+          <p:cNvPr id="19" name="Shape 17"/>
+          <p:cNvSpPr/>
+          <p:nvPr/>
+        </p:nvSpPr>
+        <p:spPr>
+          <a:xfrm>
+            <a:off x="4572000" y="4160520"/>
+            <a:ext cx="3291840" cy="685800"/>
+          </a:xfrm>
+          <a:prstGeom prst="diamond">
+            <a:avLst/>
+          </a:prstGeom>
+          <a:solidFill>
+            <a:srgbClr val="FF8A3D"/>
+          </a:solidFill>
+          <a:ln/>
+        </p:spPr>
+      </p:sp>
+      <p:sp>
+        <p:nvSpPr>
+          <p:cNvPr id="20" name="Text 18"/>
+          <p:cNvSpPr txBox="1"/>
+          <p:nvPr/>
+        </p:nvSpPr>
+        <p:spPr>
+          <a:xfrm>
+            <a:off x="4626864" y="4160520"/>
+            <a:ext cx="3182112" cy="685800"/>
+          </a:xfrm>
+          <a:prstGeom prst="rect">
+            <a:avLst/>
+          </a:prstGeom>
+          <a:noFill/>
+          <a:ln/>
+        </p:spPr>
+        <p:txBody>
+          <a:bodyPr wrap="square" lIns="0" tIns="0" rIns="0" bIns="0" rtlCol="0" anchor="ctr"/>
+          <a:lstStyle/>
+          <a:p>
+            <a:pPr algn="ctr" indent="0" marL="0">
+              <a:lnSpc>
+                <a:spcPct val="105000"/>
+              </a:lnSpc>
+              <a:buNone/>
+            </a:pPr>
+            <a:r>
+              <a:rPr lang="en-US" sz="1150" b="1" dirty="0">
+                <a:solidFill>
+                  <a:srgbClr val="FFFFFF"/>
+                </a:solidFill>
+                <a:latin typeface="Calibri" pitchFamily="34" charset="0"/>
+                <a:ea typeface="Calibri" pitchFamily="34" charset="-122"/>
+                <a:cs typeface="Calibri" pitchFamily="34" charset="-120"/>
+              </a:rPr>
+              <a:t>Compare specificity</a:t>
+            </a:r>
+            <a:endParaRPr lang="en-US" sz="1150" dirty="0"/>
+          </a:p>
+        </p:txBody>
+      </p:sp>
+      <p:sp>
+        <p:nvSpPr>
+          <p:cNvPr id="21" name="Shape 19"/>
+          <p:cNvSpPr/>
+          <p:nvPr/>
+        </p:nvSpPr>
+        <p:spPr>
+          <a:xfrm>
+            <a:off x="3017520" y="5257800"/>
+            <a:ext cx="2834640" cy="548640"/>
+          </a:xfrm>
+          <a:prstGeom prst="rect">
+            <a:avLst/>
+          </a:prstGeom>
+          <a:solidFill>
+            <a:srgbClr val="3FA66B"/>
+          </a:solidFill>
+          <a:ln/>
+        </p:spPr>
+      </p:sp>
+      <p:sp>
+        <p:nvSpPr>
+          <p:cNvPr id="22" name="Text 20"/>
+          <p:cNvSpPr txBox="1"/>
+          <p:nvPr/>
+        </p:nvSpPr>
+        <p:spPr>
+          <a:xfrm>
+            <a:off x="3072384" y="5257800"/>
+            <a:ext cx="2724912" cy="548640"/>
+          </a:xfrm>
+          <a:prstGeom prst="rect">
+            <a:avLst/>
+          </a:prstGeom>
+          <a:noFill/>
+          <a:ln/>
+        </p:spPr>
+        <p:txBody>
+          <a:bodyPr wrap="square" lIns="0" tIns="0" rIns="0" bIns="0" rtlCol="0" anchor="ctr"/>
+          <a:lstStyle/>
+          <a:p>
+            <a:pPr algn="ctr" indent="0" marL="0">
+              <a:lnSpc>
+                <a:spcPct val="105000"/>
+              </a:lnSpc>
+              <a:buNone/>
+            </a:pPr>
+            <a:r>
+              <a:rPr lang="en-US" sz="1200" b="1" dirty="0">
+                <a:solidFill>
+                  <a:srgbClr val="FFFFFF"/>
+                </a:solidFill>
+                <a:latin typeface="Calibri" pitchFamily="34" charset="0"/>
+                <a:ea typeface="Calibri" pitchFamily="34" charset="-122"/>
+                <a:cs typeface="Calibri" pitchFamily="34" charset="-120"/>
+              </a:rPr>
+              <a:t>More specific</a:t>
+            </a:r>
+            <a:endParaRPr lang="en-US" sz="1200" dirty="0"/>
+          </a:p>
+          <a:p>
+            <a:pPr algn="ctr" indent="0" marL="0">
+              <a:lnSpc>
+                <a:spcPct val="105000"/>
+              </a:lnSpc>
+              <a:buNone/>
+            </a:pPr>
+            <a:r>
+              <a:rPr lang="en-US" sz="1200" b="1" dirty="0">
+                <a:solidFill>
+                  <a:srgbClr val="FFFFFF"/>
+                </a:solidFill>
+                <a:latin typeface="Calibri" pitchFamily="34" charset="0"/>
+                <a:ea typeface="Calibri" pitchFamily="34" charset="-122"/>
+                <a:cs typeface="Calibri" pitchFamily="34" charset="-120"/>
+              </a:rPr>
+              <a:t>rule wins</a:t>
+            </a:r>
+            <a:endParaRPr lang="en-US" sz="1200" dirty="0"/>
+          </a:p>
+        </p:txBody>
+      </p:sp>
+      <p:sp>
+        <p:nvSpPr>
+          <p:cNvPr id="23" name="Shape 21"/>
+          <p:cNvSpPr/>
+          <p:nvPr/>
+        </p:nvSpPr>
+        <p:spPr>
+          <a:xfrm>
+            <a:off x="6583680" y="5257800"/>
+            <a:ext cx="3291840" cy="548640"/>
+          </a:xfrm>
+          <a:prstGeom prst="rect">
+            <a:avLst/>
+          </a:prstGeom>
+          <a:solidFill>
+            <a:srgbClr val="3FA66B"/>
+          </a:solidFill>
+          <a:ln/>
+        </p:spPr>
+      </p:sp>
+      <p:sp>
+        <p:nvSpPr>
+          <p:cNvPr id="24" name="Text 22"/>
+          <p:cNvSpPr txBox="1"/>
+          <p:nvPr/>
+        </p:nvSpPr>
+        <p:spPr>
+          <a:xfrm>
+            <a:off x="6638544" y="5257800"/>
+            <a:ext cx="3182112" cy="548640"/>
+          </a:xfrm>
+          <a:prstGeom prst="rect">
+            <a:avLst/>
+          </a:prstGeom>
+          <a:noFill/>
+          <a:ln/>
+        </p:spPr>
+        <p:txBody>
+          <a:bodyPr wrap="square" lIns="0" tIns="0" rIns="0" bIns="0" rtlCol="0" anchor="ctr"/>
+          <a:lstStyle/>
+          <a:p>
+            <a:pPr algn="ctr" indent="0" marL="0">
+              <a:lnSpc>
+                <a:spcPct val="105000"/>
+              </a:lnSpc>
+              <a:buNone/>
+            </a:pPr>
+            <a:r>
+              <a:rPr lang="en-US" sz="1150" b="1" dirty="0">
+                <a:solidFill>
+                  <a:srgbClr val="FFFFFF"/>
+                </a:solidFill>
+                <a:latin typeface="Calibri" pitchFamily="34" charset="0"/>
+                <a:ea typeface="Calibri" pitchFamily="34" charset="-122"/>
+                <a:cs typeface="Calibri" pitchFamily="34" charset="-120"/>
+              </a:rPr>
+              <a:t>Rule written LATER wins</a:t>
+            </a:r>
+            <a:endParaRPr lang="en-US" sz="1150" dirty="0"/>
+          </a:p>
+          <a:p>
+            <a:pPr algn="ctr" indent="0" marL="0">
+              <a:lnSpc>
+                <a:spcPct val="105000"/>
+              </a:lnSpc>
+              <a:buNone/>
+            </a:pPr>
+            <a:r>
+              <a:rPr lang="en-US" sz="1150" b="1" dirty="0">
+                <a:solidFill>
+                  <a:srgbClr val="FFFFFF"/>
+                </a:solidFill>
+                <a:latin typeface="Calibri" pitchFamily="34" charset="0"/>
+                <a:ea typeface="Calibri" pitchFamily="34" charset="-122"/>
+                <a:cs typeface="Calibri" pitchFamily="34" charset="-120"/>
+              </a:rPr>
+              <a:t>(equal specificity)</a:t>
+            </a:r>
+            <a:endParaRPr lang="en-US" sz="1150" dirty="0"/>
+          </a:p>
+        </p:txBody>
+      </p:sp>
+      <p:sp>
+        <p:nvSpPr>
+          <p:cNvPr id="25" name="Text 23"/>
+          <p:cNvSpPr txBox="1"/>
+          <p:nvPr/>
+        </p:nvSpPr>
+        <p:spPr>
+          <a:xfrm>
+            <a:off x="640080" y="5989320"/>
+            <a:ext cx="10911535" cy="411480"/>
+          </a:xfrm>
+          <a:prstGeom prst="rect">
+            <a:avLst/>
+          </a:prstGeom>
+          <a:noFill/>
+          <a:ln/>
+        </p:spPr>
+        <p:txBody>
+          <a:bodyPr wrap="square" lIns="0" tIns="0" rIns="0" bIns="0" rtlCol="0" anchor="t"/>
+          <a:lstStyle/>
+          <a:p>
+            <a:pPr indent="0" marL="0">
+              <a:buNone/>
+            </a:pPr>
+            <a:r>
+              <a:rPr lang="en-US" sz="1250" i="1" dirty="0">
+                <a:solidFill>
+                  <a:srgbClr val="5D5D72"/>
+                </a:solidFill>
+                <a:latin typeface="Calibri" pitchFamily="34" charset="0"/>
+                <a:ea typeface="Calibri" pitchFamily="34" charset="-122"/>
+                <a:cs typeface="Calibri" pitchFamily="34" charset="-120"/>
+              </a:rPr>
+              <a:t>Every cascade conflict resolves through exactly these branches, in this order — importance first, then specificity, then source order.</a:t>
+            </a:r>
+            <a:endParaRPr lang="en-US" sz="1250" dirty="0"/>
+          </a:p>
+        </p:txBody>
+      </p:sp>
+      <p:sp>
+        <p:nvSpPr>
+          <p:cNvPr id="26" name="Text 24"/>
+          <p:cNvSpPr txBox="1"/>
+          <p:nvPr/>
+        </p:nvSpPr>
+        <p:spPr>
+          <a:xfrm>
+            <a:off x="640080" y="6446520"/>
+            <a:ext cx="8686800" cy="292608"/>
+          </a:xfrm>
+          <a:prstGeom prst="rect">
+            <a:avLst/>
+          </a:prstGeom>
+          <a:noFill/>
+          <a:ln/>
+        </p:spPr>
+        <p:txBody>
+          <a:bodyPr wrap="square" lIns="0" tIns="0" rIns="0" bIns="0" rtlCol="0" anchor="ctr"/>
+          <a:lstStyle/>
+          <a:p>
+            <a:pPr algn="l" indent="0" marL="0">
+              <a:buNone/>
+            </a:pPr>
+            <a:r>
+              <a:rPr lang="en-US" sz="900" dirty="0">
+                <a:solidFill>
+                  <a:srgbClr val="5D5D72"/>
+                </a:solidFill>
+                <a:latin typeface="Calibri" pitchFamily="34" charset="0"/>
+                <a:ea typeface="Calibri" pitchFamily="34" charset="-122"/>
+                <a:cs typeface="Calibri" pitchFamily="34" charset="-120"/>
+              </a:rPr>
               <a:t>Usman Akram  •  COMSATS University Islamabad</a:t>
             </a:r>
             <a:endParaRPr lang="en-US" sz="900" dirty="0"/>
@@ -12410,7 +13142,7 @@
       </p:sp>
       <p:sp>
         <p:nvSpPr>
-          <p:cNvPr id="8" name="Text 6"/>
+          <p:cNvPr id="27" name="Text 25"/>
           <p:cNvSpPr txBox="1"/>
           <p:nvPr/>
         </p:nvSpPr>
@@ -12512,7 +13244,7 @@
                 <a:ea typeface="Calibri" pitchFamily="34" charset="-122"/>
                 <a:cs typeface="Calibri" pitchFamily="34" charset="-120"/>
               </a:rPr>
-              <a:t>THE REAL FORMULA</a:t>
+              <a:t>EVERY CONFLICT CASE</a:t>
             </a:r>
             <a:endParaRPr lang="en-US" sz="1300" dirty="0"/>
           </a:p>
@@ -12551,6 +13283,346 @@
                 <a:ea typeface="Cambria" pitchFamily="34" charset="-122"/>
                 <a:cs typeface="Cambria" pitchFamily="34" charset="-120"/>
               </a:rPr>
+              <a:t>Case 5 in Code</a:t>
+            </a:r>
+            <a:endParaRPr lang="en-US" sz="3400" dirty="0"/>
+          </a:p>
+        </p:txBody>
+      </p:sp>
+      <p:sp>
+        <p:nvSpPr>
+          <p:cNvPr id="4" name="Shape 2"/>
+          <p:cNvSpPr/>
+          <p:nvPr/>
+        </p:nvSpPr>
+        <p:spPr>
+          <a:xfrm>
+            <a:off x="640080" y="1965960"/>
+            <a:ext cx="10911535" cy="1615440"/>
+          </a:xfrm>
+          <a:prstGeom prst="roundRect">
+            <a:avLst>
+              <a:gd name="adj" fmla="val 4528"/>
+            </a:avLst>
+          </a:prstGeom>
+          <a:solidFill>
+            <a:srgbClr val="1E1E4C"/>
+          </a:solidFill>
+          <a:ln/>
+        </p:spPr>
+      </p:sp>
+      <p:sp>
+        <p:nvSpPr>
+          <p:cNvPr id="5" name="Text 3"/>
+          <p:cNvSpPr txBox="1"/>
+          <p:nvPr/>
+        </p:nvSpPr>
+        <p:spPr>
+          <a:xfrm>
+            <a:off x="960120" y="2194560"/>
+            <a:ext cx="10271455" cy="1158240"/>
+          </a:xfrm>
+          <a:prstGeom prst="rect">
+            <a:avLst/>
+          </a:prstGeom>
+          <a:noFill/>
+          <a:ln/>
+        </p:spPr>
+        <p:txBody>
+          <a:bodyPr wrap="square" lIns="0" tIns="0" rIns="0" bIns="0" rtlCol="0" anchor="t"/>
+          <a:lstStyle/>
+          <a:p>
+            <a:pPr indent="0" marL="0">
+              <a:lnSpc>
+                <a:spcPct val="125000"/>
+              </a:lnSpc>
+              <a:buNone/>
+            </a:pPr>
+            <a:r>
+              <a:rPr lang="en-US" sz="1400" dirty="0">
+                <a:solidFill>
+                  <a:srgbClr val="C9D3F5"/>
+                </a:solidFill>
+                <a:latin typeface="Courier New" pitchFamily="34" charset="0"/>
+                <a:ea typeface="Courier New" pitchFamily="34" charset="-122"/>
+                <a:cs typeface="Courier New" pitchFamily="34" charset="-120"/>
+              </a:rPr>
+              <a:t>&lt;p id="lead" style="color: purple;"&gt;...&lt;/p&gt;</a:t>
+            </a:r>
+            <a:endParaRPr lang="en-US" sz="1400" dirty="0"/>
+          </a:p>
+          <a:p>
+            <a:pPr indent="0" marL="0">
+              <a:lnSpc>
+                <a:spcPct val="125000"/>
+              </a:lnSpc>
+              <a:buNone/>
+            </a:pPr>
+            <a:endParaRPr lang="en-US" sz="1400" dirty="0"/>
+          </a:p>
+          <a:p>
+            <a:pPr indent="0" marL="0">
+              <a:lnSpc>
+                <a:spcPct val="125000"/>
+              </a:lnSpc>
+              <a:buNone/>
+            </a:pPr>
+            <a:r>
+              <a:rPr lang="en-US" sz="1400" dirty="0">
+                <a:solidFill>
+                  <a:srgbClr val="C9D3F5"/>
+                </a:solidFill>
+                <a:latin typeface="Courier New" pitchFamily="34" charset="0"/>
+                <a:ea typeface="Courier New" pitchFamily="34" charset="-122"/>
+                <a:cs typeface="Courier New" pitchFamily="34" charset="-120"/>
+              </a:rPr>
+              <a:t>#lead { color: blue; }              /* loses to inline */</a:t>
+            </a:r>
+            <a:endParaRPr lang="en-US" sz="1400" dirty="0"/>
+          </a:p>
+          <a:p>
+            <a:pPr indent="0" marL="0">
+              <a:lnSpc>
+                <a:spcPct val="125000"/>
+              </a:lnSpc>
+              <a:buNone/>
+            </a:pPr>
+            <a:r>
+              <a:rPr lang="en-US" sz="1400" dirty="0">
+                <a:solidFill>
+                  <a:srgbClr val="C9D3F5"/>
+                </a:solidFill>
+                <a:latin typeface="Courier New" pitchFamily="34" charset="0"/>
+                <a:ea typeface="Courier New" pitchFamily="34" charset="-122"/>
+                <a:cs typeface="Courier New" pitchFamily="34" charset="-120"/>
+              </a:rPr>
+              <a:t>#lead { color: green !important; } /* beats inline   */</a:t>
+            </a:r>
+            <a:endParaRPr lang="en-US" sz="1400" dirty="0"/>
+          </a:p>
+        </p:txBody>
+      </p:sp>
+      <p:sp>
+        <p:nvSpPr>
+          <p:cNvPr id="6" name="Text 4"/>
+          <p:cNvSpPr txBox="1"/>
+          <p:nvPr/>
+        </p:nvSpPr>
+        <p:spPr>
+          <a:xfrm>
+            <a:off x="640080" y="3810000"/>
+            <a:ext cx="10911535" cy="2453640"/>
+          </a:xfrm>
+          <a:prstGeom prst="rect">
+            <a:avLst/>
+          </a:prstGeom>
+          <a:noFill/>
+          <a:ln/>
+        </p:spPr>
+        <p:txBody>
+          <a:bodyPr wrap="square" lIns="0" tIns="0" rIns="0" bIns="0" rtlCol="0" anchor="t"/>
+          <a:lstStyle/>
+          <a:p>
+            <a:pPr indent="0" marL="0">
+              <a:buNone/>
+            </a:pPr>
+            <a:r>
+              <a:rPr lang="en-US" sz="1300" dirty="0">
+                <a:solidFill>
+                  <a:srgbClr val="26262F"/>
+                </a:solidFill>
+                <a:latin typeface="Calibri" pitchFamily="34" charset="0"/>
+                <a:ea typeface="Calibri" pitchFamily="34" charset="-122"/>
+                <a:cs typeface="Calibri" pitchFamily="34" charset="-120"/>
+              </a:rPr>
+              <a:t>Without the !important line, the paragraph is purple. With it, green — one of the few times !important is the right tool.</a:t>
+            </a:r>
+            <a:endParaRPr lang="en-US" sz="1300" dirty="0"/>
+          </a:p>
+        </p:txBody>
+      </p:sp>
+      <p:sp>
+        <p:nvSpPr>
+          <p:cNvPr id="7" name="Text 5"/>
+          <p:cNvSpPr txBox="1"/>
+          <p:nvPr/>
+        </p:nvSpPr>
+        <p:spPr>
+          <a:xfrm>
+            <a:off x="640080" y="6446520"/>
+            <a:ext cx="8686800" cy="292608"/>
+          </a:xfrm>
+          <a:prstGeom prst="rect">
+            <a:avLst/>
+          </a:prstGeom>
+          <a:noFill/>
+          <a:ln/>
+        </p:spPr>
+        <p:txBody>
+          <a:bodyPr wrap="square" lIns="0" tIns="0" rIns="0" bIns="0" rtlCol="0" anchor="ctr"/>
+          <a:lstStyle/>
+          <a:p>
+            <a:pPr algn="l" indent="0" marL="0">
+              <a:buNone/>
+            </a:pPr>
+            <a:r>
+              <a:rPr lang="en-US" sz="900" dirty="0">
+                <a:solidFill>
+                  <a:srgbClr val="5D5D72"/>
+                </a:solidFill>
+                <a:latin typeface="Calibri" pitchFamily="34" charset="0"/>
+                <a:ea typeface="Calibri" pitchFamily="34" charset="-122"/>
+                <a:cs typeface="Calibri" pitchFamily="34" charset="-120"/>
+              </a:rPr>
+              <a:t>Usman Akram  •  COMSATS University Islamabad</a:t>
+            </a:r>
+            <a:endParaRPr lang="en-US" sz="900" dirty="0"/>
+          </a:p>
+        </p:txBody>
+      </p:sp>
+      <p:sp>
+        <p:nvSpPr>
+          <p:cNvPr id="8" name="Text 6"/>
+          <p:cNvSpPr txBox="1"/>
+          <p:nvPr/>
+        </p:nvSpPr>
+        <p:spPr>
+          <a:xfrm>
+            <a:off x="11155680" y="6446520"/>
+            <a:ext cx="457200" cy="292608"/>
+          </a:xfrm>
+          <a:prstGeom prst="rect">
+            <a:avLst/>
+          </a:prstGeom>
+          <a:noFill/>
+          <a:ln/>
+        </p:spPr>
+        <p:txBody>
+          <a:bodyPr wrap="square" lIns="0" tIns="0" rIns="0" bIns="0" rtlCol="0" anchor="ctr"/>
+          <a:lstStyle/>
+          <a:p>
+            <a:pPr algn="r" indent="0" marL="0">
+              <a:buNone/>
+            </a:pPr>
+            <a:r>
+              <a:rPr lang="en-US" sz="900" dirty="0">
+                <a:solidFill>
+                  <a:srgbClr val="5D5D72"/>
+                </a:solidFill>
+                <a:latin typeface="Calibri" pitchFamily="34" charset="0"/>
+                <a:ea typeface="Calibri" pitchFamily="34" charset="-122"/>
+                <a:cs typeface="Calibri" pitchFamily="34" charset="-120"/>
+              </a:rPr>
+              <a:t>25</a:t>
+            </a:r>
+            <a:endParaRPr lang="en-US" sz="900" dirty="0"/>
+          </a:p>
+        </p:txBody>
+      </p:sp>
+    </p:spTree>
+  </p:cSld>
+  <p:clrMapOvr>
+    <a:masterClrMapping/>
+  </p:clrMapOvr>
+</p:sld>
+</file>
+
+<file path=ppt/slides/slide26.xml><?xml version="1.0" encoding="utf-8"?>
+<p:sld xmlns:a="http://schemas.openxmlformats.org/drawingml/2006/main" xmlns:r="http://schemas.openxmlformats.org/officeDocument/2006/relationships" xmlns:p="http://schemas.openxmlformats.org/presentationml/2006/main">
+  <p:cSld name="Slide 26">
+    <p:bg>
+      <p:bgPr>
+        <a:solidFill>
+          <a:srgbClr val="FFFFFF"/>
+        </a:solidFill>
+      </p:bgPr>
+    </p:bg>
+    <p:spTree>
+      <p:nvGrpSpPr>
+        <p:cNvPr id="1" name=""/>
+        <p:cNvGrpSpPr/>
+        <p:nvPr/>
+      </p:nvGrpSpPr>
+      <p:grpSpPr>
+        <a:xfrm>
+          <a:off x="0" y="0"/>
+          <a:ext cx="0" cy="0"/>
+          <a:chOff x="0" y="0"/>
+          <a:chExt cx="0" cy="0"/>
+        </a:xfrm>
+      </p:grpSpPr>
+      <p:sp>
+        <p:nvSpPr>
+          <p:cNvPr id="2" name="Text 0"/>
+          <p:cNvSpPr txBox="1"/>
+          <p:nvPr/>
+        </p:nvSpPr>
+        <p:spPr>
+          <a:xfrm>
+            <a:off x="640080" y="457200"/>
+            <a:ext cx="10058400" cy="365760"/>
+          </a:xfrm>
+          <a:prstGeom prst="rect">
+            <a:avLst/>
+          </a:prstGeom>
+          <a:noFill/>
+          <a:ln/>
+        </p:spPr>
+        <p:txBody>
+          <a:bodyPr wrap="square" lIns="0" tIns="0" rIns="0" bIns="0" rtlCol="0" anchor="ctr"/>
+          <a:lstStyle/>
+          <a:p>
+            <a:pPr algn="l" indent="0" marL="0">
+              <a:buNone/>
+            </a:pPr>
+            <a:r>
+              <a:rPr lang="en-US" sz="1300" b="1" spc="300" kern="0" dirty="0">
+                <a:solidFill>
+                  <a:srgbClr val="FF8A3D"/>
+                </a:solidFill>
+                <a:latin typeface="Calibri" pitchFamily="34" charset="0"/>
+                <a:ea typeface="Calibri" pitchFamily="34" charset="-122"/>
+                <a:cs typeface="Calibri" pitchFamily="34" charset="-120"/>
+              </a:rPr>
+              <a:t>THE REAL FORMULA</a:t>
+            </a:r>
+            <a:endParaRPr lang="en-US" sz="1300" dirty="0"/>
+          </a:p>
+        </p:txBody>
+      </p:sp>
+      <p:sp>
+        <p:nvSpPr>
+          <p:cNvPr id="3" name="Text 1"/>
+          <p:cNvSpPr txBox="1"/>
+          <p:nvPr/>
+        </p:nvSpPr>
+        <p:spPr>
+          <a:xfrm>
+            <a:off x="640080" y="841248"/>
+            <a:ext cx="10881360" cy="914400"/>
+          </a:xfrm>
+          <a:prstGeom prst="rect">
+            <a:avLst/>
+          </a:prstGeom>
+          <a:noFill/>
+          <a:ln/>
+        </p:spPr>
+        <p:txBody>
+          <a:bodyPr wrap="square" lIns="0" tIns="0" rIns="0" bIns="0" rtlCol="0" anchor="ctr"/>
+          <a:lstStyle/>
+          <a:p>
+            <a:pPr algn="l" indent="0" marL="0">
+              <a:buNone/>
+            </a:pPr>
+            <a:r>
+              <a:rPr lang="en-US" sz="3400" b="1" dirty="0">
+                <a:solidFill>
+                  <a:srgbClr val="2B2B7A"/>
+                </a:solidFill>
+                <a:latin typeface="Cambria" pitchFamily="34" charset="0"/>
+                <a:ea typeface="Cambria" pitchFamily="34" charset="-122"/>
+                <a:cs typeface="Cambria" pitchFamily="34" charset="-120"/>
+              </a:rPr>
               <a:t>The 4-Part Specificity Score</a:t>
             </a:r>
             <a:endParaRPr lang="en-US" sz="3400" dirty="0"/>
@@ -12559,7 +13631,7 @@
       </p:sp>
       <p:graphicFrame>
         <p:nvGraphicFramePr>
-          <p:cNvPr id="26" name="Table 0"/>
+          <p:cNvPr id="27" name="Table 0"/>
           <p:cNvGraphicFramePr>
             <a:graphicFrameLocks noGrp="1"/>
           </p:cNvGraphicFramePr>
@@ -13388,7 +14460,7 @@
                 <a:ea typeface="Calibri" pitchFamily="34" charset="-122"/>
                 <a:cs typeface="Calibri" pitchFamily="34" charset="-120"/>
               </a:rPr>
-              <a:t>25</a:t>
+              <a:t>26</a:t>
             </a:r>
             <a:endParaRPr lang="en-US" sz="900" dirty="0"/>
           </a:p>
@@ -13402,9 +14474,9 @@
 </p:sld>
 </file>
 
-<file path=ppt/slides/slide26.xml><?xml version="1.0" encoding="utf-8"?>
+<file path=ppt/slides/slide27.xml><?xml version="1.0" encoding="utf-8"?>
 <p:sld xmlns:a="http://schemas.openxmlformats.org/drawingml/2006/main" xmlns:r="http://schemas.openxmlformats.org/officeDocument/2006/relationships" xmlns:p="http://schemas.openxmlformats.org/presentationml/2006/main">
-  <p:cSld name="Slide 26">
+  <p:cSld name="Slide 27">
     <p:bg>
       <p:bgPr>
         <a:solidFill>
@@ -13506,7 +14578,7 @@
       </p:sp>
       <p:graphicFrame>
         <p:nvGraphicFramePr>
-          <p:cNvPr id="27" name="Table 0"/>
+          <p:cNvPr id="28" name="Table 0"/>
           <p:cNvGraphicFramePr>
             <a:graphicFrameLocks noGrp="1"/>
           </p:cNvGraphicFramePr>
@@ -14676,466 +15748,6 @@
                 <a:ea typeface="Calibri" pitchFamily="34" charset="-122"/>
                 <a:cs typeface="Calibri" pitchFamily="34" charset="-120"/>
               </a:rPr>
-              <a:t>26</a:t>
-            </a:r>
-            <a:endParaRPr lang="en-US" sz="900" dirty="0"/>
-          </a:p>
-        </p:txBody>
-      </p:sp>
-    </p:spTree>
-  </p:cSld>
-  <p:clrMapOvr>
-    <a:masterClrMapping/>
-  </p:clrMapOvr>
-</p:sld>
-</file>
-
-<file path=ppt/slides/slide27.xml><?xml version="1.0" encoding="utf-8"?>
-<p:sld xmlns:a="http://schemas.openxmlformats.org/drawingml/2006/main" xmlns:r="http://schemas.openxmlformats.org/officeDocument/2006/relationships" xmlns:p="http://schemas.openxmlformats.org/presentationml/2006/main">
-  <p:cSld name="Slide 27">
-    <p:bg>
-      <p:bgPr>
-        <a:solidFill>
-          <a:srgbClr val="FFFFFF"/>
-        </a:solidFill>
-      </p:bgPr>
-    </p:bg>
-    <p:spTree>
-      <p:nvGrpSpPr>
-        <p:cNvPr id="1" name=""/>
-        <p:cNvGrpSpPr/>
-        <p:nvPr/>
-      </p:nvGrpSpPr>
-      <p:grpSpPr>
-        <a:xfrm>
-          <a:off x="0" y="0"/>
-          <a:ext cx="0" cy="0"/>
-          <a:chOff x="0" y="0"/>
-          <a:chExt cx="0" cy="0"/>
-        </a:xfrm>
-      </p:grpSpPr>
-      <p:sp>
-        <p:nvSpPr>
-          <p:cNvPr id="2" name="Text 0"/>
-          <p:cNvSpPr txBox="1"/>
-          <p:nvPr/>
-        </p:nvSpPr>
-        <p:spPr>
-          <a:xfrm>
-            <a:off x="640080" y="457200"/>
-            <a:ext cx="10058400" cy="365760"/>
-          </a:xfrm>
-          <a:prstGeom prst="rect">
-            <a:avLst/>
-          </a:prstGeom>
-          <a:noFill/>
-          <a:ln/>
-        </p:spPr>
-        <p:txBody>
-          <a:bodyPr wrap="square" lIns="0" tIns="0" rIns="0" bIns="0" rtlCol="0" anchor="ctr"/>
-          <a:lstStyle/>
-          <a:p>
-            <a:pPr algn="l" indent="0" marL="0">
-              <a:buNone/>
-            </a:pPr>
-            <a:r>
-              <a:rPr lang="en-US" sz="1300" b="1" spc="300" kern="0" dirty="0">
-                <a:solidFill>
-                  <a:srgbClr val="FF8A3D"/>
-                </a:solidFill>
-                <a:latin typeface="Calibri" pitchFamily="34" charset="0"/>
-                <a:ea typeface="Calibri" pitchFamily="34" charset="-122"/>
-                <a:cs typeface="Calibri" pitchFamily="34" charset="-120"/>
-              </a:rPr>
-              <a:t>INHERITANCE</a:t>
-            </a:r>
-            <a:endParaRPr lang="en-US" sz="1300" dirty="0"/>
-          </a:p>
-        </p:txBody>
-      </p:sp>
-      <p:sp>
-        <p:nvSpPr>
-          <p:cNvPr id="3" name="Text 1"/>
-          <p:cNvSpPr txBox="1"/>
-          <p:nvPr/>
-        </p:nvSpPr>
-        <p:spPr>
-          <a:xfrm>
-            <a:off x="640080" y="841248"/>
-            <a:ext cx="10881360" cy="914400"/>
-          </a:xfrm>
-          <a:prstGeom prst="rect">
-            <a:avLst/>
-          </a:prstGeom>
-          <a:noFill/>
-          <a:ln/>
-        </p:spPr>
-        <p:txBody>
-          <a:bodyPr wrap="square" lIns="0" tIns="0" rIns="0" bIns="0" rtlCol="0" anchor="ctr"/>
-          <a:lstStyle/>
-          <a:p>
-            <a:pPr algn="l" indent="0" marL="0">
-              <a:buNone/>
-            </a:pPr>
-            <a:r>
-              <a:rPr lang="en-US" sz="3400" b="1" dirty="0">
-                <a:solidFill>
-                  <a:srgbClr val="2B2B7A"/>
-                </a:solidFill>
-                <a:latin typeface="Cambria" pitchFamily="34" charset="0"/>
-                <a:ea typeface="Cambria" pitchFamily="34" charset="-122"/>
-                <a:cs typeface="Cambria" pitchFamily="34" charset="-120"/>
-              </a:rPr>
-              <a:t>An Example Where Inheritance Does NOT Happen</a:t>
-            </a:r>
-            <a:endParaRPr lang="en-US" sz="3400" dirty="0"/>
-          </a:p>
-        </p:txBody>
-      </p:sp>
-      <p:sp>
-        <p:nvSpPr>
-          <p:cNvPr id="4" name="Shape 2"/>
-          <p:cNvSpPr/>
-          <p:nvPr/>
-        </p:nvSpPr>
-        <p:spPr>
-          <a:xfrm>
-            <a:off x="640080" y="1965960"/>
-            <a:ext cx="10911535" cy="3215640"/>
-          </a:xfrm>
-          <a:prstGeom prst="roundRect">
-            <a:avLst>
-              <a:gd name="adj" fmla="val 2275"/>
-            </a:avLst>
-          </a:prstGeom>
-          <a:solidFill>
-            <a:srgbClr val="1E1E4C"/>
-          </a:solidFill>
-          <a:ln/>
-        </p:spPr>
-      </p:sp>
-      <p:sp>
-        <p:nvSpPr>
-          <p:cNvPr id="5" name="Text 3"/>
-          <p:cNvSpPr txBox="1"/>
-          <p:nvPr/>
-        </p:nvSpPr>
-        <p:spPr>
-          <a:xfrm>
-            <a:off x="960120" y="2194560"/>
-            <a:ext cx="10271455" cy="2758440"/>
-          </a:xfrm>
-          <a:prstGeom prst="rect">
-            <a:avLst/>
-          </a:prstGeom>
-          <a:noFill/>
-          <a:ln/>
-        </p:spPr>
-        <p:txBody>
-          <a:bodyPr wrap="square" lIns="0" tIns="0" rIns="0" bIns="0" rtlCol="0" anchor="t"/>
-          <a:lstStyle/>
-          <a:p>
-            <a:pPr indent="0" marL="0">
-              <a:lnSpc>
-                <a:spcPct val="125000"/>
-              </a:lnSpc>
-              <a:buNone/>
-            </a:pPr>
-            <a:r>
-              <a:rPr lang="en-US" sz="1400" dirty="0">
-                <a:solidFill>
-                  <a:srgbClr val="C9D3F5"/>
-                </a:solidFill>
-                <a:latin typeface="Courier New" pitchFamily="34" charset="0"/>
-                <a:ea typeface="Courier New" pitchFamily="34" charset="-122"/>
-                <a:cs typeface="Courier New" pitchFamily="34" charset="-120"/>
-              </a:rPr>
-              <a:t>.parent {</a:t>
-            </a:r>
-            <a:endParaRPr lang="en-US" sz="1400" dirty="0"/>
-          </a:p>
-          <a:p>
-            <a:pPr indent="0" marL="0">
-              <a:lnSpc>
-                <a:spcPct val="125000"/>
-              </a:lnSpc>
-              <a:buNone/>
-            </a:pPr>
-            <a:r>
-              <a:rPr lang="en-US" sz="1400" dirty="0">
-                <a:solidFill>
-                  <a:srgbClr val="C9D3F5"/>
-                </a:solidFill>
-                <a:latin typeface="Courier New" pitchFamily="34" charset="0"/>
-                <a:ea typeface="Courier New" pitchFamily="34" charset="-122"/>
-                <a:cs typeface="Courier New" pitchFamily="34" charset="-120"/>
-              </a:rPr>
-              <a:t>  border: 4px solid crimson;</a:t>
-            </a:r>
-            <a:endParaRPr lang="en-US" sz="1400" dirty="0"/>
-          </a:p>
-          <a:p>
-            <a:pPr indent="0" marL="0">
-              <a:lnSpc>
-                <a:spcPct val="125000"/>
-              </a:lnSpc>
-              <a:buNone/>
-            </a:pPr>
-            <a:r>
-              <a:rPr lang="en-US" sz="1400" dirty="0">
-                <a:solidFill>
-                  <a:srgbClr val="C9D3F5"/>
-                </a:solidFill>
-                <a:latin typeface="Courier New" pitchFamily="34" charset="0"/>
-                <a:ea typeface="Courier New" pitchFamily="34" charset="-122"/>
-                <a:cs typeface="Courier New" pitchFamily="34" charset="-120"/>
-              </a:rPr>
-              <a:t>  padding: 20px;</a:t>
-            </a:r>
-            <a:endParaRPr lang="en-US" sz="1400" dirty="0"/>
-          </a:p>
-          <a:p>
-            <a:pPr indent="0" marL="0">
-              <a:lnSpc>
-                <a:spcPct val="125000"/>
-              </a:lnSpc>
-              <a:buNone/>
-            </a:pPr>
-            <a:r>
-              <a:rPr lang="en-US" sz="1400" dirty="0">
-                <a:solidFill>
-                  <a:srgbClr val="C9D3F5"/>
-                </a:solidFill>
-                <a:latin typeface="Courier New" pitchFamily="34" charset="0"/>
-                <a:ea typeface="Courier New" pitchFamily="34" charset="-122"/>
-                <a:cs typeface="Courier New" pitchFamily="34" charset="-120"/>
-              </a:rPr>
-              <a:t>  color: darkblue;</a:t>
-            </a:r>
-            <a:endParaRPr lang="en-US" sz="1400" dirty="0"/>
-          </a:p>
-          <a:p>
-            <a:pPr indent="0" marL="0">
-              <a:lnSpc>
-                <a:spcPct val="125000"/>
-              </a:lnSpc>
-              <a:buNone/>
-            </a:pPr>
-            <a:r>
-              <a:rPr lang="en-US" sz="1400" dirty="0">
-                <a:solidFill>
-                  <a:srgbClr val="C9D3F5"/>
-                </a:solidFill>
-                <a:latin typeface="Courier New" pitchFamily="34" charset="0"/>
-                <a:ea typeface="Courier New" pitchFamily="34" charset="-122"/>
-                <a:cs typeface="Courier New" pitchFamily="34" charset="-120"/>
-              </a:rPr>
-              <a:t>}</a:t>
-            </a:r>
-            <a:endParaRPr lang="en-US" sz="1400" dirty="0"/>
-          </a:p>
-          <a:p>
-            <a:pPr indent="0" marL="0">
-              <a:lnSpc>
-                <a:spcPct val="125000"/>
-              </a:lnSpc>
-              <a:buNone/>
-            </a:pPr>
-            <a:endParaRPr lang="en-US" sz="1400" dirty="0"/>
-          </a:p>
-          <a:p>
-            <a:pPr indent="0" marL="0">
-              <a:lnSpc>
-                <a:spcPct val="125000"/>
-              </a:lnSpc>
-              <a:buNone/>
-            </a:pPr>
-            <a:r>
-              <a:rPr lang="en-US" sz="1400" dirty="0">
-                <a:solidFill>
-                  <a:srgbClr val="C9D3F5"/>
-                </a:solidFill>
-                <a:latin typeface="Courier New" pitchFamily="34" charset="0"/>
-                <a:ea typeface="Courier New" pitchFamily="34" charset="-122"/>
-                <a:cs typeface="Courier New" pitchFamily="34" charset="-120"/>
-              </a:rPr>
-              <a:t>&lt;div class="parent"&gt;</a:t>
-            </a:r>
-            <a:endParaRPr lang="en-US" sz="1400" dirty="0"/>
-          </a:p>
-          <a:p>
-            <a:pPr indent="0" marL="0">
-              <a:lnSpc>
-                <a:spcPct val="125000"/>
-              </a:lnSpc>
-              <a:buNone/>
-            </a:pPr>
-            <a:r>
-              <a:rPr lang="en-US" sz="1400" dirty="0">
-                <a:solidFill>
-                  <a:srgbClr val="C9D3F5"/>
-                </a:solidFill>
-                <a:latin typeface="Courier New" pitchFamily="34" charset="0"/>
-                <a:ea typeface="Courier New" pitchFamily="34" charset="-122"/>
-                <a:cs typeface="Courier New" pitchFamily="34" charset="-120"/>
-              </a:rPr>
-              <a:t>  Parent text is dark blue.</a:t>
-            </a:r>
-            <a:endParaRPr lang="en-US" sz="1400" dirty="0"/>
-          </a:p>
-          <a:p>
-            <a:pPr indent="0" marL="0">
-              <a:lnSpc>
-                <a:spcPct val="125000"/>
-              </a:lnSpc>
-              <a:buNone/>
-            </a:pPr>
-            <a:r>
-              <a:rPr lang="en-US" sz="1400" dirty="0">
-                <a:solidFill>
-                  <a:srgbClr val="C9D3F5"/>
-                </a:solidFill>
-                <a:latin typeface="Courier New" pitchFamily="34" charset="0"/>
-                <a:ea typeface="Courier New" pitchFamily="34" charset="-122"/>
-                <a:cs typeface="Courier New" pitchFamily="34" charset="-120"/>
-              </a:rPr>
-              <a:t>  &lt;p&gt;Child paragraph is dark blue too.&lt;/p&gt;</a:t>
-            </a:r>
-            <a:endParaRPr lang="en-US" sz="1400" dirty="0"/>
-          </a:p>
-          <a:p>
-            <a:pPr indent="0" marL="0">
-              <a:lnSpc>
-                <a:spcPct val="125000"/>
-              </a:lnSpc>
-              <a:buNone/>
-            </a:pPr>
-            <a:r>
-              <a:rPr lang="en-US" sz="1400" dirty="0">
-                <a:solidFill>
-                  <a:srgbClr val="C9D3F5"/>
-                </a:solidFill>
-                <a:latin typeface="Courier New" pitchFamily="34" charset="0"/>
-                <a:ea typeface="Courier New" pitchFamily="34" charset="-122"/>
-                <a:cs typeface="Courier New" pitchFamily="34" charset="-120"/>
-              </a:rPr>
-              <a:t>&lt;/div&gt;</a:t>
-            </a:r>
-            <a:endParaRPr lang="en-US" sz="1400" dirty="0"/>
-          </a:p>
-        </p:txBody>
-      </p:sp>
-      <p:sp>
-        <p:nvSpPr>
-          <p:cNvPr id="6" name="Text 4"/>
-          <p:cNvSpPr txBox="1"/>
-          <p:nvPr/>
-        </p:nvSpPr>
-        <p:spPr>
-          <a:xfrm>
-            <a:off x="640080" y="5410200"/>
-            <a:ext cx="10911535" cy="853440"/>
-          </a:xfrm>
-          <a:prstGeom prst="rect">
-            <a:avLst/>
-          </a:prstGeom>
-          <a:noFill/>
-          <a:ln/>
-        </p:spPr>
-        <p:txBody>
-          <a:bodyPr wrap="square" lIns="0" tIns="0" rIns="0" bIns="0" rtlCol="0" anchor="t"/>
-          <a:lstStyle/>
-          <a:p>
-            <a:pPr indent="0" marL="0">
-              <a:buNone/>
-            </a:pPr>
-            <a:r>
-              <a:rPr lang="en-US" sz="1300" dirty="0">
-                <a:solidFill>
-                  <a:srgbClr val="26262F"/>
-                </a:solidFill>
-                <a:latin typeface="Calibri" pitchFamily="34" charset="0"/>
-                <a:ea typeface="Calibri" pitchFamily="34" charset="-122"/>
-                <a:cs typeface="Calibri" pitchFamily="34" charset="-120"/>
-              </a:rPr>
-              <a:t>color inherits, so the &lt;p&gt; is dark blue too. border and padding do NOT inherit — only .parent itself gets the crimson outline and padding.</a:t>
-            </a:r>
-            <a:endParaRPr lang="en-US" sz="1300" dirty="0"/>
-          </a:p>
-        </p:txBody>
-      </p:sp>
-      <p:sp>
-        <p:nvSpPr>
-          <p:cNvPr id="7" name="Text 5"/>
-          <p:cNvSpPr txBox="1"/>
-          <p:nvPr/>
-        </p:nvSpPr>
-        <p:spPr>
-          <a:xfrm>
-            <a:off x="640080" y="6446520"/>
-            <a:ext cx="8686800" cy="292608"/>
-          </a:xfrm>
-          <a:prstGeom prst="rect">
-            <a:avLst/>
-          </a:prstGeom>
-          <a:noFill/>
-          <a:ln/>
-        </p:spPr>
-        <p:txBody>
-          <a:bodyPr wrap="square" lIns="0" tIns="0" rIns="0" bIns="0" rtlCol="0" anchor="ctr"/>
-          <a:lstStyle/>
-          <a:p>
-            <a:pPr algn="l" indent="0" marL="0">
-              <a:buNone/>
-            </a:pPr>
-            <a:r>
-              <a:rPr lang="en-US" sz="900" dirty="0">
-                <a:solidFill>
-                  <a:srgbClr val="5D5D72"/>
-                </a:solidFill>
-                <a:latin typeface="Calibri" pitchFamily="34" charset="0"/>
-                <a:ea typeface="Calibri" pitchFamily="34" charset="-122"/>
-                <a:cs typeface="Calibri" pitchFamily="34" charset="-120"/>
-              </a:rPr>
-              <a:t>Usman Akram  •  COMSATS University Islamabad</a:t>
-            </a:r>
-            <a:endParaRPr lang="en-US" sz="900" dirty="0"/>
-          </a:p>
-        </p:txBody>
-      </p:sp>
-      <p:sp>
-        <p:nvSpPr>
-          <p:cNvPr id="8" name="Text 6"/>
-          <p:cNvSpPr txBox="1"/>
-          <p:nvPr/>
-        </p:nvSpPr>
-        <p:spPr>
-          <a:xfrm>
-            <a:off x="11155680" y="6446520"/>
-            <a:ext cx="457200" cy="292608"/>
-          </a:xfrm>
-          <a:prstGeom prst="rect">
-            <a:avLst/>
-          </a:prstGeom>
-          <a:noFill/>
-          <a:ln/>
-        </p:spPr>
-        <p:txBody>
-          <a:bodyPr wrap="square" lIns="0" tIns="0" rIns="0" bIns="0" rtlCol="0" anchor="ctr"/>
-          <a:lstStyle/>
-          <a:p>
-            <a:pPr algn="r" indent="0" marL="0">
-              <a:buNone/>
-            </a:pPr>
-            <a:r>
-              <a:rPr lang="en-US" sz="900" dirty="0">
-                <a:solidFill>
-                  <a:srgbClr val="5D5D72"/>
-                </a:solidFill>
-                <a:latin typeface="Calibri" pitchFamily="34" charset="0"/>
-                <a:ea typeface="Calibri" pitchFamily="34" charset="-122"/>
-                <a:cs typeface="Calibri" pitchFamily="34" charset="-120"/>
-              </a:rPr>
               <a:t>27</a:t>
             </a:r>
             <a:endParaRPr lang="en-US" sz="900" dirty="0"/>
@@ -15246,6 +15858,466 @@
                 <a:ea typeface="Cambria" pitchFamily="34" charset="-122"/>
                 <a:cs typeface="Cambria" pitchFamily="34" charset="-120"/>
               </a:rPr>
+              <a:t>An Example Where Inheritance Does NOT Happen</a:t>
+            </a:r>
+            <a:endParaRPr lang="en-US" sz="3400" dirty="0"/>
+          </a:p>
+        </p:txBody>
+      </p:sp>
+      <p:sp>
+        <p:nvSpPr>
+          <p:cNvPr id="4" name="Shape 2"/>
+          <p:cNvSpPr/>
+          <p:nvPr/>
+        </p:nvSpPr>
+        <p:spPr>
+          <a:xfrm>
+            <a:off x="640080" y="1965960"/>
+            <a:ext cx="10911535" cy="3215640"/>
+          </a:xfrm>
+          <a:prstGeom prst="roundRect">
+            <a:avLst>
+              <a:gd name="adj" fmla="val 2275"/>
+            </a:avLst>
+          </a:prstGeom>
+          <a:solidFill>
+            <a:srgbClr val="1E1E4C"/>
+          </a:solidFill>
+          <a:ln/>
+        </p:spPr>
+      </p:sp>
+      <p:sp>
+        <p:nvSpPr>
+          <p:cNvPr id="5" name="Text 3"/>
+          <p:cNvSpPr txBox="1"/>
+          <p:nvPr/>
+        </p:nvSpPr>
+        <p:spPr>
+          <a:xfrm>
+            <a:off x="960120" y="2194560"/>
+            <a:ext cx="10271455" cy="2758440"/>
+          </a:xfrm>
+          <a:prstGeom prst="rect">
+            <a:avLst/>
+          </a:prstGeom>
+          <a:noFill/>
+          <a:ln/>
+        </p:spPr>
+        <p:txBody>
+          <a:bodyPr wrap="square" lIns="0" tIns="0" rIns="0" bIns="0" rtlCol="0" anchor="t"/>
+          <a:lstStyle/>
+          <a:p>
+            <a:pPr indent="0" marL="0">
+              <a:lnSpc>
+                <a:spcPct val="125000"/>
+              </a:lnSpc>
+              <a:buNone/>
+            </a:pPr>
+            <a:r>
+              <a:rPr lang="en-US" sz="1400" dirty="0">
+                <a:solidFill>
+                  <a:srgbClr val="C9D3F5"/>
+                </a:solidFill>
+                <a:latin typeface="Courier New" pitchFamily="34" charset="0"/>
+                <a:ea typeface="Courier New" pitchFamily="34" charset="-122"/>
+                <a:cs typeface="Courier New" pitchFamily="34" charset="-120"/>
+              </a:rPr>
+              <a:t>.parent {</a:t>
+            </a:r>
+            <a:endParaRPr lang="en-US" sz="1400" dirty="0"/>
+          </a:p>
+          <a:p>
+            <a:pPr indent="0" marL="0">
+              <a:lnSpc>
+                <a:spcPct val="125000"/>
+              </a:lnSpc>
+              <a:buNone/>
+            </a:pPr>
+            <a:r>
+              <a:rPr lang="en-US" sz="1400" dirty="0">
+                <a:solidFill>
+                  <a:srgbClr val="C9D3F5"/>
+                </a:solidFill>
+                <a:latin typeface="Courier New" pitchFamily="34" charset="0"/>
+                <a:ea typeface="Courier New" pitchFamily="34" charset="-122"/>
+                <a:cs typeface="Courier New" pitchFamily="34" charset="-120"/>
+              </a:rPr>
+              <a:t>  border: 4px solid crimson;</a:t>
+            </a:r>
+            <a:endParaRPr lang="en-US" sz="1400" dirty="0"/>
+          </a:p>
+          <a:p>
+            <a:pPr indent="0" marL="0">
+              <a:lnSpc>
+                <a:spcPct val="125000"/>
+              </a:lnSpc>
+              <a:buNone/>
+            </a:pPr>
+            <a:r>
+              <a:rPr lang="en-US" sz="1400" dirty="0">
+                <a:solidFill>
+                  <a:srgbClr val="C9D3F5"/>
+                </a:solidFill>
+                <a:latin typeface="Courier New" pitchFamily="34" charset="0"/>
+                <a:ea typeface="Courier New" pitchFamily="34" charset="-122"/>
+                <a:cs typeface="Courier New" pitchFamily="34" charset="-120"/>
+              </a:rPr>
+              <a:t>  padding: 20px;</a:t>
+            </a:r>
+            <a:endParaRPr lang="en-US" sz="1400" dirty="0"/>
+          </a:p>
+          <a:p>
+            <a:pPr indent="0" marL="0">
+              <a:lnSpc>
+                <a:spcPct val="125000"/>
+              </a:lnSpc>
+              <a:buNone/>
+            </a:pPr>
+            <a:r>
+              <a:rPr lang="en-US" sz="1400" dirty="0">
+                <a:solidFill>
+                  <a:srgbClr val="C9D3F5"/>
+                </a:solidFill>
+                <a:latin typeface="Courier New" pitchFamily="34" charset="0"/>
+                <a:ea typeface="Courier New" pitchFamily="34" charset="-122"/>
+                <a:cs typeface="Courier New" pitchFamily="34" charset="-120"/>
+              </a:rPr>
+              <a:t>  color: darkblue;</a:t>
+            </a:r>
+            <a:endParaRPr lang="en-US" sz="1400" dirty="0"/>
+          </a:p>
+          <a:p>
+            <a:pPr indent="0" marL="0">
+              <a:lnSpc>
+                <a:spcPct val="125000"/>
+              </a:lnSpc>
+              <a:buNone/>
+            </a:pPr>
+            <a:r>
+              <a:rPr lang="en-US" sz="1400" dirty="0">
+                <a:solidFill>
+                  <a:srgbClr val="C9D3F5"/>
+                </a:solidFill>
+                <a:latin typeface="Courier New" pitchFamily="34" charset="0"/>
+                <a:ea typeface="Courier New" pitchFamily="34" charset="-122"/>
+                <a:cs typeface="Courier New" pitchFamily="34" charset="-120"/>
+              </a:rPr>
+              <a:t>}</a:t>
+            </a:r>
+            <a:endParaRPr lang="en-US" sz="1400" dirty="0"/>
+          </a:p>
+          <a:p>
+            <a:pPr indent="0" marL="0">
+              <a:lnSpc>
+                <a:spcPct val="125000"/>
+              </a:lnSpc>
+              <a:buNone/>
+            </a:pPr>
+            <a:endParaRPr lang="en-US" sz="1400" dirty="0"/>
+          </a:p>
+          <a:p>
+            <a:pPr indent="0" marL="0">
+              <a:lnSpc>
+                <a:spcPct val="125000"/>
+              </a:lnSpc>
+              <a:buNone/>
+            </a:pPr>
+            <a:r>
+              <a:rPr lang="en-US" sz="1400" dirty="0">
+                <a:solidFill>
+                  <a:srgbClr val="C9D3F5"/>
+                </a:solidFill>
+                <a:latin typeface="Courier New" pitchFamily="34" charset="0"/>
+                <a:ea typeface="Courier New" pitchFamily="34" charset="-122"/>
+                <a:cs typeface="Courier New" pitchFamily="34" charset="-120"/>
+              </a:rPr>
+              <a:t>&lt;div class="parent"&gt;</a:t>
+            </a:r>
+            <a:endParaRPr lang="en-US" sz="1400" dirty="0"/>
+          </a:p>
+          <a:p>
+            <a:pPr indent="0" marL="0">
+              <a:lnSpc>
+                <a:spcPct val="125000"/>
+              </a:lnSpc>
+              <a:buNone/>
+            </a:pPr>
+            <a:r>
+              <a:rPr lang="en-US" sz="1400" dirty="0">
+                <a:solidFill>
+                  <a:srgbClr val="C9D3F5"/>
+                </a:solidFill>
+                <a:latin typeface="Courier New" pitchFamily="34" charset="0"/>
+                <a:ea typeface="Courier New" pitchFamily="34" charset="-122"/>
+                <a:cs typeface="Courier New" pitchFamily="34" charset="-120"/>
+              </a:rPr>
+              <a:t>  Parent text is dark blue.</a:t>
+            </a:r>
+            <a:endParaRPr lang="en-US" sz="1400" dirty="0"/>
+          </a:p>
+          <a:p>
+            <a:pPr indent="0" marL="0">
+              <a:lnSpc>
+                <a:spcPct val="125000"/>
+              </a:lnSpc>
+              <a:buNone/>
+            </a:pPr>
+            <a:r>
+              <a:rPr lang="en-US" sz="1400" dirty="0">
+                <a:solidFill>
+                  <a:srgbClr val="C9D3F5"/>
+                </a:solidFill>
+                <a:latin typeface="Courier New" pitchFamily="34" charset="0"/>
+                <a:ea typeface="Courier New" pitchFamily="34" charset="-122"/>
+                <a:cs typeface="Courier New" pitchFamily="34" charset="-120"/>
+              </a:rPr>
+              <a:t>  &lt;p&gt;Child paragraph is dark blue too.&lt;/p&gt;</a:t>
+            </a:r>
+            <a:endParaRPr lang="en-US" sz="1400" dirty="0"/>
+          </a:p>
+          <a:p>
+            <a:pPr indent="0" marL="0">
+              <a:lnSpc>
+                <a:spcPct val="125000"/>
+              </a:lnSpc>
+              <a:buNone/>
+            </a:pPr>
+            <a:r>
+              <a:rPr lang="en-US" sz="1400" dirty="0">
+                <a:solidFill>
+                  <a:srgbClr val="C9D3F5"/>
+                </a:solidFill>
+                <a:latin typeface="Courier New" pitchFamily="34" charset="0"/>
+                <a:ea typeface="Courier New" pitchFamily="34" charset="-122"/>
+                <a:cs typeface="Courier New" pitchFamily="34" charset="-120"/>
+              </a:rPr>
+              <a:t>&lt;/div&gt;</a:t>
+            </a:r>
+            <a:endParaRPr lang="en-US" sz="1400" dirty="0"/>
+          </a:p>
+        </p:txBody>
+      </p:sp>
+      <p:sp>
+        <p:nvSpPr>
+          <p:cNvPr id="6" name="Text 4"/>
+          <p:cNvSpPr txBox="1"/>
+          <p:nvPr/>
+        </p:nvSpPr>
+        <p:spPr>
+          <a:xfrm>
+            <a:off x="640080" y="5410200"/>
+            <a:ext cx="10911535" cy="853440"/>
+          </a:xfrm>
+          <a:prstGeom prst="rect">
+            <a:avLst/>
+          </a:prstGeom>
+          <a:noFill/>
+          <a:ln/>
+        </p:spPr>
+        <p:txBody>
+          <a:bodyPr wrap="square" lIns="0" tIns="0" rIns="0" bIns="0" rtlCol="0" anchor="t"/>
+          <a:lstStyle/>
+          <a:p>
+            <a:pPr indent="0" marL="0">
+              <a:buNone/>
+            </a:pPr>
+            <a:r>
+              <a:rPr lang="en-US" sz="1300" dirty="0">
+                <a:solidFill>
+                  <a:srgbClr val="26262F"/>
+                </a:solidFill>
+                <a:latin typeface="Calibri" pitchFamily="34" charset="0"/>
+                <a:ea typeface="Calibri" pitchFamily="34" charset="-122"/>
+                <a:cs typeface="Calibri" pitchFamily="34" charset="-120"/>
+              </a:rPr>
+              <a:t>color inherits, so the &lt;p&gt; is dark blue too. border and padding do NOT inherit — only .parent itself gets the crimson outline and padding.</a:t>
+            </a:r>
+            <a:endParaRPr lang="en-US" sz="1300" dirty="0"/>
+          </a:p>
+        </p:txBody>
+      </p:sp>
+      <p:sp>
+        <p:nvSpPr>
+          <p:cNvPr id="7" name="Text 5"/>
+          <p:cNvSpPr txBox="1"/>
+          <p:nvPr/>
+        </p:nvSpPr>
+        <p:spPr>
+          <a:xfrm>
+            <a:off x="640080" y="6446520"/>
+            <a:ext cx="8686800" cy="292608"/>
+          </a:xfrm>
+          <a:prstGeom prst="rect">
+            <a:avLst/>
+          </a:prstGeom>
+          <a:noFill/>
+          <a:ln/>
+        </p:spPr>
+        <p:txBody>
+          <a:bodyPr wrap="square" lIns="0" tIns="0" rIns="0" bIns="0" rtlCol="0" anchor="ctr"/>
+          <a:lstStyle/>
+          <a:p>
+            <a:pPr algn="l" indent="0" marL="0">
+              <a:buNone/>
+            </a:pPr>
+            <a:r>
+              <a:rPr lang="en-US" sz="900" dirty="0">
+                <a:solidFill>
+                  <a:srgbClr val="5D5D72"/>
+                </a:solidFill>
+                <a:latin typeface="Calibri" pitchFamily="34" charset="0"/>
+                <a:ea typeface="Calibri" pitchFamily="34" charset="-122"/>
+                <a:cs typeface="Calibri" pitchFamily="34" charset="-120"/>
+              </a:rPr>
+              <a:t>Usman Akram  •  COMSATS University Islamabad</a:t>
+            </a:r>
+            <a:endParaRPr lang="en-US" sz="900" dirty="0"/>
+          </a:p>
+        </p:txBody>
+      </p:sp>
+      <p:sp>
+        <p:nvSpPr>
+          <p:cNvPr id="8" name="Text 6"/>
+          <p:cNvSpPr txBox="1"/>
+          <p:nvPr/>
+        </p:nvSpPr>
+        <p:spPr>
+          <a:xfrm>
+            <a:off x="11155680" y="6446520"/>
+            <a:ext cx="457200" cy="292608"/>
+          </a:xfrm>
+          <a:prstGeom prst="rect">
+            <a:avLst/>
+          </a:prstGeom>
+          <a:noFill/>
+          <a:ln/>
+        </p:spPr>
+        <p:txBody>
+          <a:bodyPr wrap="square" lIns="0" tIns="0" rIns="0" bIns="0" rtlCol="0" anchor="ctr"/>
+          <a:lstStyle/>
+          <a:p>
+            <a:pPr algn="r" indent="0" marL="0">
+              <a:buNone/>
+            </a:pPr>
+            <a:r>
+              <a:rPr lang="en-US" sz="900" dirty="0">
+                <a:solidFill>
+                  <a:srgbClr val="5D5D72"/>
+                </a:solidFill>
+                <a:latin typeface="Calibri" pitchFamily="34" charset="0"/>
+                <a:ea typeface="Calibri" pitchFamily="34" charset="-122"/>
+                <a:cs typeface="Calibri" pitchFamily="34" charset="-120"/>
+              </a:rPr>
+              <a:t>28</a:t>
+            </a:r>
+            <a:endParaRPr lang="en-US" sz="900" dirty="0"/>
+          </a:p>
+        </p:txBody>
+      </p:sp>
+    </p:spTree>
+  </p:cSld>
+  <p:clrMapOvr>
+    <a:masterClrMapping/>
+  </p:clrMapOvr>
+</p:sld>
+</file>
+
+<file path=ppt/slides/slide29.xml><?xml version="1.0" encoding="utf-8"?>
+<p:sld xmlns:a="http://schemas.openxmlformats.org/drawingml/2006/main" xmlns:r="http://schemas.openxmlformats.org/officeDocument/2006/relationships" xmlns:p="http://schemas.openxmlformats.org/presentationml/2006/main">
+  <p:cSld name="Slide 29">
+    <p:bg>
+      <p:bgPr>
+        <a:solidFill>
+          <a:srgbClr val="FFFFFF"/>
+        </a:solidFill>
+      </p:bgPr>
+    </p:bg>
+    <p:spTree>
+      <p:nvGrpSpPr>
+        <p:cNvPr id="1" name=""/>
+        <p:cNvGrpSpPr/>
+        <p:nvPr/>
+      </p:nvGrpSpPr>
+      <p:grpSpPr>
+        <a:xfrm>
+          <a:off x="0" y="0"/>
+          <a:ext cx="0" cy="0"/>
+          <a:chOff x="0" y="0"/>
+          <a:chExt cx="0" cy="0"/>
+        </a:xfrm>
+      </p:grpSpPr>
+      <p:sp>
+        <p:nvSpPr>
+          <p:cNvPr id="2" name="Text 0"/>
+          <p:cNvSpPr txBox="1"/>
+          <p:nvPr/>
+        </p:nvSpPr>
+        <p:spPr>
+          <a:xfrm>
+            <a:off x="640080" y="457200"/>
+            <a:ext cx="10058400" cy="365760"/>
+          </a:xfrm>
+          <a:prstGeom prst="rect">
+            <a:avLst/>
+          </a:prstGeom>
+          <a:noFill/>
+          <a:ln/>
+        </p:spPr>
+        <p:txBody>
+          <a:bodyPr wrap="square" lIns="0" tIns="0" rIns="0" bIns="0" rtlCol="0" anchor="ctr"/>
+          <a:lstStyle/>
+          <a:p>
+            <a:pPr algn="l" indent="0" marL="0">
+              <a:buNone/>
+            </a:pPr>
+            <a:r>
+              <a:rPr lang="en-US" sz="1300" b="1" spc="300" kern="0" dirty="0">
+                <a:solidFill>
+                  <a:srgbClr val="FF8A3D"/>
+                </a:solidFill>
+                <a:latin typeface="Calibri" pitchFamily="34" charset="0"/>
+                <a:ea typeface="Calibri" pitchFamily="34" charset="-122"/>
+                <a:cs typeface="Calibri" pitchFamily="34" charset="-120"/>
+              </a:rPr>
+              <a:t>INHERITANCE</a:t>
+            </a:r>
+            <a:endParaRPr lang="en-US" sz="1300" dirty="0"/>
+          </a:p>
+        </p:txBody>
+      </p:sp>
+      <p:sp>
+        <p:nvSpPr>
+          <p:cNvPr id="3" name="Text 1"/>
+          <p:cNvSpPr txBox="1"/>
+          <p:nvPr/>
+        </p:nvSpPr>
+        <p:spPr>
+          <a:xfrm>
+            <a:off x="640080" y="841248"/>
+            <a:ext cx="10881360" cy="914400"/>
+          </a:xfrm>
+          <a:prstGeom prst="rect">
+            <a:avLst/>
+          </a:prstGeom>
+          <a:noFill/>
+          <a:ln/>
+        </p:spPr>
+        <p:txBody>
+          <a:bodyPr wrap="square" lIns="0" tIns="0" rIns="0" bIns="0" rtlCol="0" anchor="ctr"/>
+          <a:lstStyle/>
+          <a:p>
+            <a:pPr algn="l" indent="0" marL="0">
+              <a:buNone/>
+            </a:pPr>
+            <a:r>
+              <a:rPr lang="en-US" sz="3400" b="1" dirty="0">
+                <a:solidFill>
+                  <a:srgbClr val="2B2B7A"/>
+                </a:solidFill>
+                <a:latin typeface="Cambria" pitchFamily="34" charset="0"/>
+                <a:ea typeface="Cambria" pitchFamily="34" charset="-122"/>
+                <a:cs typeface="Cambria" pitchFamily="34" charset="-120"/>
+              </a:rPr>
               <a:t>Inherited vs. Not Inherited</a:t>
             </a:r>
             <a:endParaRPr lang="en-US" sz="3400" dirty="0"/>
@@ -15254,7 +16326,7 @@
       </p:sp>
       <p:graphicFrame>
         <p:nvGraphicFramePr>
-          <p:cNvPr id="29" name="Table 0"/>
+          <p:cNvPr id="30" name="Table 0"/>
           <p:cNvGraphicFramePr>
             <a:graphicFrameLocks noGrp="1"/>
           </p:cNvGraphicFramePr>
@@ -16182,396 +17254,6 @@
                 <a:ea typeface="Calibri" pitchFamily="34" charset="-122"/>
                 <a:cs typeface="Calibri" pitchFamily="34" charset="-120"/>
               </a:rPr>
-              <a:t>28</a:t>
-            </a:r>
-            <a:endParaRPr lang="en-US" sz="900" dirty="0"/>
-          </a:p>
-        </p:txBody>
-      </p:sp>
-    </p:spTree>
-  </p:cSld>
-  <p:clrMapOvr>
-    <a:masterClrMapping/>
-  </p:clrMapOvr>
-</p:sld>
-</file>
-
-<file path=ppt/slides/slide29.xml><?xml version="1.0" encoding="utf-8"?>
-<p:sld xmlns:a="http://schemas.openxmlformats.org/drawingml/2006/main" xmlns:r="http://schemas.openxmlformats.org/officeDocument/2006/relationships" xmlns:p="http://schemas.openxmlformats.org/presentationml/2006/main">
-  <p:cSld name="Slide 29">
-    <p:bg>
-      <p:bgPr>
-        <a:solidFill>
-          <a:srgbClr val="FFFFFF"/>
-        </a:solidFill>
-      </p:bgPr>
-    </p:bg>
-    <p:spTree>
-      <p:nvGrpSpPr>
-        <p:cNvPr id="1" name=""/>
-        <p:cNvGrpSpPr/>
-        <p:nvPr/>
-      </p:nvGrpSpPr>
-      <p:grpSpPr>
-        <a:xfrm>
-          <a:off x="0" y="0"/>
-          <a:ext cx="0" cy="0"/>
-          <a:chOff x="0" y="0"/>
-          <a:chExt cx="0" cy="0"/>
-        </a:xfrm>
-      </p:grpSpPr>
-      <p:sp>
-        <p:nvSpPr>
-          <p:cNvPr id="2" name="Text 0"/>
-          <p:cNvSpPr txBox="1"/>
-          <p:nvPr/>
-        </p:nvSpPr>
-        <p:spPr>
-          <a:xfrm>
-            <a:off x="640080" y="457200"/>
-            <a:ext cx="10058400" cy="365760"/>
-          </a:xfrm>
-          <a:prstGeom prst="rect">
-            <a:avLst/>
-          </a:prstGeom>
-          <a:noFill/>
-          <a:ln/>
-        </p:spPr>
-        <p:txBody>
-          <a:bodyPr wrap="square" lIns="0" tIns="0" rIns="0" bIns="0" rtlCol="0" anchor="ctr"/>
-          <a:lstStyle/>
-          <a:p>
-            <a:pPr algn="l" indent="0" marL="0">
-              <a:buNone/>
-            </a:pPr>
-            <a:r>
-              <a:rPr lang="en-US" sz="1300" b="1" spc="300" kern="0" dirty="0">
-                <a:solidFill>
-                  <a:srgbClr val="FF8A3D"/>
-                </a:solidFill>
-                <a:latin typeface="Calibri" pitchFamily="34" charset="0"/>
-                <a:ea typeface="Calibri" pitchFamily="34" charset="-122"/>
-                <a:cs typeface="Calibri" pitchFamily="34" charset="-120"/>
-              </a:rPr>
-              <a:t>COLOUR</a:t>
-            </a:r>
-            <a:endParaRPr lang="en-US" sz="1300" dirty="0"/>
-          </a:p>
-        </p:txBody>
-      </p:sp>
-      <p:sp>
-        <p:nvSpPr>
-          <p:cNvPr id="3" name="Text 1"/>
-          <p:cNvSpPr txBox="1"/>
-          <p:nvPr/>
-        </p:nvSpPr>
-        <p:spPr>
-          <a:xfrm>
-            <a:off x="640080" y="841248"/>
-            <a:ext cx="10881360" cy="914400"/>
-          </a:xfrm>
-          <a:prstGeom prst="rect">
-            <a:avLst/>
-          </a:prstGeom>
-          <a:noFill/>
-          <a:ln/>
-        </p:spPr>
-        <p:txBody>
-          <a:bodyPr wrap="square" lIns="0" tIns="0" rIns="0" bIns="0" rtlCol="0" anchor="ctr"/>
-          <a:lstStyle/>
-          <a:p>
-            <a:pPr algn="l" indent="0" marL="0">
-              <a:buNone/>
-            </a:pPr>
-            <a:r>
-              <a:rPr lang="en-US" sz="3400" b="1" dirty="0">
-                <a:solidFill>
-                  <a:srgbClr val="2B2B7A"/>
-                </a:solidFill>
-                <a:latin typeface="Cambria" pitchFamily="34" charset="0"/>
-                <a:ea typeface="Cambria" pitchFamily="34" charset="-122"/>
-                <a:cs typeface="Cambria" pitchFamily="34" charset="-120"/>
-              </a:rPr>
-              <a:t>Five Ways to Write a Colour</a:t>
-            </a:r>
-            <a:endParaRPr lang="en-US" sz="3400" dirty="0"/>
-          </a:p>
-        </p:txBody>
-      </p:sp>
-      <p:sp>
-        <p:nvSpPr>
-          <p:cNvPr id="4" name="Shape 2"/>
-          <p:cNvSpPr/>
-          <p:nvPr/>
-        </p:nvSpPr>
-        <p:spPr>
-          <a:xfrm>
-            <a:off x="640080" y="1965960"/>
-            <a:ext cx="10911535" cy="1739265"/>
-          </a:xfrm>
-          <a:prstGeom prst="roundRect">
-            <a:avLst>
-              <a:gd name="adj" fmla="val 4206"/>
-            </a:avLst>
-          </a:prstGeom>
-          <a:solidFill>
-            <a:srgbClr val="1E1E4C"/>
-          </a:solidFill>
-          <a:ln/>
-        </p:spPr>
-      </p:sp>
-      <p:sp>
-        <p:nvSpPr>
-          <p:cNvPr id="5" name="Text 3"/>
-          <p:cNvSpPr txBox="1"/>
-          <p:nvPr/>
-        </p:nvSpPr>
-        <p:spPr>
-          <a:xfrm>
-            <a:off x="960120" y="2194560"/>
-            <a:ext cx="10271455" cy="1282065"/>
-          </a:xfrm>
-          <a:prstGeom prst="rect">
-            <a:avLst/>
-          </a:prstGeom>
-          <a:noFill/>
-          <a:ln/>
-        </p:spPr>
-        <p:txBody>
-          <a:bodyPr wrap="square" lIns="0" tIns="0" rIns="0" bIns="0" rtlCol="0" anchor="t"/>
-          <a:lstStyle/>
-          <a:p>
-            <a:pPr indent="0" marL="0">
-              <a:lnSpc>
-                <a:spcPct val="125000"/>
-              </a:lnSpc>
-              <a:buNone/>
-            </a:pPr>
-            <a:r>
-              <a:rPr lang="en-US" sz="1250" dirty="0">
-                <a:solidFill>
-                  <a:srgbClr val="C9D3F5"/>
-                </a:solidFill>
-                <a:latin typeface="Courier New" pitchFamily="34" charset="0"/>
-                <a:ea typeface="Courier New" pitchFamily="34" charset="-122"/>
-                <a:cs typeface="Courier New" pitchFamily="34" charset="-120"/>
-              </a:rPr>
-              <a:t>.a { color: red; }                  /* named colour */</a:t>
-            </a:r>
-            <a:endParaRPr lang="en-US" sz="1250" dirty="0"/>
-          </a:p>
-          <a:p>
-            <a:pPr indent="0" marL="0">
-              <a:lnSpc>
-                <a:spcPct val="125000"/>
-              </a:lnSpc>
-              <a:buNone/>
-            </a:pPr>
-            <a:r>
-              <a:rPr lang="en-US" sz="1250" dirty="0">
-                <a:solidFill>
-                  <a:srgbClr val="C9D3F5"/>
-                </a:solidFill>
-                <a:latin typeface="Courier New" pitchFamily="34" charset="0"/>
-                <a:ea typeface="Courier New" pitchFamily="34" charset="-122"/>
-                <a:cs typeface="Courier New" pitchFamily="34" charset="-120"/>
-              </a:rPr>
-              <a:t>.b { color: #ff0000; }              /* hex code */</a:t>
-            </a:r>
-            <a:endParaRPr lang="en-US" sz="1250" dirty="0"/>
-          </a:p>
-          <a:p>
-            <a:pPr indent="0" marL="0">
-              <a:lnSpc>
-                <a:spcPct val="125000"/>
-              </a:lnSpc>
-              <a:buNone/>
-            </a:pPr>
-            <a:r>
-              <a:rPr lang="en-US" sz="1250" dirty="0">
-                <a:solidFill>
-                  <a:srgbClr val="C9D3F5"/>
-                </a:solidFill>
-                <a:latin typeface="Courier New" pitchFamily="34" charset="0"/>
-                <a:ea typeface="Courier New" pitchFamily="34" charset="-122"/>
-                <a:cs typeface="Courier New" pitchFamily="34" charset="-120"/>
-              </a:rPr>
-              <a:t>.c { color: rgb(255, 0, 0); }       /* red, green, blue */</a:t>
-            </a:r>
-            <a:endParaRPr lang="en-US" sz="1250" dirty="0"/>
-          </a:p>
-          <a:p>
-            <a:pPr indent="0" marL="0">
-              <a:lnSpc>
-                <a:spcPct val="125000"/>
-              </a:lnSpc>
-              <a:buNone/>
-            </a:pPr>
-            <a:r>
-              <a:rPr lang="en-US" sz="1250" dirty="0">
-                <a:solidFill>
-                  <a:srgbClr val="C9D3F5"/>
-                </a:solidFill>
-                <a:latin typeface="Courier New" pitchFamily="34" charset="0"/>
-                <a:ea typeface="Courier New" pitchFamily="34" charset="-122"/>
-                <a:cs typeface="Courier New" pitchFamily="34" charset="-120"/>
-              </a:rPr>
-              <a:t>.d { color: rgba(255, 0, 0, 0.5); } /* rgb + alpha */</a:t>
-            </a:r>
-            <a:endParaRPr lang="en-US" sz="1250" dirty="0"/>
-          </a:p>
-          <a:p>
-            <a:pPr indent="0" marL="0">
-              <a:lnSpc>
-                <a:spcPct val="125000"/>
-              </a:lnSpc>
-              <a:buNone/>
-            </a:pPr>
-            <a:r>
-              <a:rPr lang="en-US" sz="1250" dirty="0">
-                <a:solidFill>
-                  <a:srgbClr val="C9D3F5"/>
-                </a:solidFill>
-                <a:latin typeface="Courier New" pitchFamily="34" charset="0"/>
-                <a:ea typeface="Courier New" pitchFamily="34" charset="-122"/>
-                <a:cs typeface="Courier New" pitchFamily="34" charset="-120"/>
-              </a:rPr>
-              <a:t>.e { color: hsl(0, 100%, 50%); }    /* hue, sat, lightness */</a:t>
-            </a:r>
-            <a:endParaRPr lang="en-US" sz="1250" dirty="0"/>
-          </a:p>
-        </p:txBody>
-      </p:sp>
-      <p:sp>
-        <p:nvSpPr>
-          <p:cNvPr id="6" name="Shape 4"/>
-          <p:cNvSpPr/>
-          <p:nvPr/>
-        </p:nvSpPr>
-        <p:spPr>
-          <a:xfrm>
-            <a:off x="530352" y="3869817"/>
-            <a:ext cx="11130991" cy="2457831"/>
-          </a:xfrm>
-          <a:prstGeom prst="roundRect">
-            <a:avLst>
-              <a:gd name="adj" fmla="val 2232"/>
-            </a:avLst>
-          </a:prstGeom>
-          <a:solidFill>
-            <a:srgbClr val="FFFFFF"/>
-          </a:solidFill>
-          <a:ln w="12700">
-            <a:solidFill>
-              <a:srgbClr val="E2E2EE"/>
-            </a:solidFill>
-            <a:prstDash val="solid"/>
-          </a:ln>
-          <a:effectLst>
-            <a:outerShdw sx="100000" sy="100000" kx="0" ky="0" algn="bl" rotWithShape="0" blurRad="101600" dist="38100" dir="5400000">
-              <a:srgbClr val="000000">
-                <a:alpha val="12000"/>
-              </a:srgbClr>
-            </a:outerShdw>
-          </a:effectLst>
-        </p:spPr>
-      </p:sp>
-      <p:pic>
-        <p:nvPicPr>
-          <p:cNvPr id="7" name="Image 0" descr="D:/GitHub/mern-web-book/docs/assets/img/lecture-05/color-values.png">    </p:cNvPr>
-          <p:cNvPicPr>
-            <a:picLocks noChangeAspect="1"/>
-          </p:cNvPicPr>
-          <p:nvPr/>
-        </p:nvPicPr>
-        <p:blipFill>
-          <a:blip r:embed="rId1"/>
-          <a:stretch>
-            <a:fillRect/>
-          </a:stretch>
-        </p:blipFill>
-        <p:spPr>
-          <a:xfrm>
-            <a:off x="3781381" y="3979545"/>
-            <a:ext cx="4628934" cy="2238375"/>
-          </a:xfrm>
-          <a:prstGeom prst="rect">
-            <a:avLst/>
-          </a:prstGeom>
-        </p:spPr>
-      </p:pic>
-      <p:sp>
-        <p:nvSpPr>
-          <p:cNvPr id="8" name="Text 5"/>
-          <p:cNvSpPr txBox="1"/>
-          <p:nvPr/>
-        </p:nvSpPr>
-        <p:spPr>
-          <a:xfrm>
-            <a:off x="640080" y="6446520"/>
-            <a:ext cx="8686800" cy="292608"/>
-          </a:xfrm>
-          <a:prstGeom prst="rect">
-            <a:avLst/>
-          </a:prstGeom>
-          <a:noFill/>
-          <a:ln/>
-        </p:spPr>
-        <p:txBody>
-          <a:bodyPr wrap="square" lIns="0" tIns="0" rIns="0" bIns="0" rtlCol="0" anchor="ctr"/>
-          <a:lstStyle/>
-          <a:p>
-            <a:pPr algn="l" indent="0" marL="0">
-              <a:buNone/>
-            </a:pPr>
-            <a:r>
-              <a:rPr lang="en-US" sz="900" dirty="0">
-                <a:solidFill>
-                  <a:srgbClr val="5D5D72"/>
-                </a:solidFill>
-                <a:latin typeface="Calibri" pitchFamily="34" charset="0"/>
-                <a:ea typeface="Calibri" pitchFamily="34" charset="-122"/>
-                <a:cs typeface="Calibri" pitchFamily="34" charset="-120"/>
-              </a:rPr>
-              <a:t>Usman Akram  •  COMSATS University Islamabad</a:t>
-            </a:r>
-            <a:endParaRPr lang="en-US" sz="900" dirty="0"/>
-          </a:p>
-        </p:txBody>
-      </p:sp>
-      <p:sp>
-        <p:nvSpPr>
-          <p:cNvPr id="9" name="Text 6"/>
-          <p:cNvSpPr txBox="1"/>
-          <p:nvPr/>
-        </p:nvSpPr>
-        <p:spPr>
-          <a:xfrm>
-            <a:off x="11155680" y="6446520"/>
-            <a:ext cx="457200" cy="292608"/>
-          </a:xfrm>
-          <a:prstGeom prst="rect">
-            <a:avLst/>
-          </a:prstGeom>
-          <a:noFill/>
-          <a:ln/>
-        </p:spPr>
-        <p:txBody>
-          <a:bodyPr wrap="square" lIns="0" tIns="0" rIns="0" bIns="0" rtlCol="0" anchor="ctr"/>
-          <a:lstStyle/>
-          <a:p>
-            <a:pPr algn="r" indent="0" marL="0">
-              <a:buNone/>
-            </a:pPr>
-            <a:r>
-              <a:rPr lang="en-US" sz="900" dirty="0">
-                <a:solidFill>
-                  <a:srgbClr val="5D5D72"/>
-                </a:solidFill>
-                <a:latin typeface="Calibri" pitchFamily="34" charset="0"/>
-                <a:ea typeface="Calibri" pitchFamily="34" charset="-122"/>
-                <a:cs typeface="Calibri" pitchFamily="34" charset="-120"/>
-              </a:rPr>
               <a:t>29</a:t>
             </a:r>
             <a:endParaRPr lang="en-US" sz="900" dirty="0"/>
@@ -17223,7 +17905,7 @@
                 <a:ea typeface="Calibri" pitchFamily="34" charset="-122"/>
                 <a:cs typeface="Calibri" pitchFamily="34" charset="-120"/>
               </a:rPr>
-              <a:t>FONTS</a:t>
+              <a:t>COLOUR</a:t>
             </a:r>
             <a:endParaRPr lang="en-US" sz="1300" dirty="0"/>
           </a:p>
@@ -17262,7 +17944,7 @@
                 <a:ea typeface="Cambria" pitchFamily="34" charset="-122"/>
                 <a:cs typeface="Cambria" pitchFamily="34" charset="-120"/>
               </a:rPr>
-              <a:t>Font Properties</a:t>
+              <a:t>Five Ways to Write a Colour</a:t>
             </a:r>
             <a:endParaRPr lang="en-US" sz="3400" dirty="0"/>
           </a:p>
@@ -17270,57 +17952,18 @@
       </p:sp>
       <p:sp>
         <p:nvSpPr>
-          <p:cNvPr id="4" name="Text 2"/>
-          <p:cNvSpPr txBox="1"/>
-          <p:nvPr/>
-        </p:nvSpPr>
-        <p:spPr>
-          <a:xfrm>
-            <a:off x="640080" y="1691640"/>
-            <a:ext cx="10911535" cy="411480"/>
-          </a:xfrm>
-          <a:prstGeom prst="rect">
-            <a:avLst/>
-          </a:prstGeom>
-          <a:noFill/>
-          <a:ln/>
-        </p:spPr>
-        <p:txBody>
-          <a:bodyPr wrap="square" lIns="0" tIns="0" rIns="0" bIns="0" rtlCol="0" anchor="ctr"/>
-          <a:lstStyle/>
-          <a:p>
-            <a:pPr indent="0" marL="0">
-              <a:buNone/>
-            </a:pPr>
-            <a:r>
-              <a:rPr lang="en-US" sz="1350" i="1" dirty="0">
-                <a:solidFill>
-                  <a:srgbClr val="5D5D72"/>
-                </a:solidFill>
-                <a:latin typeface="Calibri" pitchFamily="34" charset="0"/>
-                <a:ea typeface="Calibri" pitchFamily="34" charset="-122"/>
-                <a:cs typeface="Calibri" pitchFamily="34" charset="-120"/>
-              </a:rPr>
-              <a:t>font-family (a fallback list), font-size, font-weight, font-style — combined via the font shorthand too.</a:t>
-            </a:r>
-            <a:endParaRPr lang="en-US" sz="1350" dirty="0"/>
-          </a:p>
-        </p:txBody>
-      </p:sp>
-      <p:sp>
-        <p:nvSpPr>
-          <p:cNvPr id="5" name="Shape 3"/>
+          <p:cNvPr id="4" name="Shape 2"/>
           <p:cNvSpPr/>
           <p:nvPr/>
         </p:nvSpPr>
         <p:spPr>
           <a:xfrm>
-            <a:off x="640080" y="2240280"/>
-            <a:ext cx="10911535" cy="1977390"/>
+            <a:off x="640080" y="1965960"/>
+            <a:ext cx="10911535" cy="1739265"/>
           </a:xfrm>
           <a:prstGeom prst="roundRect">
             <a:avLst>
-              <a:gd name="adj" fmla="val 3699"/>
+              <a:gd name="adj" fmla="val 4206"/>
             </a:avLst>
           </a:prstGeom>
           <a:solidFill>
@@ -17331,14 +17974,14 @@
       </p:sp>
       <p:sp>
         <p:nvSpPr>
-          <p:cNvPr id="6" name="Text 4"/>
+          <p:cNvPr id="5" name="Text 3"/>
           <p:cNvSpPr txBox="1"/>
           <p:nvPr/>
         </p:nvSpPr>
         <p:spPr>
           <a:xfrm>
-            <a:off x="960120" y="2468880"/>
-            <a:ext cx="10271455" cy="1520190"/>
+            <a:off x="960120" y="2194560"/>
+            <a:ext cx="10271455" cy="1282065"/>
           </a:xfrm>
           <a:prstGeom prst="rect">
             <a:avLst/>
@@ -17365,7 +18008,7 @@
                 <a:ea typeface="Courier New" pitchFamily="34" charset="-122"/>
                 <a:cs typeface="Courier New" pitchFamily="34" charset="-120"/>
               </a:rPr>
-              <a:t>p {</a:t>
+              <a:t>.a { color: red; }                  /* named colour */</a:t>
             </a:r>
             <a:endParaRPr lang="en-US" sz="1250" dirty="0"/>
           </a:p>
@@ -17385,7 +18028,7 @@
                 <a:ea typeface="Courier New" pitchFamily="34" charset="-122"/>
                 <a:cs typeface="Courier New" pitchFamily="34" charset="-120"/>
               </a:rPr>
-              <a:t>  font-family: "Helvetica Neue", Arial, sans-serif;</a:t>
+              <a:t>.b { color: #ff0000; }              /* hex code */</a:t>
             </a:r>
             <a:endParaRPr lang="en-US" sz="1250" dirty="0"/>
           </a:p>
@@ -17405,7 +18048,7 @@
                 <a:ea typeface="Courier New" pitchFamily="34" charset="-122"/>
                 <a:cs typeface="Courier New" pitchFamily="34" charset="-120"/>
               </a:rPr>
-              <a:t>  font-size: 16px;</a:t>
+              <a:t>.c { color: rgb(255, 0, 0); }       /* red, green, blue */</a:t>
             </a:r>
             <a:endParaRPr lang="en-US" sz="1250" dirty="0"/>
           </a:p>
@@ -17425,7 +18068,7 @@
                 <a:ea typeface="Courier New" pitchFamily="34" charset="-122"/>
                 <a:cs typeface="Courier New" pitchFamily="34" charset="-120"/>
               </a:rPr>
-              <a:t>  font-weight: bold;</a:t>
+              <a:t>.d { color: rgba(255, 0, 0, 0.5); } /* rgb + alpha */</a:t>
             </a:r>
             <a:endParaRPr lang="en-US" sz="1250" dirty="0"/>
           </a:p>
@@ -17445,46 +18088,26 @@
                 <a:ea typeface="Courier New" pitchFamily="34" charset="-122"/>
                 <a:cs typeface="Courier New" pitchFamily="34" charset="-120"/>
               </a:rPr>
-              <a:t>  font-style: italic;</a:t>
+              <a:t>.e { color: hsl(0, 100%, 50%); }    /* hue, sat, lightness */</a:t>
             </a:r>
             <a:endParaRPr lang="en-US" sz="1250" dirty="0"/>
           </a:p>
-          <a:p>
-            <a:pPr indent="0" marL="0">
-              <a:lnSpc>
-                <a:spcPct val="125000"/>
-              </a:lnSpc>
-              <a:buNone/>
-            </a:pPr>
-            <a:r>
-              <a:rPr lang="en-US" sz="1250" dirty="0">
-                <a:solidFill>
-                  <a:srgbClr val="C9D3F5"/>
-                </a:solidFill>
-                <a:latin typeface="Courier New" pitchFamily="34" charset="0"/>
-                <a:ea typeface="Courier New" pitchFamily="34" charset="-122"/>
-                <a:cs typeface="Courier New" pitchFamily="34" charset="-120"/>
-              </a:rPr>
-              <a:t>}</a:t>
-            </a:r>
-            <a:endParaRPr lang="en-US" sz="1250" dirty="0"/>
-          </a:p>
-        </p:txBody>
-      </p:sp>
-      <p:sp>
-        <p:nvSpPr>
-          <p:cNvPr id="7" name="Shape 5"/>
+        </p:txBody>
+      </p:sp>
+      <p:sp>
+        <p:nvSpPr>
+          <p:cNvPr id="6" name="Shape 4"/>
           <p:cNvSpPr/>
           <p:nvPr/>
         </p:nvSpPr>
         <p:spPr>
           <a:xfrm>
-            <a:off x="530352" y="4382262"/>
-            <a:ext cx="11130991" cy="1945386"/>
+            <a:off x="530352" y="3869817"/>
+            <a:ext cx="11130991" cy="2457831"/>
           </a:xfrm>
           <a:prstGeom prst="roundRect">
             <a:avLst>
-              <a:gd name="adj" fmla="val 2820"/>
+              <a:gd name="adj" fmla="val 2232"/>
             </a:avLst>
           </a:prstGeom>
           <a:solidFill>
@@ -17507,7 +18130,7 @@
       </p:sp>
       <p:pic>
         <p:nvPicPr>
-          <p:cNvPr id="8" name="Image 0" descr="D:/GitHub/mern-web-book/docs/assets/img/lecture-05/font-properties.png">    </p:cNvPr>
+          <p:cNvPr id="7" name="Image 0" descr="D:/GitHub/mern-web-book/docs/assets/img/lecture-05/color-values.png">    </p:cNvPr>
           <p:cNvPicPr>
             <a:picLocks noChangeAspect="1"/>
           </p:cNvPicPr>
@@ -17521,8 +18144,8 @@
         </p:blipFill>
         <p:spPr>
           <a:xfrm>
-            <a:off x="640080" y="5049654"/>
-            <a:ext cx="10911535" cy="610602"/>
+            <a:off x="3781381" y="3979545"/>
+            <a:ext cx="4628934" cy="2238375"/>
           </a:xfrm>
           <a:prstGeom prst="rect">
             <a:avLst/>
@@ -17531,7 +18154,7 @@
       </p:pic>
       <p:sp>
         <p:nvSpPr>
-          <p:cNvPr id="9" name="Text 6"/>
+          <p:cNvPr id="8" name="Text 5"/>
           <p:cNvSpPr txBox="1"/>
           <p:nvPr/>
         </p:nvSpPr>
@@ -17570,7 +18193,7 @@
       </p:sp>
       <p:sp>
         <p:nvSpPr>
-          <p:cNvPr id="10" name="Text 7"/>
+          <p:cNvPr id="9" name="Text 6"/>
           <p:cNvSpPr txBox="1"/>
           <p:nvPr/>
         </p:nvSpPr>
@@ -17672,7 +18295,7 @@
                 <a:ea typeface="Calibri" pitchFamily="34" charset="-122"/>
                 <a:cs typeface="Calibri" pitchFamily="34" charset="-120"/>
               </a:rPr>
-              <a:t>TEXT</a:t>
+              <a:t>FONTS</a:t>
             </a:r>
             <a:endParaRPr lang="en-US" sz="1300" dirty="0"/>
           </a:p>
@@ -17711,7 +18334,7 @@
                 <a:ea typeface="Cambria" pitchFamily="34" charset="-122"/>
                 <a:cs typeface="Cambria" pitchFamily="34" charset="-120"/>
               </a:rPr>
-              <a:t>Text Properties</a:t>
+              <a:t>Font Properties</a:t>
             </a:r>
             <a:endParaRPr lang="en-US" sz="3400" dirty="0"/>
           </a:p>
@@ -17719,18 +18342,57 @@
       </p:sp>
       <p:sp>
         <p:nvSpPr>
-          <p:cNvPr id="4" name="Shape 2"/>
+          <p:cNvPr id="4" name="Text 2"/>
+          <p:cNvSpPr txBox="1"/>
+          <p:nvPr/>
+        </p:nvSpPr>
+        <p:spPr>
+          <a:xfrm>
+            <a:off x="640080" y="1691640"/>
+            <a:ext cx="10911535" cy="411480"/>
+          </a:xfrm>
+          <a:prstGeom prst="rect">
+            <a:avLst/>
+          </a:prstGeom>
+          <a:noFill/>
+          <a:ln/>
+        </p:spPr>
+        <p:txBody>
+          <a:bodyPr wrap="square" lIns="0" tIns="0" rIns="0" bIns="0" rtlCol="0" anchor="ctr"/>
+          <a:lstStyle/>
+          <a:p>
+            <a:pPr indent="0" marL="0">
+              <a:buNone/>
+            </a:pPr>
+            <a:r>
+              <a:rPr lang="en-US" sz="1350" i="1" dirty="0">
+                <a:solidFill>
+                  <a:srgbClr val="5D5D72"/>
+                </a:solidFill>
+                <a:latin typeface="Calibri" pitchFamily="34" charset="0"/>
+                <a:ea typeface="Calibri" pitchFamily="34" charset="-122"/>
+                <a:cs typeface="Calibri" pitchFamily="34" charset="-120"/>
+              </a:rPr>
+              <a:t>font-family (a fallback list), font-size, font-weight, font-style — combined via the font shorthand too.</a:t>
+            </a:r>
+            <a:endParaRPr lang="en-US" sz="1350" dirty="0"/>
+          </a:p>
+        </p:txBody>
+      </p:sp>
+      <p:sp>
+        <p:nvSpPr>
+          <p:cNvPr id="5" name="Shape 3"/>
           <p:cNvSpPr/>
           <p:nvPr/>
         </p:nvSpPr>
         <p:spPr>
           <a:xfrm>
-            <a:off x="640080" y="1965960"/>
-            <a:ext cx="10911535" cy="2215515"/>
+            <a:off x="640080" y="2240280"/>
+            <a:ext cx="10911535" cy="1977390"/>
           </a:xfrm>
           <a:prstGeom prst="roundRect">
             <a:avLst>
-              <a:gd name="adj" fmla="val 3302"/>
+              <a:gd name="adj" fmla="val 3699"/>
             </a:avLst>
           </a:prstGeom>
           <a:solidFill>
@@ -17741,14 +18403,14 @@
       </p:sp>
       <p:sp>
         <p:nvSpPr>
-          <p:cNvPr id="5" name="Text 3"/>
+          <p:cNvPr id="6" name="Text 4"/>
           <p:cNvSpPr txBox="1"/>
           <p:nvPr/>
         </p:nvSpPr>
         <p:spPr>
           <a:xfrm>
-            <a:off x="960120" y="2194560"/>
-            <a:ext cx="10271455" cy="1758315"/>
+            <a:off x="960120" y="2468880"/>
+            <a:ext cx="10271455" cy="1520190"/>
           </a:xfrm>
           <a:prstGeom prst="rect">
             <a:avLst/>
@@ -17795,7 +18457,7 @@
                 <a:ea typeface="Courier New" pitchFamily="34" charset="-122"/>
                 <a:cs typeface="Courier New" pitchFamily="34" charset="-120"/>
               </a:rPr>
-              <a:t>  text-align: center;</a:t>
+              <a:t>  font-family: "Helvetica Neue", Arial, sans-serif;</a:t>
             </a:r>
             <a:endParaRPr lang="en-US" sz="1250" dirty="0"/>
           </a:p>
@@ -17815,7 +18477,7 @@
                 <a:ea typeface="Courier New" pitchFamily="34" charset="-122"/>
                 <a:cs typeface="Courier New" pitchFamily="34" charset="-120"/>
               </a:rPr>
-              <a:t>  text-decoration: underline;</a:t>
+              <a:t>  font-size: 16px;</a:t>
             </a:r>
             <a:endParaRPr lang="en-US" sz="1250" dirty="0"/>
           </a:p>
@@ -17835,7 +18497,7 @@
                 <a:ea typeface="Courier New" pitchFamily="34" charset="-122"/>
                 <a:cs typeface="Courier New" pitchFamily="34" charset="-120"/>
               </a:rPr>
-              <a:t>  text-transform: uppercase;</a:t>
+              <a:t>  font-weight: bold;</a:t>
             </a:r>
             <a:endParaRPr lang="en-US" sz="1250" dirty="0"/>
           </a:p>
@@ -17855,7 +18517,7 @@
                 <a:ea typeface="Courier New" pitchFamily="34" charset="-122"/>
                 <a:cs typeface="Courier New" pitchFamily="34" charset="-120"/>
               </a:rPr>
-              <a:t>  line-height: 1.6;</a:t>
+              <a:t>  font-style: italic;</a:t>
             </a:r>
             <a:endParaRPr lang="en-US" sz="1250" dirty="0"/>
           </a:p>
@@ -17875,46 +18537,26 @@
                 <a:ea typeface="Courier New" pitchFamily="34" charset="-122"/>
                 <a:cs typeface="Courier New" pitchFamily="34" charset="-120"/>
               </a:rPr>
-              <a:t>  letter-spacing: 0.5px;</a:t>
+              <a:t>}</a:t>
             </a:r>
             <a:endParaRPr lang="en-US" sz="1250" dirty="0"/>
           </a:p>
-          <a:p>
-            <a:pPr indent="0" marL="0">
-              <a:lnSpc>
-                <a:spcPct val="125000"/>
-              </a:lnSpc>
-              <a:buNone/>
-            </a:pPr>
-            <a:r>
-              <a:rPr lang="en-US" sz="1250" dirty="0">
-                <a:solidFill>
-                  <a:srgbClr val="C9D3F5"/>
-                </a:solidFill>
-                <a:latin typeface="Courier New" pitchFamily="34" charset="0"/>
-                <a:ea typeface="Courier New" pitchFamily="34" charset="-122"/>
-                <a:cs typeface="Courier New" pitchFamily="34" charset="-120"/>
-              </a:rPr>
-              <a:t>}</a:t>
-            </a:r>
-            <a:endParaRPr lang="en-US" sz="1250" dirty="0"/>
-          </a:p>
-        </p:txBody>
-      </p:sp>
-      <p:sp>
-        <p:nvSpPr>
-          <p:cNvPr id="6" name="Shape 4"/>
+        </p:txBody>
+      </p:sp>
+      <p:sp>
+        <p:nvSpPr>
+          <p:cNvPr id="7" name="Shape 5"/>
           <p:cNvSpPr/>
           <p:nvPr/>
         </p:nvSpPr>
         <p:spPr>
           <a:xfrm>
-            <a:off x="530352" y="4346067"/>
-            <a:ext cx="11130991" cy="1981581"/>
+            <a:off x="530352" y="4382262"/>
+            <a:ext cx="11130991" cy="1945386"/>
           </a:xfrm>
           <a:prstGeom prst="roundRect">
             <a:avLst>
-              <a:gd name="adj" fmla="val 2769"/>
+              <a:gd name="adj" fmla="val 2820"/>
             </a:avLst>
           </a:prstGeom>
           <a:solidFill>
@@ -17937,7 +18579,7 @@
       </p:sp>
       <p:pic>
         <p:nvPicPr>
-          <p:cNvPr id="7" name="Image 0" descr="D:/GitHub/mern-web-book/docs/assets/img/lecture-05/text-properties.png">    </p:cNvPr>
+          <p:cNvPr id="8" name="Image 0" descr="D:/GitHub/mern-web-book/docs/assets/img/lecture-05/font-properties.png">    </p:cNvPr>
           <p:cNvPicPr>
             <a:picLocks noChangeAspect="1"/>
           </p:cNvPicPr>
@@ -17951,8 +18593,8 @@
         </p:blipFill>
         <p:spPr>
           <a:xfrm>
-            <a:off x="1700435" y="4455795"/>
-            <a:ext cx="8790826" cy="1762125"/>
+            <a:off x="640080" y="5049654"/>
+            <a:ext cx="10911535" cy="610602"/>
           </a:xfrm>
           <a:prstGeom prst="rect">
             <a:avLst/>
@@ -17961,7 +18603,7 @@
       </p:pic>
       <p:sp>
         <p:nvSpPr>
-          <p:cNvPr id="8" name="Text 5"/>
+          <p:cNvPr id="9" name="Text 6"/>
           <p:cNvSpPr txBox="1"/>
           <p:nvPr/>
         </p:nvSpPr>
@@ -18000,7 +18642,7 @@
       </p:sp>
       <p:sp>
         <p:nvSpPr>
-          <p:cNvPr id="9" name="Text 6"/>
+          <p:cNvPr id="10" name="Text 7"/>
           <p:cNvSpPr txBox="1"/>
           <p:nvPr/>
         </p:nvSpPr>
@@ -18102,7 +18744,7 @@
                 <a:ea typeface="Calibri" pitchFamily="34" charset="-122"/>
                 <a:cs typeface="Calibri" pitchFamily="34" charset="-120"/>
               </a:rPr>
-              <a:t>BACKGROUNDS</a:t>
+              <a:t>TEXT</a:t>
             </a:r>
             <a:endParaRPr lang="en-US" sz="1300" dirty="0"/>
           </a:p>
@@ -18141,7 +18783,7 @@
                 <a:ea typeface="Cambria" pitchFamily="34" charset="-122"/>
                 <a:cs typeface="Cambria" pitchFamily="34" charset="-120"/>
               </a:rPr>
-              <a:t>Background Properties</a:t>
+              <a:t>Text Properties</a:t>
             </a:r>
             <a:endParaRPr lang="en-US" sz="3400" dirty="0"/>
           </a:p>
@@ -18156,11 +18798,11 @@
         <p:spPr>
           <a:xfrm>
             <a:off x="640080" y="1965960"/>
-            <a:ext cx="10911535" cy="2415540"/>
+            <a:ext cx="10911535" cy="2215515"/>
           </a:xfrm>
           <a:prstGeom prst="roundRect">
             <a:avLst>
-              <a:gd name="adj" fmla="val 3028"/>
+              <a:gd name="adj" fmla="val 3302"/>
             </a:avLst>
           </a:prstGeom>
           <a:solidFill>
@@ -18178,7 +18820,7 @@
         <p:spPr>
           <a:xfrm>
             <a:off x="960120" y="2194560"/>
-            <a:ext cx="10271455" cy="1958340"/>
+            <a:ext cx="10271455" cy="1758315"/>
           </a:xfrm>
           <a:prstGeom prst="rect">
             <a:avLst/>
@@ -18197,7 +18839,7 @@
               <a:buNone/>
             </a:pPr>
             <a:r>
-              <a:rPr lang="en-US" sz="1400" dirty="0">
+              <a:rPr lang="en-US" sz="1250" dirty="0">
                 <a:solidFill>
                   <a:srgbClr val="C9D3F5"/>
                 </a:solidFill>
@@ -18205,9 +18847,9 @@
                 <a:ea typeface="Courier New" pitchFamily="34" charset="-122"/>
                 <a:cs typeface="Courier New" pitchFamily="34" charset="-120"/>
               </a:rPr>
-              <a:t>.card {</a:t>
-            </a:r>
-            <a:endParaRPr lang="en-US" sz="1400" dirty="0"/>
+              <a:t>p {</a:t>
+            </a:r>
+            <a:endParaRPr lang="en-US" sz="1250" dirty="0"/>
           </a:p>
           <a:p>
             <a:pPr indent="0" marL="0">
@@ -18217,7 +18859,7 @@
               <a:buNone/>
             </a:pPr>
             <a:r>
-              <a:rPr lang="en-US" sz="1400" dirty="0">
+              <a:rPr lang="en-US" sz="1250" dirty="0">
                 <a:solidFill>
                   <a:srgbClr val="C9D3F5"/>
                 </a:solidFill>
@@ -18225,9 +18867,9 @@
                 <a:ea typeface="Courier New" pitchFamily="34" charset="-122"/>
                 <a:cs typeface="Courier New" pitchFamily="34" charset="-120"/>
               </a:rPr>
-              <a:t>  background-color: #f5f5f5;</a:t>
-            </a:r>
-            <a:endParaRPr lang="en-US" sz="1400" dirty="0"/>
+              <a:t>  text-align: center;</a:t>
+            </a:r>
+            <a:endParaRPr lang="en-US" sz="1250" dirty="0"/>
           </a:p>
           <a:p>
             <a:pPr indent="0" marL="0">
@@ -18237,7 +18879,7 @@
               <a:buNone/>
             </a:pPr>
             <a:r>
-              <a:rPr lang="en-US" sz="1400" dirty="0">
+              <a:rPr lang="en-US" sz="1250" dirty="0">
                 <a:solidFill>
                   <a:srgbClr val="C9D3F5"/>
                 </a:solidFill>
@@ -18245,9 +18887,9 @@
                 <a:ea typeface="Courier New" pitchFamily="34" charset="-122"/>
                 <a:cs typeface="Courier New" pitchFamily="34" charset="-120"/>
               </a:rPr>
-              <a:t>  background-image: url("pattern.png");</a:t>
-            </a:r>
-            <a:endParaRPr lang="en-US" sz="1400" dirty="0"/>
+              <a:t>  text-decoration: underline;</a:t>
+            </a:r>
+            <a:endParaRPr lang="en-US" sz="1250" dirty="0"/>
           </a:p>
           <a:p>
             <a:pPr indent="0" marL="0">
@@ -18257,7 +18899,7 @@
               <a:buNone/>
             </a:pPr>
             <a:r>
-              <a:rPr lang="en-US" sz="1400" dirty="0">
+              <a:rPr lang="en-US" sz="1250" dirty="0">
                 <a:solidFill>
                   <a:srgbClr val="C9D3F5"/>
                 </a:solidFill>
@@ -18265,9 +18907,9 @@
                 <a:ea typeface="Courier New" pitchFamily="34" charset="-122"/>
                 <a:cs typeface="Courier New" pitchFamily="34" charset="-120"/>
               </a:rPr>
-              <a:t>  background-repeat: no-repeat;</a:t>
-            </a:r>
-            <a:endParaRPr lang="en-US" sz="1400" dirty="0"/>
+              <a:t>  text-transform: uppercase;</a:t>
+            </a:r>
+            <a:endParaRPr lang="en-US" sz="1250" dirty="0"/>
           </a:p>
           <a:p>
             <a:pPr indent="0" marL="0">
@@ -18277,7 +18919,7 @@
               <a:buNone/>
             </a:pPr>
             <a:r>
-              <a:rPr lang="en-US" sz="1400" dirty="0">
+              <a:rPr lang="en-US" sz="1250" dirty="0">
                 <a:solidFill>
                   <a:srgbClr val="C9D3F5"/>
                 </a:solidFill>
@@ -18285,9 +18927,9 @@
                 <a:ea typeface="Courier New" pitchFamily="34" charset="-122"/>
                 <a:cs typeface="Courier New" pitchFamily="34" charset="-120"/>
               </a:rPr>
-              <a:t>  background-position: center;</a:t>
-            </a:r>
-            <a:endParaRPr lang="en-US" sz="1400" dirty="0"/>
+              <a:t>  line-height: 1.6;</a:t>
+            </a:r>
+            <a:endParaRPr lang="en-US" sz="1250" dirty="0"/>
           </a:p>
           <a:p>
             <a:pPr indent="0" marL="0">
@@ -18297,7 +18939,7 @@
               <a:buNone/>
             </a:pPr>
             <a:r>
-              <a:rPr lang="en-US" sz="1400" dirty="0">
+              <a:rPr lang="en-US" sz="1250" dirty="0">
                 <a:solidFill>
                   <a:srgbClr val="C9D3F5"/>
                 </a:solidFill>
@@ -18305,9 +18947,9 @@
                 <a:ea typeface="Courier New" pitchFamily="34" charset="-122"/>
                 <a:cs typeface="Courier New" pitchFamily="34" charset="-120"/>
               </a:rPr>
-              <a:t>  background-size: cover;</a:t>
-            </a:r>
-            <a:endParaRPr lang="en-US" sz="1400" dirty="0"/>
+              <a:t>  letter-spacing: 0.5px;</a:t>
+            </a:r>
+            <a:endParaRPr lang="en-US" sz="1250" dirty="0"/>
           </a:p>
           <a:p>
             <a:pPr indent="0" marL="0">
@@ -18317,7 +18959,7 @@
               <a:buNone/>
             </a:pPr>
             <a:r>
-              <a:rPr lang="en-US" sz="1400" dirty="0">
+              <a:rPr lang="en-US" sz="1250" dirty="0">
                 <a:solidFill>
                   <a:srgbClr val="C9D3F5"/>
                 </a:solidFill>
@@ -18327,20 +18969,78 @@
               </a:rPr>
               <a:t>}</a:t>
             </a:r>
-            <a:endParaRPr lang="en-US" sz="1400" dirty="0"/>
-          </a:p>
-        </p:txBody>
-      </p:sp>
-      <p:sp>
-        <p:nvSpPr>
-          <p:cNvPr id="6" name="Text 4"/>
+            <a:endParaRPr lang="en-US" sz="1250" dirty="0"/>
+          </a:p>
+        </p:txBody>
+      </p:sp>
+      <p:sp>
+        <p:nvSpPr>
+          <p:cNvPr id="6" name="Shape 4"/>
+          <p:cNvSpPr/>
+          <p:nvPr/>
+        </p:nvSpPr>
+        <p:spPr>
+          <a:xfrm>
+            <a:off x="530352" y="4346067"/>
+            <a:ext cx="11130991" cy="1981581"/>
+          </a:xfrm>
+          <a:prstGeom prst="roundRect">
+            <a:avLst>
+              <a:gd name="adj" fmla="val 2769"/>
+            </a:avLst>
+          </a:prstGeom>
+          <a:solidFill>
+            <a:srgbClr val="FFFFFF"/>
+          </a:solidFill>
+          <a:ln w="12700">
+            <a:solidFill>
+              <a:srgbClr val="E2E2EE"/>
+            </a:solidFill>
+            <a:prstDash val="solid"/>
+          </a:ln>
+          <a:effectLst>
+            <a:outerShdw sx="100000" sy="100000" kx="0" ky="0" algn="bl" rotWithShape="0" blurRad="101600" dist="38100" dir="5400000">
+              <a:srgbClr val="000000">
+                <a:alpha val="12000"/>
+              </a:srgbClr>
+            </a:outerShdw>
+          </a:effectLst>
+        </p:spPr>
+      </p:sp>
+      <p:pic>
+        <p:nvPicPr>
+          <p:cNvPr id="7" name="Image 0" descr="D:/GitHub/mern-web-book/docs/assets/img/lecture-05/text-properties.png">    </p:cNvPr>
+          <p:cNvPicPr>
+            <a:picLocks noChangeAspect="1"/>
+          </p:cNvPicPr>
+          <p:nvPr/>
+        </p:nvPicPr>
+        <p:blipFill>
+          <a:blip r:embed="rId1"/>
+          <a:stretch>
+            <a:fillRect/>
+          </a:stretch>
+        </p:blipFill>
+        <p:spPr>
+          <a:xfrm>
+            <a:off x="1700435" y="4455795"/>
+            <a:ext cx="8790826" cy="1762125"/>
+          </a:xfrm>
+          <a:prstGeom prst="rect">
+            <a:avLst/>
+          </a:prstGeom>
+        </p:spPr>
+      </p:pic>
+      <p:sp>
+        <p:nvSpPr>
+          <p:cNvPr id="8" name="Text 5"/>
           <p:cNvSpPr txBox="1"/>
           <p:nvPr/>
         </p:nvSpPr>
         <p:spPr>
           <a:xfrm>
-            <a:off x="640080" y="4610100"/>
-            <a:ext cx="10911535" cy="1653540"/>
+            <a:off x="640080" y="6446520"/>
+            <a:ext cx="8686800" cy="292608"/>
           </a:xfrm>
           <a:prstGeom prst="rect">
             <a:avLst/>
@@ -18349,60 +19049,21 @@
           <a:ln/>
         </p:spPr>
         <p:txBody>
-          <a:bodyPr wrap="square" lIns="0" tIns="0" rIns="0" bIns="0" rtlCol="0" anchor="t"/>
-          <a:lstStyle/>
-          <a:p>
-            <a:pPr indent="0" marL="0">
-              <a:buNone/>
-            </a:pPr>
-            <a:r>
-              <a:rPr lang="en-US" sz="1300" dirty="0">
-                <a:solidFill>
-                  <a:srgbClr val="26262F"/>
+          <a:bodyPr wrap="square" lIns="0" tIns="0" rIns="0" bIns="0" rtlCol="0" anchor="ctr"/>
+          <a:lstStyle/>
+          <a:p>
+            <a:pPr algn="l" indent="0" marL="0">
+              <a:buNone/>
+            </a:pPr>
+            <a:r>
+              <a:rPr lang="en-US" sz="900" dirty="0">
+                <a:solidFill>
+                  <a:srgbClr val="5D5D72"/>
                 </a:solidFill>
                 <a:latin typeface="Calibri" pitchFamily="34" charset="0"/>
                 <a:ea typeface="Calibri" pitchFamily="34" charset="-122"/>
                 <a:cs typeface="Calibri" pitchFamily="34" charset="-120"/>
               </a:rPr>
-              <a:t>A background shorthand combines several of these into one declaration, just like font does.</a:t>
-            </a:r>
-            <a:endParaRPr lang="en-US" sz="1300" dirty="0"/>
-          </a:p>
-        </p:txBody>
-      </p:sp>
-      <p:sp>
-        <p:nvSpPr>
-          <p:cNvPr id="7" name="Text 5"/>
-          <p:cNvSpPr txBox="1"/>
-          <p:nvPr/>
-        </p:nvSpPr>
-        <p:spPr>
-          <a:xfrm>
-            <a:off x="640080" y="6446520"/>
-            <a:ext cx="8686800" cy="292608"/>
-          </a:xfrm>
-          <a:prstGeom prst="rect">
-            <a:avLst/>
-          </a:prstGeom>
-          <a:noFill/>
-          <a:ln/>
-        </p:spPr>
-        <p:txBody>
-          <a:bodyPr wrap="square" lIns="0" tIns="0" rIns="0" bIns="0" rtlCol="0" anchor="ctr"/>
-          <a:lstStyle/>
-          <a:p>
-            <a:pPr algn="l" indent="0" marL="0">
-              <a:buNone/>
-            </a:pPr>
-            <a:r>
-              <a:rPr lang="en-US" sz="900" dirty="0">
-                <a:solidFill>
-                  <a:srgbClr val="5D5D72"/>
-                </a:solidFill>
-                <a:latin typeface="Calibri" pitchFamily="34" charset="0"/>
-                <a:ea typeface="Calibri" pitchFamily="34" charset="-122"/>
-                <a:cs typeface="Calibri" pitchFamily="34" charset="-120"/>
-              </a:rPr>
               <a:t>Usman Akram  •  COMSATS University Islamabad</a:t>
             </a:r>
             <a:endParaRPr lang="en-US" sz="900" dirty="0"/>
@@ -18411,7 +19072,7 @@
       </p:sp>
       <p:sp>
         <p:nvSpPr>
-          <p:cNvPr id="8" name="Text 6"/>
+          <p:cNvPr id="9" name="Text 6"/>
           <p:cNvSpPr txBox="1"/>
           <p:nvPr/>
         </p:nvSpPr>
@@ -18459,6 +19120,417 @@
 <file path=ppt/slides/slide33.xml><?xml version="1.0" encoding="utf-8"?>
 <p:sld xmlns:a="http://schemas.openxmlformats.org/drawingml/2006/main" xmlns:r="http://schemas.openxmlformats.org/officeDocument/2006/relationships" xmlns:p="http://schemas.openxmlformats.org/presentationml/2006/main">
   <p:cSld name="Slide 33">
+    <p:bg>
+      <p:bgPr>
+        <a:solidFill>
+          <a:srgbClr val="FFFFFF"/>
+        </a:solidFill>
+      </p:bgPr>
+    </p:bg>
+    <p:spTree>
+      <p:nvGrpSpPr>
+        <p:cNvPr id="1" name=""/>
+        <p:cNvGrpSpPr/>
+        <p:nvPr/>
+      </p:nvGrpSpPr>
+      <p:grpSpPr>
+        <a:xfrm>
+          <a:off x="0" y="0"/>
+          <a:ext cx="0" cy="0"/>
+          <a:chOff x="0" y="0"/>
+          <a:chExt cx="0" cy="0"/>
+        </a:xfrm>
+      </p:grpSpPr>
+      <p:sp>
+        <p:nvSpPr>
+          <p:cNvPr id="2" name="Text 0"/>
+          <p:cNvSpPr txBox="1"/>
+          <p:nvPr/>
+        </p:nvSpPr>
+        <p:spPr>
+          <a:xfrm>
+            <a:off x="640080" y="457200"/>
+            <a:ext cx="10058400" cy="365760"/>
+          </a:xfrm>
+          <a:prstGeom prst="rect">
+            <a:avLst/>
+          </a:prstGeom>
+          <a:noFill/>
+          <a:ln/>
+        </p:spPr>
+        <p:txBody>
+          <a:bodyPr wrap="square" lIns="0" tIns="0" rIns="0" bIns="0" rtlCol="0" anchor="ctr"/>
+          <a:lstStyle/>
+          <a:p>
+            <a:pPr algn="l" indent="0" marL="0">
+              <a:buNone/>
+            </a:pPr>
+            <a:r>
+              <a:rPr lang="en-US" sz="1300" b="1" spc="300" kern="0" dirty="0">
+                <a:solidFill>
+                  <a:srgbClr val="FF8A3D"/>
+                </a:solidFill>
+                <a:latin typeface="Calibri" pitchFamily="34" charset="0"/>
+                <a:ea typeface="Calibri" pitchFamily="34" charset="-122"/>
+                <a:cs typeface="Calibri" pitchFamily="34" charset="-120"/>
+              </a:rPr>
+              <a:t>BACKGROUNDS</a:t>
+            </a:r>
+            <a:endParaRPr lang="en-US" sz="1300" dirty="0"/>
+          </a:p>
+        </p:txBody>
+      </p:sp>
+      <p:sp>
+        <p:nvSpPr>
+          <p:cNvPr id="3" name="Text 1"/>
+          <p:cNvSpPr txBox="1"/>
+          <p:nvPr/>
+        </p:nvSpPr>
+        <p:spPr>
+          <a:xfrm>
+            <a:off x="640080" y="841248"/>
+            <a:ext cx="10881360" cy="914400"/>
+          </a:xfrm>
+          <a:prstGeom prst="rect">
+            <a:avLst/>
+          </a:prstGeom>
+          <a:noFill/>
+          <a:ln/>
+        </p:spPr>
+        <p:txBody>
+          <a:bodyPr wrap="square" lIns="0" tIns="0" rIns="0" bIns="0" rtlCol="0" anchor="ctr"/>
+          <a:lstStyle/>
+          <a:p>
+            <a:pPr algn="l" indent="0" marL="0">
+              <a:buNone/>
+            </a:pPr>
+            <a:r>
+              <a:rPr lang="en-US" sz="3400" b="1" dirty="0">
+                <a:solidFill>
+                  <a:srgbClr val="2B2B7A"/>
+                </a:solidFill>
+                <a:latin typeface="Cambria" pitchFamily="34" charset="0"/>
+                <a:ea typeface="Cambria" pitchFamily="34" charset="-122"/>
+                <a:cs typeface="Cambria" pitchFamily="34" charset="-120"/>
+              </a:rPr>
+              <a:t>Background Properties</a:t>
+            </a:r>
+            <a:endParaRPr lang="en-US" sz="3400" dirty="0"/>
+          </a:p>
+        </p:txBody>
+      </p:sp>
+      <p:sp>
+        <p:nvSpPr>
+          <p:cNvPr id="4" name="Shape 2"/>
+          <p:cNvSpPr/>
+          <p:nvPr/>
+        </p:nvSpPr>
+        <p:spPr>
+          <a:xfrm>
+            <a:off x="640080" y="1965960"/>
+            <a:ext cx="10911535" cy="2415540"/>
+          </a:xfrm>
+          <a:prstGeom prst="roundRect">
+            <a:avLst>
+              <a:gd name="adj" fmla="val 3028"/>
+            </a:avLst>
+          </a:prstGeom>
+          <a:solidFill>
+            <a:srgbClr val="1E1E4C"/>
+          </a:solidFill>
+          <a:ln/>
+        </p:spPr>
+      </p:sp>
+      <p:sp>
+        <p:nvSpPr>
+          <p:cNvPr id="5" name="Text 3"/>
+          <p:cNvSpPr txBox="1"/>
+          <p:nvPr/>
+        </p:nvSpPr>
+        <p:spPr>
+          <a:xfrm>
+            <a:off x="960120" y="2194560"/>
+            <a:ext cx="10271455" cy="1958340"/>
+          </a:xfrm>
+          <a:prstGeom prst="rect">
+            <a:avLst/>
+          </a:prstGeom>
+          <a:noFill/>
+          <a:ln/>
+        </p:spPr>
+        <p:txBody>
+          <a:bodyPr wrap="square" lIns="0" tIns="0" rIns="0" bIns="0" rtlCol="0" anchor="t"/>
+          <a:lstStyle/>
+          <a:p>
+            <a:pPr indent="0" marL="0">
+              <a:lnSpc>
+                <a:spcPct val="125000"/>
+              </a:lnSpc>
+              <a:buNone/>
+            </a:pPr>
+            <a:r>
+              <a:rPr lang="en-US" sz="1400" dirty="0">
+                <a:solidFill>
+                  <a:srgbClr val="C9D3F5"/>
+                </a:solidFill>
+                <a:latin typeface="Courier New" pitchFamily="34" charset="0"/>
+                <a:ea typeface="Courier New" pitchFamily="34" charset="-122"/>
+                <a:cs typeface="Courier New" pitchFamily="34" charset="-120"/>
+              </a:rPr>
+              <a:t>.card {</a:t>
+            </a:r>
+            <a:endParaRPr lang="en-US" sz="1400" dirty="0"/>
+          </a:p>
+          <a:p>
+            <a:pPr indent="0" marL="0">
+              <a:lnSpc>
+                <a:spcPct val="125000"/>
+              </a:lnSpc>
+              <a:buNone/>
+            </a:pPr>
+            <a:r>
+              <a:rPr lang="en-US" sz="1400" dirty="0">
+                <a:solidFill>
+                  <a:srgbClr val="C9D3F5"/>
+                </a:solidFill>
+                <a:latin typeface="Courier New" pitchFamily="34" charset="0"/>
+                <a:ea typeface="Courier New" pitchFamily="34" charset="-122"/>
+                <a:cs typeface="Courier New" pitchFamily="34" charset="-120"/>
+              </a:rPr>
+              <a:t>  background-color: #f5f5f5;</a:t>
+            </a:r>
+            <a:endParaRPr lang="en-US" sz="1400" dirty="0"/>
+          </a:p>
+          <a:p>
+            <a:pPr indent="0" marL="0">
+              <a:lnSpc>
+                <a:spcPct val="125000"/>
+              </a:lnSpc>
+              <a:buNone/>
+            </a:pPr>
+            <a:r>
+              <a:rPr lang="en-US" sz="1400" dirty="0">
+                <a:solidFill>
+                  <a:srgbClr val="C9D3F5"/>
+                </a:solidFill>
+                <a:latin typeface="Courier New" pitchFamily="34" charset="0"/>
+                <a:ea typeface="Courier New" pitchFamily="34" charset="-122"/>
+                <a:cs typeface="Courier New" pitchFamily="34" charset="-120"/>
+              </a:rPr>
+              <a:t>  background-image: url("pattern.png");</a:t>
+            </a:r>
+            <a:endParaRPr lang="en-US" sz="1400" dirty="0"/>
+          </a:p>
+          <a:p>
+            <a:pPr indent="0" marL="0">
+              <a:lnSpc>
+                <a:spcPct val="125000"/>
+              </a:lnSpc>
+              <a:buNone/>
+            </a:pPr>
+            <a:r>
+              <a:rPr lang="en-US" sz="1400" dirty="0">
+                <a:solidFill>
+                  <a:srgbClr val="C9D3F5"/>
+                </a:solidFill>
+                <a:latin typeface="Courier New" pitchFamily="34" charset="0"/>
+                <a:ea typeface="Courier New" pitchFamily="34" charset="-122"/>
+                <a:cs typeface="Courier New" pitchFamily="34" charset="-120"/>
+              </a:rPr>
+              <a:t>  background-repeat: no-repeat;</a:t>
+            </a:r>
+            <a:endParaRPr lang="en-US" sz="1400" dirty="0"/>
+          </a:p>
+          <a:p>
+            <a:pPr indent="0" marL="0">
+              <a:lnSpc>
+                <a:spcPct val="125000"/>
+              </a:lnSpc>
+              <a:buNone/>
+            </a:pPr>
+            <a:r>
+              <a:rPr lang="en-US" sz="1400" dirty="0">
+                <a:solidFill>
+                  <a:srgbClr val="C9D3F5"/>
+                </a:solidFill>
+                <a:latin typeface="Courier New" pitchFamily="34" charset="0"/>
+                <a:ea typeface="Courier New" pitchFamily="34" charset="-122"/>
+                <a:cs typeface="Courier New" pitchFamily="34" charset="-120"/>
+              </a:rPr>
+              <a:t>  background-position: center;</a:t>
+            </a:r>
+            <a:endParaRPr lang="en-US" sz="1400" dirty="0"/>
+          </a:p>
+          <a:p>
+            <a:pPr indent="0" marL="0">
+              <a:lnSpc>
+                <a:spcPct val="125000"/>
+              </a:lnSpc>
+              <a:buNone/>
+            </a:pPr>
+            <a:r>
+              <a:rPr lang="en-US" sz="1400" dirty="0">
+                <a:solidFill>
+                  <a:srgbClr val="C9D3F5"/>
+                </a:solidFill>
+                <a:latin typeface="Courier New" pitchFamily="34" charset="0"/>
+                <a:ea typeface="Courier New" pitchFamily="34" charset="-122"/>
+                <a:cs typeface="Courier New" pitchFamily="34" charset="-120"/>
+              </a:rPr>
+              <a:t>  background-size: cover;</a:t>
+            </a:r>
+            <a:endParaRPr lang="en-US" sz="1400" dirty="0"/>
+          </a:p>
+          <a:p>
+            <a:pPr indent="0" marL="0">
+              <a:lnSpc>
+                <a:spcPct val="125000"/>
+              </a:lnSpc>
+              <a:buNone/>
+            </a:pPr>
+            <a:r>
+              <a:rPr lang="en-US" sz="1400" dirty="0">
+                <a:solidFill>
+                  <a:srgbClr val="C9D3F5"/>
+                </a:solidFill>
+                <a:latin typeface="Courier New" pitchFamily="34" charset="0"/>
+                <a:ea typeface="Courier New" pitchFamily="34" charset="-122"/>
+                <a:cs typeface="Courier New" pitchFamily="34" charset="-120"/>
+              </a:rPr>
+              <a:t>}</a:t>
+            </a:r>
+            <a:endParaRPr lang="en-US" sz="1400" dirty="0"/>
+          </a:p>
+        </p:txBody>
+      </p:sp>
+      <p:sp>
+        <p:nvSpPr>
+          <p:cNvPr id="6" name="Text 4"/>
+          <p:cNvSpPr txBox="1"/>
+          <p:nvPr/>
+        </p:nvSpPr>
+        <p:spPr>
+          <a:xfrm>
+            <a:off x="640080" y="4610100"/>
+            <a:ext cx="10911535" cy="1653540"/>
+          </a:xfrm>
+          <a:prstGeom prst="rect">
+            <a:avLst/>
+          </a:prstGeom>
+          <a:noFill/>
+          <a:ln/>
+        </p:spPr>
+        <p:txBody>
+          <a:bodyPr wrap="square" lIns="0" tIns="0" rIns="0" bIns="0" rtlCol="0" anchor="t"/>
+          <a:lstStyle/>
+          <a:p>
+            <a:pPr indent="0" marL="0">
+              <a:buNone/>
+            </a:pPr>
+            <a:r>
+              <a:rPr lang="en-US" sz="1300" dirty="0">
+                <a:solidFill>
+                  <a:srgbClr val="26262F"/>
+                </a:solidFill>
+                <a:latin typeface="Calibri" pitchFamily="34" charset="0"/>
+                <a:ea typeface="Calibri" pitchFamily="34" charset="-122"/>
+                <a:cs typeface="Calibri" pitchFamily="34" charset="-120"/>
+              </a:rPr>
+              <a:t>A background shorthand combines several of these into one declaration, just like font does.</a:t>
+            </a:r>
+            <a:endParaRPr lang="en-US" sz="1300" dirty="0"/>
+          </a:p>
+        </p:txBody>
+      </p:sp>
+      <p:sp>
+        <p:nvSpPr>
+          <p:cNvPr id="7" name="Text 5"/>
+          <p:cNvSpPr txBox="1"/>
+          <p:nvPr/>
+        </p:nvSpPr>
+        <p:spPr>
+          <a:xfrm>
+            <a:off x="640080" y="6446520"/>
+            <a:ext cx="8686800" cy="292608"/>
+          </a:xfrm>
+          <a:prstGeom prst="rect">
+            <a:avLst/>
+          </a:prstGeom>
+          <a:noFill/>
+          <a:ln/>
+        </p:spPr>
+        <p:txBody>
+          <a:bodyPr wrap="square" lIns="0" tIns="0" rIns="0" bIns="0" rtlCol="0" anchor="ctr"/>
+          <a:lstStyle/>
+          <a:p>
+            <a:pPr algn="l" indent="0" marL="0">
+              <a:buNone/>
+            </a:pPr>
+            <a:r>
+              <a:rPr lang="en-US" sz="900" dirty="0">
+                <a:solidFill>
+                  <a:srgbClr val="5D5D72"/>
+                </a:solidFill>
+                <a:latin typeface="Calibri" pitchFamily="34" charset="0"/>
+                <a:ea typeface="Calibri" pitchFamily="34" charset="-122"/>
+                <a:cs typeface="Calibri" pitchFamily="34" charset="-120"/>
+              </a:rPr>
+              <a:t>Usman Akram  •  COMSATS University Islamabad</a:t>
+            </a:r>
+            <a:endParaRPr lang="en-US" sz="900" dirty="0"/>
+          </a:p>
+        </p:txBody>
+      </p:sp>
+      <p:sp>
+        <p:nvSpPr>
+          <p:cNvPr id="8" name="Text 6"/>
+          <p:cNvSpPr txBox="1"/>
+          <p:nvPr/>
+        </p:nvSpPr>
+        <p:spPr>
+          <a:xfrm>
+            <a:off x="11155680" y="6446520"/>
+            <a:ext cx="457200" cy="292608"/>
+          </a:xfrm>
+          <a:prstGeom prst="rect">
+            <a:avLst/>
+          </a:prstGeom>
+          <a:noFill/>
+          <a:ln/>
+        </p:spPr>
+        <p:txBody>
+          <a:bodyPr wrap="square" lIns="0" tIns="0" rIns="0" bIns="0" rtlCol="0" anchor="ctr"/>
+          <a:lstStyle/>
+          <a:p>
+            <a:pPr algn="r" indent="0" marL="0">
+              <a:buNone/>
+            </a:pPr>
+            <a:r>
+              <a:rPr lang="en-US" sz="900" dirty="0">
+                <a:solidFill>
+                  <a:srgbClr val="5D5D72"/>
+                </a:solidFill>
+                <a:latin typeface="Calibri" pitchFamily="34" charset="0"/>
+                <a:ea typeface="Calibri" pitchFamily="34" charset="-122"/>
+                <a:cs typeface="Calibri" pitchFamily="34" charset="-120"/>
+              </a:rPr>
+              <a:t>33</a:t>
+            </a:r>
+            <a:endParaRPr lang="en-US" sz="900" dirty="0"/>
+          </a:p>
+        </p:txBody>
+      </p:sp>
+    </p:spTree>
+  </p:cSld>
+  <p:clrMapOvr>
+    <a:masterClrMapping/>
+  </p:clrMapOvr>
+</p:sld>
+</file>
+
+<file path=ppt/slides/slide34.xml><?xml version="1.0" encoding="utf-8"?>
+<p:sld xmlns:a="http://schemas.openxmlformats.org/drawingml/2006/main" xmlns:r="http://schemas.openxmlformats.org/officeDocument/2006/relationships" xmlns:p="http://schemas.openxmlformats.org/presentationml/2006/main">
+  <p:cSld name="Slide 34">
     <p:bg>
       <p:bgPr>
         <a:solidFill>
@@ -19218,7 +20290,7 @@
                 <a:ea typeface="Calibri" pitchFamily="34" charset="-122"/>
                 <a:cs typeface="Calibri" pitchFamily="34" charset="-120"/>
               </a:rPr>
-              <a:t>33</a:t>
+              <a:t>34</a:t>
             </a:r>
             <a:endParaRPr lang="en-US" sz="900" dirty="0"/>
           </a:p>

</xml_diff>